<commit_message>
Fix PowerPoint layout - adjusted margins, box sizes, and text overflow
</commit_message>
<xml_diff>
--- a/RBI_Term_Money_Market_HeroFinCorp_Analysis.pptx
+++ b/RBI_Term_Money_Market_HeroFinCorp_Analysis.pptx
@@ -884,7 +884,7 @@
         <p:spPr>
           <a:xfrm>
             <a:off x="0" y="0"/>
-            <a:ext cx="9144000" cy="731520"/>
+            <a:ext cx="9144000" cy="594360"/>
           </a:xfrm>
           <a:prstGeom prst="rect">
             <a:avLst/>
@@ -903,8 +903,8 @@
         </p:nvSpPr>
         <p:spPr>
           <a:xfrm>
-            <a:off x="274320" y="137160"/>
-            <a:ext cx="5486400" cy="457200"/>
+            <a:off x="365760" y="109728"/>
+            <a:ext cx="7315200" cy="320040"/>
           </a:xfrm>
           <a:prstGeom prst="rect">
             <a:avLst/>
@@ -920,7 +920,7 @@
               <a:buNone/>
             </a:pPr>
             <a:r>
-              <a:rPr lang="en-US" sz="2400" b="1" dirty="0">
+              <a:rPr lang="en-US" sz="2000" b="1" dirty="0">
                 <a:solidFill>
                   <a:srgbClr val="FFFFFF"/>
                 </a:solidFill>
@@ -930,7 +930,7 @@
               </a:rPr>
               <a:t>🏛️ RBI Term Money Market Expansion</a:t>
             </a:r>
-            <a:endParaRPr lang="en-US" sz="2400" dirty="0"/>
+            <a:endParaRPr lang="en-US" sz="2000" dirty="0"/>
           </a:p>
         </p:txBody>
       </p:sp>
@@ -942,8 +942,8 @@
         </p:nvSpPr>
         <p:spPr>
           <a:xfrm>
-            <a:off x="274320" y="411480"/>
-            <a:ext cx="5486400" cy="274320"/>
+            <a:off x="365760" y="347472"/>
+            <a:ext cx="5486400" cy="182880"/>
           </a:xfrm>
           <a:prstGeom prst="rect">
             <a:avLst/>
@@ -959,7 +959,7 @@
               <a:buNone/>
             </a:pPr>
             <a:r>
-              <a:rPr lang="en-US" sz="1200" dirty="0">
+              <a:rPr lang="en-US" sz="1000" dirty="0">
                 <a:solidFill>
                   <a:srgbClr val="CADCFC"/>
                 </a:solidFill>
@@ -969,7 +969,7 @@
               </a:rPr>
               <a:t>Strategic Impact Analysis for Hero FinCorp | April 9, 2026</a:t>
             </a:r>
-            <a:endParaRPr lang="en-US" sz="1200" dirty="0"/>
+            <a:endParaRPr lang="en-US" sz="1000" dirty="0"/>
           </a:p>
         </p:txBody>
       </p:sp>
@@ -981,8 +981,8 @@
         </p:nvSpPr>
         <p:spPr>
           <a:xfrm>
-            <a:off x="6858000" y="137160"/>
-            <a:ext cx="2286000" cy="548640"/>
+            <a:off x="7772400" y="182880"/>
+            <a:ext cx="1645920" cy="274320"/>
           </a:xfrm>
           <a:prstGeom prst="rect">
             <a:avLst/>
@@ -998,7 +998,7 @@
               <a:buNone/>
             </a:pPr>
             <a:r>
-              <a:rPr lang="en-US" sz="1100" dirty="0">
+              <a:rPr lang="en-US" sz="1000" dirty="0">
                 <a:solidFill>
                   <a:srgbClr val="FFFFFF"/>
                 </a:solidFill>
@@ -1006,9 +1006,9 @@
                 <a:ea typeface="Arial" pitchFamily="34" charset="-122"/>
                 <a:cs typeface="Arial" pitchFamily="34" charset="-120"/>
               </a:rPr>
-              <a:t>NBFC-ML Treasury Strategy</a:t>
-            </a:r>
-            <a:endParaRPr lang="en-US" sz="1100" dirty="0"/>
+              <a:t>NBFC-ML Treasury</a:t>
+            </a:r>
+            <a:endParaRPr lang="en-US" sz="1000" dirty="0"/>
           </a:p>
         </p:txBody>
       </p:sp>
@@ -1020,18 +1020,18 @@
         </p:nvSpPr>
         <p:spPr>
           <a:xfrm>
-            <a:off x="274320" y="868680"/>
-            <a:ext cx="2148840" cy="640080"/>
+            <a:off x="365760" y="713232"/>
+            <a:ext cx="2148840" cy="548640"/>
           </a:xfrm>
           <a:prstGeom prst="roundRect">
             <a:avLst>
-              <a:gd name="adj" fmla="val 7143"/>
+              <a:gd name="adj" fmla="val 6667"/>
             </a:avLst>
           </a:prstGeom>
           <a:solidFill>
             <a:srgbClr val="FFFFFF"/>
           </a:solidFill>
-          <a:ln w="25400">
+          <a:ln w="19050">
             <a:solidFill>
               <a:srgbClr val="1E2761"/>
             </a:solidFill>
@@ -1047,8 +1047,8 @@
         </p:nvSpPr>
         <p:spPr>
           <a:xfrm>
-            <a:off x="365760" y="941832"/>
-            <a:ext cx="1965960" cy="320040"/>
+            <a:off x="457200" y="768096"/>
+            <a:ext cx="1965960" cy="256032"/>
           </a:xfrm>
           <a:prstGeom prst="rect">
             <a:avLst/>
@@ -1064,7 +1064,7 @@
               <a:buNone/>
             </a:pPr>
             <a:r>
-              <a:rPr lang="en-US" sz="2200" b="1" dirty="0">
+              <a:rPr lang="en-US" sz="1800" b="1" dirty="0">
                 <a:solidFill>
                   <a:srgbClr val="1E2761"/>
                 </a:solidFill>
@@ -1074,7 +1074,7 @@
               </a:rPr>
               <a:t>15-40 bps</a:t>
             </a:r>
-            <a:endParaRPr lang="en-US" sz="2200" dirty="0"/>
+            <a:endParaRPr lang="en-US" sz="1800" dirty="0"/>
           </a:p>
         </p:txBody>
       </p:sp>
@@ -1086,8 +1086,8 @@
         </p:nvSpPr>
         <p:spPr>
           <a:xfrm>
-            <a:off x="365760" y="1234440"/>
-            <a:ext cx="1965960" cy="182880"/>
+            <a:off x="457200" y="1005840"/>
+            <a:ext cx="1965960" cy="201168"/>
           </a:xfrm>
           <a:prstGeom prst="rect">
             <a:avLst/>
@@ -1103,7 +1103,7 @@
               <a:buNone/>
             </a:pPr>
             <a:r>
-              <a:rPr lang="en-US" sz="900" dirty="0">
+              <a:rPr lang="en-US" sz="800" dirty="0">
                 <a:solidFill>
                   <a:srgbClr val="4B5563"/>
                 </a:solidFill>
@@ -1113,7 +1113,7 @@
               </a:rPr>
               <a:t>💰 Cost Savings vs Bank Credit</a:t>
             </a:r>
-            <a:endParaRPr lang="en-US" sz="900" dirty="0"/>
+            <a:endParaRPr lang="en-US" sz="800" dirty="0"/>
           </a:p>
         </p:txBody>
       </p:sp>
@@ -1125,18 +1125,18 @@
         </p:nvSpPr>
         <p:spPr>
           <a:xfrm>
-            <a:off x="2560320" y="868680"/>
-            <a:ext cx="2148840" cy="640080"/>
+            <a:off x="2633472" y="713232"/>
+            <a:ext cx="2148840" cy="548640"/>
           </a:xfrm>
           <a:prstGeom prst="roundRect">
             <a:avLst>
-              <a:gd name="adj" fmla="val 7143"/>
+              <a:gd name="adj" fmla="val 6667"/>
             </a:avLst>
           </a:prstGeom>
           <a:solidFill>
             <a:srgbClr val="FFFFFF"/>
           </a:solidFill>
-          <a:ln w="25400">
+          <a:ln w="19050">
             <a:solidFill>
               <a:srgbClr val="10B981"/>
             </a:solidFill>
@@ -1152,8 +1152,8 @@
         </p:nvSpPr>
         <p:spPr>
           <a:xfrm>
-            <a:off x="2651760" y="941832"/>
-            <a:ext cx="1965960" cy="320040"/>
+            <a:off x="2724912" y="768096"/>
+            <a:ext cx="1965960" cy="256032"/>
           </a:xfrm>
           <a:prstGeom prst="rect">
             <a:avLst/>
@@ -1169,7 +1169,7 @@
               <a:buNone/>
             </a:pPr>
             <a:r>
-              <a:rPr lang="en-US" sz="2200" b="1" dirty="0">
+              <a:rPr lang="en-US" sz="1800" b="1" dirty="0">
                 <a:solidFill>
                   <a:srgbClr val="10B981"/>
                 </a:solidFill>
@@ -1179,7 +1179,7 @@
               </a:rPr>
               <a:t>₹3-12 Cr</a:t>
             </a:r>
-            <a:endParaRPr lang="en-US" sz="2200" dirty="0"/>
+            <a:endParaRPr lang="en-US" sz="1800" dirty="0"/>
           </a:p>
         </p:txBody>
       </p:sp>
@@ -1191,8 +1191,8 @@
         </p:nvSpPr>
         <p:spPr>
           <a:xfrm>
-            <a:off x="2651760" y="1234440"/>
-            <a:ext cx="1965960" cy="182880"/>
+            <a:off x="2724912" y="1005840"/>
+            <a:ext cx="1965960" cy="201168"/>
           </a:xfrm>
           <a:prstGeom prst="rect">
             <a:avLst/>
@@ -1208,7 +1208,7 @@
               <a:buNone/>
             </a:pPr>
             <a:r>
-              <a:rPr lang="en-US" sz="900" dirty="0">
+              <a:rPr lang="en-US" sz="800" dirty="0">
                 <a:solidFill>
                   <a:srgbClr val="4B5563"/>
                 </a:solidFill>
@@ -1216,9 +1216,9 @@
                 <a:ea typeface="Arial" pitchFamily="34" charset="-122"/>
                 <a:cs typeface="Arial" pitchFamily="34" charset="-120"/>
               </a:rPr>
-              <a:t>📈 Annual Interest Savings (Est.)</a:t>
-            </a:r>
-            <a:endParaRPr lang="en-US" sz="900" dirty="0"/>
+              <a:t>📈 Annual Interest Savings</a:t>
+            </a:r>
+            <a:endParaRPr lang="en-US" sz="800" dirty="0"/>
           </a:p>
         </p:txBody>
       </p:sp>
@@ -1230,20 +1230,20 @@
         </p:nvSpPr>
         <p:spPr>
           <a:xfrm>
-            <a:off x="4846320" y="868680"/>
-            <a:ext cx="2148840" cy="640080"/>
+            <a:off x="4901184" y="713232"/>
+            <a:ext cx="2148840" cy="548640"/>
           </a:xfrm>
           <a:prstGeom prst="roundRect">
             <a:avLst>
-              <a:gd name="adj" fmla="val 7143"/>
+              <a:gd name="adj" fmla="val 6667"/>
             </a:avLst>
           </a:prstGeom>
           <a:solidFill>
             <a:srgbClr val="FFFFFF"/>
           </a:solidFill>
-          <a:ln w="25400">
+          <a:ln w="19050">
             <a:solidFill>
-              <a:srgbClr val="F59E0B"/>
+              <a:srgbClr val="D97706"/>
             </a:solidFill>
             <a:prstDash val="solid"/>
           </a:ln>
@@ -1257,8 +1257,8 @@
         </p:nvSpPr>
         <p:spPr>
           <a:xfrm>
-            <a:off x="4937760" y="941832"/>
-            <a:ext cx="1965960" cy="320040"/>
+            <a:off x="4992624" y="768096"/>
+            <a:ext cx="1965960" cy="256032"/>
           </a:xfrm>
           <a:prstGeom prst="rect">
             <a:avLst/>
@@ -1274,9 +1274,9 @@
               <a:buNone/>
             </a:pPr>
             <a:r>
-              <a:rPr lang="en-US" sz="2200" b="1" dirty="0">
-                <a:solidFill>
-                  <a:srgbClr val="F59E0B"/>
+              <a:rPr lang="en-US" sz="1800" b="1" dirty="0">
+                <a:solidFill>
+                  <a:srgbClr val="D97706"/>
                 </a:solidFill>
                 <a:latin typeface="Arial" pitchFamily="34" charset="0"/>
                 <a:ea typeface="Arial" pitchFamily="34" charset="-122"/>
@@ -1284,7 +1284,7 @@
               </a:rPr>
               <a:t>Direct</a:t>
             </a:r>
-            <a:endParaRPr lang="en-US" sz="2200" dirty="0"/>
+            <a:endParaRPr lang="en-US" sz="1800" dirty="0"/>
           </a:p>
         </p:txBody>
       </p:sp>
@@ -1296,8 +1296,8 @@
         </p:nvSpPr>
         <p:spPr>
           <a:xfrm>
-            <a:off x="4937760" y="1234440"/>
-            <a:ext cx="1965960" cy="182880"/>
+            <a:off x="4992624" y="1005840"/>
+            <a:ext cx="1965960" cy="201168"/>
           </a:xfrm>
           <a:prstGeom prst="rect">
             <a:avLst/>
@@ -1313,7 +1313,7 @@
               <a:buNone/>
             </a:pPr>
             <a:r>
-              <a:rPr lang="en-US" sz="900" dirty="0">
+              <a:rPr lang="en-US" sz="800" dirty="0">
                 <a:solidFill>
                   <a:srgbClr val="4B5563"/>
                 </a:solidFill>
@@ -1321,9 +1321,9 @@
                 <a:ea typeface="Arial" pitchFamily="34" charset="-122"/>
                 <a:cs typeface="Arial" pitchFamily="34" charset="-120"/>
               </a:rPr>
-              <a:t>🔓 No Bank Intermediary Required</a:t>
-            </a:r>
-            <a:endParaRPr lang="en-US" sz="900" dirty="0"/>
+              <a:t>🔓 No Bank Intermediary</a:t>
+            </a:r>
+            <a:endParaRPr lang="en-US" sz="800" dirty="0"/>
           </a:p>
         </p:txBody>
       </p:sp>
@@ -1335,18 +1335,18 @@
         </p:nvSpPr>
         <p:spPr>
           <a:xfrm>
-            <a:off x="7132320" y="868680"/>
-            <a:ext cx="2148840" cy="640080"/>
+            <a:off x="7168896" y="713232"/>
+            <a:ext cx="2148840" cy="548640"/>
           </a:xfrm>
           <a:prstGeom prst="roundRect">
             <a:avLst>
-              <a:gd name="adj" fmla="val 7143"/>
+              <a:gd name="adj" fmla="val 6667"/>
             </a:avLst>
           </a:prstGeom>
           <a:solidFill>
             <a:srgbClr val="FFFFFF"/>
           </a:solidFill>
-          <a:ln w="25400">
+          <a:ln w="19050">
             <a:solidFill>
               <a:srgbClr val="1E2761"/>
             </a:solidFill>
@@ -1362,8 +1362,8 @@
         </p:nvSpPr>
         <p:spPr>
           <a:xfrm>
-            <a:off x="7223760" y="941832"/>
-            <a:ext cx="1965960" cy="320040"/>
+            <a:off x="7260336" y="768096"/>
+            <a:ext cx="1965960" cy="256032"/>
           </a:xfrm>
           <a:prstGeom prst="rect">
             <a:avLst/>
@@ -1379,7 +1379,7 @@
               <a:buNone/>
             </a:pPr>
             <a:r>
-              <a:rPr lang="en-US" sz="2200" b="1" dirty="0">
+              <a:rPr lang="en-US" sz="1800" b="1" dirty="0">
                 <a:solidFill>
                   <a:srgbClr val="1E2761"/>
                 </a:solidFill>
@@ -1389,7 +1389,7 @@
               </a:rPr>
               <a:t>10-15%</a:t>
             </a:r>
-            <a:endParaRPr lang="en-US" sz="2200" dirty="0"/>
+            <a:endParaRPr lang="en-US" sz="1800" dirty="0"/>
           </a:p>
         </p:txBody>
       </p:sp>
@@ -1401,8 +1401,8 @@
         </p:nvSpPr>
         <p:spPr>
           <a:xfrm>
-            <a:off x="7223760" y="1234440"/>
-            <a:ext cx="1965960" cy="182880"/>
+            <a:off x="7260336" y="1005840"/>
+            <a:ext cx="1965960" cy="201168"/>
           </a:xfrm>
           <a:prstGeom prst="rect">
             <a:avLst/>
@@ -1418,7 +1418,7 @@
               <a:buNone/>
             </a:pPr>
             <a:r>
-              <a:rPr lang="en-US" sz="900" dirty="0">
+              <a:rPr lang="en-US" sz="800" dirty="0">
                 <a:solidFill>
                   <a:srgbClr val="4B5563"/>
                 </a:solidFill>
@@ -1426,9 +1426,9 @@
                 <a:ea typeface="Arial" pitchFamily="34" charset="-122"/>
                 <a:cs typeface="Arial" pitchFamily="34" charset="-120"/>
               </a:rPr>
-              <a:t>🎯 Target Short-Term Funding Mix</a:t>
-            </a:r>
-            <a:endParaRPr lang="en-US" sz="900" dirty="0"/>
+              <a:t>🎯 Target Funding Mix</a:t>
+            </a:r>
+            <a:endParaRPr lang="en-US" sz="800" dirty="0"/>
           </a:p>
         </p:txBody>
       </p:sp>
@@ -1440,20 +1440,20 @@
         </p:nvSpPr>
         <p:spPr>
           <a:xfrm>
-            <a:off x="274320" y="1691640"/>
-            <a:ext cx="4480560" cy="1463040"/>
+            <a:off x="365760" y="1353312"/>
+            <a:ext cx="4434840" cy="1371600"/>
           </a:xfrm>
           <a:prstGeom prst="roundRect">
             <a:avLst>
-              <a:gd name="adj" fmla="val 3125"/>
+              <a:gd name="adj" fmla="val 2667"/>
             </a:avLst>
           </a:prstGeom>
           <a:solidFill>
             <a:srgbClr val="FEF2F2"/>
           </a:solidFill>
-          <a:ln w="25400">
+          <a:ln w="19050">
             <a:solidFill>
-              <a:srgbClr val="EF4444"/>
+              <a:srgbClr val="DC2626"/>
             </a:solidFill>
             <a:prstDash val="solid"/>
           </a:ln>
@@ -1467,14 +1467,14 @@
         </p:nvSpPr>
         <p:spPr>
           <a:xfrm>
-            <a:off x="274320" y="1691640"/>
-            <a:ext cx="4480560" cy="320040"/>
-          </a:xfrm>
-          <a:prstGeom prst="rect">
-            <a:avLst/>
-          </a:prstGeom>
-          <a:solidFill>
-            <a:srgbClr val="EF4444"/>
+            <a:off x="365760" y="1353312"/>
+            <a:ext cx="4434840" cy="256032"/>
+          </a:xfrm>
+          <a:prstGeom prst="rect">
+            <a:avLst/>
+          </a:prstGeom>
+          <a:solidFill>
+            <a:srgbClr val="DC2626"/>
           </a:solidFill>
           <a:ln/>
         </p:spPr>
@@ -1487,8 +1487,8 @@
         </p:nvSpPr>
         <p:spPr>
           <a:xfrm>
-            <a:off x="365760" y="1737360"/>
-            <a:ext cx="4297680" cy="228600"/>
+            <a:off x="457200" y="1389888"/>
+            <a:ext cx="4251960" cy="182880"/>
           </a:xfrm>
           <a:prstGeom prst="rect">
             <a:avLst/>
@@ -1504,7 +1504,7 @@
               <a:buNone/>
             </a:pPr>
             <a:r>
-              <a:rPr lang="en-US" sz="1100" b="1" dirty="0">
+              <a:rPr lang="en-US" sz="1000" b="1" dirty="0">
                 <a:solidFill>
                   <a:srgbClr val="FFFFFF"/>
                 </a:solidFill>
@@ -1512,9 +1512,9 @@
                 <a:ea typeface="Arial" pitchFamily="34" charset="-122"/>
                 <a:cs typeface="Arial" pitchFamily="34" charset="-120"/>
               </a:rPr>
-              <a:t>❌ PRE-EXPANSION (Before Apr 9, 2026)</a:t>
-            </a:r>
-            <a:endParaRPr lang="en-US" sz="1100" dirty="0"/>
+              <a:t>❌ PRE-EXPANSION</a:t>
+            </a:r>
+            <a:endParaRPr lang="en-US" sz="1000" dirty="0"/>
           </a:p>
         </p:txBody>
       </p:sp>
@@ -1526,8 +1526,8 @@
         </p:nvSpPr>
         <p:spPr>
           <a:xfrm>
-            <a:off x="365760" y="2103120"/>
-            <a:ext cx="4297680" cy="1005840"/>
+            <a:off x="457200" y="1664208"/>
+            <a:ext cx="4251960" cy="1005840"/>
           </a:xfrm>
           <a:prstGeom prst="rect">
             <a:avLst/>
@@ -1541,12 +1541,12 @@
           <a:p>
             <a:pPr indent="0" marL="0">
               <a:lnSpc>
-                <a:spcPts val="1600"/>
+                <a:spcPts val="1300"/>
               </a:lnSpc>
               <a:buNone/>
             </a:pPr>
             <a:r>
-              <a:rPr lang="en-US" sz="1000" dirty="0">
+              <a:rPr lang="en-US" sz="900" dirty="0">
                 <a:solidFill>
                   <a:srgbClr val="7F1D1D"/>
                 </a:solidFill>
@@ -1554,19 +1554,19 @@
                 <a:ea typeface="Arial" pitchFamily="34" charset="-122"/>
                 <a:cs typeface="Arial" pitchFamily="34" charset="-120"/>
               </a:rPr>
-              <a:t>• Term money restricted to banks &amp; PDs only</a:t>
-            </a:r>
-            <a:endParaRPr lang="en-US" sz="1000" dirty="0"/>
+              <a:t>• Term money restricted to banks &amp; PDs</a:t>
+            </a:r>
+            <a:endParaRPr lang="en-US" sz="900" dirty="0"/>
           </a:p>
           <a:p>
             <a:pPr indent="0" marL="0">
               <a:lnSpc>
-                <a:spcPts val="1600"/>
+                <a:spcPts val="1300"/>
               </a:lnSpc>
               <a:buNone/>
             </a:pPr>
             <a:r>
-              <a:rPr lang="en-US" sz="1000" dirty="0">
+              <a:rPr lang="en-US" sz="900" dirty="0">
                 <a:solidFill>
                   <a:srgbClr val="7F1D1D"/>
                 </a:solidFill>
@@ -1576,17 +1576,17 @@
               </a:rPr>
               <a:t>• NBFCs dependent on bank intermediation</a:t>
             </a:r>
-            <a:endParaRPr lang="en-US" sz="1000" dirty="0"/>
+            <a:endParaRPr lang="en-US" sz="900" dirty="0"/>
           </a:p>
           <a:p>
             <a:pPr indent="0" marL="0">
               <a:lnSpc>
-                <a:spcPts val="1600"/>
+                <a:spcPts val="1300"/>
               </a:lnSpc>
               <a:buNone/>
             </a:pPr>
             <a:r>
-              <a:rPr lang="en-US" sz="1000" dirty="0">
+              <a:rPr lang="en-US" sz="900" dirty="0">
                 <a:solidFill>
                   <a:srgbClr val="7F1D1D"/>
                 </a:solidFill>
@@ -1596,17 +1596,17 @@
               </a:rPr>
               <a:t>• Limited 6M-1Y price transparency</a:t>
             </a:r>
-            <a:endParaRPr lang="en-US" sz="1000" dirty="0"/>
+            <a:endParaRPr lang="en-US" sz="900" dirty="0"/>
           </a:p>
           <a:p>
             <a:pPr indent="0" marL="0">
               <a:lnSpc>
-                <a:spcPts val="1600"/>
+                <a:spcPts val="1300"/>
               </a:lnSpc>
               <a:buNone/>
             </a:pPr>
             <a:r>
-              <a:rPr lang="en-US" sz="1000" dirty="0">
+              <a:rPr lang="en-US" sz="900" dirty="0">
                 <a:solidFill>
                   <a:srgbClr val="7F1D1D"/>
                 </a:solidFill>
@@ -1614,19 +1614,19 @@
                 <a:ea typeface="Arial" pitchFamily="34" charset="-122"/>
                 <a:cs typeface="Arial" pitchFamily="34" charset="-120"/>
               </a:rPr>
-              <a:t>• ALM gaps from asset-tenor mismatches</a:t>
-            </a:r>
-            <a:endParaRPr lang="en-US" sz="1000" dirty="0"/>
+              <a:t>• ALM gaps from tenor mismatches</a:t>
+            </a:r>
+            <a:endParaRPr lang="en-US" sz="900" dirty="0"/>
           </a:p>
           <a:p>
             <a:pPr indent="0" marL="0">
               <a:lnSpc>
-                <a:spcPts val="1600"/>
+                <a:spcPts val="1300"/>
               </a:lnSpc>
               <a:buNone/>
             </a:pPr>
             <a:r>
-              <a:rPr lang="en-US" sz="1000" dirty="0">
+              <a:rPr lang="en-US" sz="900" dirty="0">
                 <a:solidFill>
                   <a:srgbClr val="7F1D1D"/>
                 </a:solidFill>
@@ -1634,9 +1634,9 @@
                 <a:ea typeface="Arial" pitchFamily="34" charset="-122"/>
                 <a:cs typeface="Arial" pitchFamily="34" charset="-120"/>
               </a:rPr>
-              <a:t>• Concentrated bank funding risk (~70-75%)</a:t>
-            </a:r>
-            <a:endParaRPr lang="en-US" sz="1000" dirty="0"/>
+              <a:t>• Bank funding concentration (70-75%)</a:t>
+            </a:r>
+            <a:endParaRPr lang="en-US" sz="900" dirty="0"/>
           </a:p>
         </p:txBody>
       </p:sp>
@@ -1648,20 +1648,20 @@
         </p:nvSpPr>
         <p:spPr>
           <a:xfrm>
-            <a:off x="4937760" y="1691640"/>
-            <a:ext cx="4480560" cy="1463040"/>
+            <a:off x="4983480" y="1353312"/>
+            <a:ext cx="4434840" cy="1371600"/>
           </a:xfrm>
           <a:prstGeom prst="roundRect">
             <a:avLst>
-              <a:gd name="adj" fmla="val 3125"/>
+              <a:gd name="adj" fmla="val 2667"/>
             </a:avLst>
           </a:prstGeom>
           <a:solidFill>
             <a:srgbClr val="F0FDF4"/>
           </a:solidFill>
-          <a:ln w="25400">
+          <a:ln w="19050">
             <a:solidFill>
-              <a:srgbClr val="22C55E"/>
+              <a:srgbClr val="16A34A"/>
             </a:solidFill>
             <a:prstDash val="solid"/>
           </a:ln>
@@ -1675,14 +1675,14 @@
         </p:nvSpPr>
         <p:spPr>
           <a:xfrm>
-            <a:off x="4937760" y="1691640"/>
-            <a:ext cx="4480560" cy="320040"/>
-          </a:xfrm>
-          <a:prstGeom prst="rect">
-            <a:avLst/>
-          </a:prstGeom>
-          <a:solidFill>
-            <a:srgbClr val="22C55E"/>
+            <a:off x="4983480" y="1353312"/>
+            <a:ext cx="4434840" cy="256032"/>
+          </a:xfrm>
+          <a:prstGeom prst="rect">
+            <a:avLst/>
+          </a:prstGeom>
+          <a:solidFill>
+            <a:srgbClr val="16A34A"/>
           </a:solidFill>
           <a:ln/>
         </p:spPr>
@@ -1695,8 +1695,8 @@
         </p:nvSpPr>
         <p:spPr>
           <a:xfrm>
-            <a:off x="5029200" y="1737360"/>
-            <a:ext cx="4297680" cy="228600"/>
+            <a:off x="5074920" y="1389888"/>
+            <a:ext cx="4251960" cy="182880"/>
           </a:xfrm>
           <a:prstGeom prst="rect">
             <a:avLst/>
@@ -1712,7 +1712,7 @@
               <a:buNone/>
             </a:pPr>
             <a:r>
-              <a:rPr lang="en-US" sz="1100" b="1" dirty="0">
+              <a:rPr lang="en-US" sz="1000" b="1" dirty="0">
                 <a:solidFill>
                   <a:srgbClr val="FFFFFF"/>
                 </a:solidFill>
@@ -1720,9 +1720,9 @@
                 <a:ea typeface="Arial" pitchFamily="34" charset="-122"/>
                 <a:cs typeface="Arial" pitchFamily="34" charset="-120"/>
               </a:rPr>
-              <a:t>✅ POST-EXPANSION (After Apr 9, 2026)</a:t>
-            </a:r>
-            <a:endParaRPr lang="en-US" sz="1100" dirty="0"/>
+              <a:t>✅ POST-EXPANSION</a:t>
+            </a:r>
+            <a:endParaRPr lang="en-US" sz="1000" dirty="0"/>
           </a:p>
         </p:txBody>
       </p:sp>
@@ -1734,8 +1734,8 @@
         </p:nvSpPr>
         <p:spPr>
           <a:xfrm>
-            <a:off x="5029200" y="2103120"/>
-            <a:ext cx="4297680" cy="1005840"/>
+            <a:off x="5074920" y="1664208"/>
+            <a:ext cx="4251960" cy="1005840"/>
           </a:xfrm>
           <a:prstGeom prst="rect">
             <a:avLst/>
@@ -1749,12 +1749,12 @@
           <a:p>
             <a:pPr indent="0" marL="0">
               <a:lnSpc>
-                <a:spcPts val="1600"/>
+                <a:spcPts val="1300"/>
               </a:lnSpc>
               <a:buNone/>
             </a:pPr>
             <a:r>
-              <a:rPr lang="en-US" sz="1000" dirty="0">
+              <a:rPr lang="en-US" sz="900" dirty="0">
                 <a:solidFill>
                   <a:srgbClr val="14532D"/>
                 </a:solidFill>
@@ -1762,19 +1762,19 @@
                 <a:ea typeface="Arial" pitchFamily="34" charset="-122"/>
                 <a:cs typeface="Arial" pitchFamily="34" charset="-120"/>
               </a:rPr>
-              <a:t>• Direct NBFC participation in term money market</a:t>
-            </a:r>
-            <a:endParaRPr lang="en-US" sz="1000" dirty="0"/>
+              <a:t>• Direct NBFC participation in term market</a:t>
+            </a:r>
+            <a:endParaRPr lang="en-US" sz="900" dirty="0"/>
           </a:p>
           <a:p>
             <a:pPr indent="0" marL="0">
               <a:lnSpc>
-                <a:spcPts val="1600"/>
+                <a:spcPts val="1300"/>
               </a:lnSpc>
               <a:buNone/>
             </a:pPr>
             <a:r>
-              <a:rPr lang="en-US" sz="1000" dirty="0">
+              <a:rPr lang="en-US" sz="900" dirty="0">
                 <a:solidFill>
                   <a:srgbClr val="14532D"/>
                 </a:solidFill>
@@ -1782,19 +1782,19 @@
                 <a:ea typeface="Arial" pitchFamily="34" charset="-122"/>
                 <a:cs typeface="Arial" pitchFamily="34" charset="-120"/>
               </a:rPr>
-              <a:t>• Reduced bank intermediation costs (15-40 bps)</a:t>
-            </a:r>
-            <a:endParaRPr lang="en-US" sz="1000" dirty="0"/>
+              <a:t>• Reduced bank costs (15-40 bps savings)</a:t>
+            </a:r>
+            <a:endParaRPr lang="en-US" sz="900" dirty="0"/>
           </a:p>
           <a:p>
             <a:pPr indent="0" marL="0">
               <a:lnSpc>
-                <a:spcPts val="1600"/>
+                <a:spcPts val="1300"/>
               </a:lnSpc>
               <a:buNone/>
             </a:pPr>
             <a:r>
-              <a:rPr lang="en-US" sz="1000" dirty="0">
+              <a:rPr lang="en-US" sz="900" dirty="0">
                 <a:solidFill>
                   <a:srgbClr val="14532D"/>
                 </a:solidFill>
@@ -1804,17 +1804,17 @@
               </a:rPr>
               <a:t>• Market-driven rates (MIBOR-linked)</a:t>
             </a:r>
-            <a:endParaRPr lang="en-US" sz="1000" dirty="0"/>
+            <a:endParaRPr lang="en-US" sz="900" dirty="0"/>
           </a:p>
           <a:p>
             <a:pPr indent="0" marL="0">
               <a:lnSpc>
-                <a:spcPts val="1600"/>
+                <a:spcPts val="1300"/>
               </a:lnSpc>
               <a:buNone/>
             </a:pPr>
             <a:r>
-              <a:rPr lang="en-US" sz="1000" dirty="0">
+              <a:rPr lang="en-US" sz="900" dirty="0">
                 <a:solidFill>
                   <a:srgbClr val="14532D"/>
                 </a:solidFill>
@@ -1822,19 +1822,19 @@
                 <a:ea typeface="Arial" pitchFamily="34" charset="-122"/>
                 <a:cs typeface="Arial" pitchFamily="34" charset="-120"/>
               </a:rPr>
-              <a:t>• Flexible tenor: 14D to 1Y for ALM matching</a:t>
-            </a:r>
-            <a:endParaRPr lang="en-US" sz="1000" dirty="0"/>
+              <a:t>• Flexible tenor: 14D to 1Y for ALM</a:t>
+            </a:r>
+            <a:endParaRPr lang="en-US" sz="900" dirty="0"/>
           </a:p>
           <a:p>
             <a:pPr indent="0" marL="0">
               <a:lnSpc>
-                <a:spcPts val="1600"/>
+                <a:spcPts val="1300"/>
               </a:lnSpc>
               <a:buNone/>
             </a:pPr>
             <a:r>
-              <a:rPr lang="en-US" sz="1000" dirty="0">
+              <a:rPr lang="en-US" sz="900" dirty="0">
                 <a:solidFill>
                   <a:srgbClr val="14532D"/>
                 </a:solidFill>
@@ -1842,9 +1842,9 @@
                 <a:ea typeface="Arial" pitchFamily="34" charset="-122"/>
                 <a:cs typeface="Arial" pitchFamily="34" charset="-120"/>
               </a:rPr>
-              <a:t>• Diversify funding: target 60-65% bank vs 70-75%</a:t>
-            </a:r>
-            <a:endParaRPr lang="en-US" sz="1000" dirty="0"/>
+              <a:t>• Diversified funding (target 60-65% bank)</a:t>
+            </a:r>
+            <a:endParaRPr lang="en-US" sz="900" dirty="0"/>
           </a:p>
         </p:txBody>
       </p:sp>
@@ -1856,12 +1856,12 @@
         </p:nvSpPr>
         <p:spPr>
           <a:xfrm>
-            <a:off x="274320" y="3337560"/>
-            <a:ext cx="5486400" cy="1143000"/>
+            <a:off x="365760" y="2834640"/>
+            <a:ext cx="4754880" cy="1234440"/>
           </a:xfrm>
           <a:prstGeom prst="roundRect">
             <a:avLst>
-              <a:gd name="adj" fmla="val 4000"/>
+              <a:gd name="adj" fmla="val 2963"/>
             </a:avLst>
           </a:prstGeom>
           <a:solidFill>
@@ -1869,7 +1869,7 @@
           </a:solidFill>
           <a:ln w="12700">
             <a:solidFill>
-              <a:srgbClr val="CADCFC"/>
+              <a:srgbClr val="1E2761"/>
             </a:solidFill>
             <a:prstDash val="solid"/>
           </a:ln>
@@ -1883,8 +1883,8 @@
         </p:nvSpPr>
         <p:spPr>
           <a:xfrm>
-            <a:off x="274320" y="3337560"/>
-            <a:ext cx="5486400" cy="274320"/>
+            <a:off x="365760" y="2834640"/>
+            <a:ext cx="4754880" cy="237744"/>
           </a:xfrm>
           <a:prstGeom prst="rect">
             <a:avLst/>
@@ -1903,8 +1903,8 @@
         </p:nvSpPr>
         <p:spPr>
           <a:xfrm>
-            <a:off x="365760" y="3383280"/>
-            <a:ext cx="5303520" cy="182880"/>
+            <a:off x="457200" y="2871216"/>
+            <a:ext cx="4572000" cy="164592"/>
           </a:xfrm>
           <a:prstGeom prst="rect">
             <a:avLst/>
@@ -1920,7 +1920,7 @@
               <a:buNone/>
             </a:pPr>
             <a:r>
-              <a:rPr lang="en-US" sz="1200" b="1" dirty="0">
+              <a:rPr lang="en-US" sz="1100" b="1" dirty="0">
                 <a:solidFill>
                   <a:srgbClr val="FFFFFF"/>
                 </a:solidFill>
@@ -1928,9 +1928,9 @@
                 <a:ea typeface="Arial" pitchFamily="34" charset="-122"/>
                 <a:cs typeface="Arial" pitchFamily="34" charset="-120"/>
               </a:rPr>
-              <a:t>🎯 Strategic Benefits for Hero FinCorp</a:t>
-            </a:r>
-            <a:endParaRPr lang="en-US" sz="1200" dirty="0"/>
+              <a:t>🎯 Strategic Benefits</a:t>
+            </a:r>
+            <a:endParaRPr lang="en-US" sz="1100" dirty="0"/>
           </a:p>
         </p:txBody>
       </p:sp>
@@ -1942,8 +1942,8 @@
         </p:nvSpPr>
         <p:spPr>
           <a:xfrm>
-            <a:off x="457200" y="3703320"/>
-            <a:ext cx="2468880" cy="365760"/>
+            <a:off x="548640" y="3154680"/>
+            <a:ext cx="2011680" cy="411480"/>
           </a:xfrm>
           <a:prstGeom prst="rect">
             <a:avLst/>
@@ -1957,12 +1957,12 @@
           <a:p>
             <a:pPr indent="0" marL="0">
               <a:lnSpc>
-                <a:spcPts val="1200"/>
+                <a:spcPts val="1100"/>
               </a:lnSpc>
               <a:buNone/>
             </a:pPr>
             <a:r>
-              <a:rPr lang="en-US" sz="900" dirty="0">
+              <a:rPr lang="en-US" sz="800" dirty="0">
                 <a:solidFill>
                   <a:srgbClr val="1E2761"/>
                 </a:solidFill>
@@ -1972,17 +1972,17 @@
               </a:rPr>
               <a:t>📊 ALM Optimization</a:t>
             </a:r>
-            <a:endParaRPr lang="en-US" sz="900" dirty="0"/>
+            <a:endParaRPr lang="en-US" sz="800" dirty="0"/>
           </a:p>
           <a:p>
             <a:pPr indent="0" marL="0">
               <a:lnSpc>
-                <a:spcPts val="1200"/>
+                <a:spcPts val="1100"/>
               </a:lnSpc>
               <a:buNone/>
             </a:pPr>
             <a:r>
-              <a:rPr lang="en-US" sz="900" dirty="0">
+              <a:rPr lang="en-US" sz="800" dirty="0">
                 <a:solidFill>
                   <a:srgbClr val="1E2761"/>
                 </a:solidFill>
@@ -1990,9 +1990,9 @@
                 <a:ea typeface="Arial" pitchFamily="34" charset="-122"/>
                 <a:cs typeface="Arial" pitchFamily="34" charset="-120"/>
               </a:rPr>
-              <a:t>Granular tenor matching for 2W/3W portfolios</a:t>
-            </a:r>
-            <a:endParaRPr lang="en-US" sz="900" dirty="0"/>
+              <a:t>Granular tenor for 2W/3W portfolios</a:t>
+            </a:r>
+            <a:endParaRPr lang="en-US" sz="800" dirty="0"/>
           </a:p>
         </p:txBody>
       </p:sp>
@@ -2004,8 +2004,8 @@
         </p:nvSpPr>
         <p:spPr>
           <a:xfrm>
-            <a:off x="3108960" y="3703320"/>
-            <a:ext cx="2468880" cy="365760"/>
+            <a:off x="2743200" y="3154680"/>
+            <a:ext cx="2194560" cy="411480"/>
           </a:xfrm>
           <a:prstGeom prst="rect">
             <a:avLst/>
@@ -2019,12 +2019,12 @@
           <a:p>
             <a:pPr indent="0" marL="0">
               <a:lnSpc>
-                <a:spcPts val="1200"/>
+                <a:spcPts val="1100"/>
               </a:lnSpc>
               <a:buNone/>
             </a:pPr>
             <a:r>
-              <a:rPr lang="en-US" sz="900" dirty="0">
+              <a:rPr lang="en-US" sz="800" dirty="0">
                 <a:solidFill>
                   <a:srgbClr val="1E2761"/>
                 </a:solidFill>
@@ -2034,17 +2034,17 @@
               </a:rPr>
               <a:t>⚡ Liquidity Buffer</a:t>
             </a:r>
-            <a:endParaRPr lang="en-US" sz="900" dirty="0"/>
+            <a:endParaRPr lang="en-US" sz="800" dirty="0"/>
           </a:p>
           <a:p>
             <a:pPr indent="0" marL="0">
               <a:lnSpc>
-                <a:spcPts val="1200"/>
+                <a:spcPts val="1100"/>
               </a:lnSpc>
               <a:buNone/>
             </a:pPr>
             <a:r>
-              <a:rPr lang="en-US" sz="900" dirty="0">
+              <a:rPr lang="en-US" sz="800" dirty="0">
                 <a:solidFill>
                   <a:srgbClr val="1E2761"/>
                 </a:solidFill>
@@ -2052,9 +2052,9 @@
                 <a:ea typeface="Arial" pitchFamily="34" charset="-122"/>
                 <a:cs typeface="Arial" pitchFamily="34" charset="-120"/>
               </a:rPr>
-              <a:t>Additional LCR source without bank dependence</a:t>
-            </a:r>
-            <a:endParaRPr lang="en-US" sz="900" dirty="0"/>
+              <a:t>LCR source without bank dependence</a:t>
+            </a:r>
+            <a:endParaRPr lang="en-US" sz="800" dirty="0"/>
           </a:p>
         </p:txBody>
       </p:sp>
@@ -2066,8 +2066,8 @@
         </p:nvSpPr>
         <p:spPr>
           <a:xfrm>
-            <a:off x="457200" y="4114800"/>
-            <a:ext cx="2468880" cy="365760"/>
+            <a:off x="548640" y="3611880"/>
+            <a:ext cx="2011680" cy="411480"/>
           </a:xfrm>
           <a:prstGeom prst="rect">
             <a:avLst/>
@@ -2081,12 +2081,12 @@
           <a:p>
             <a:pPr indent="0" marL="0">
               <a:lnSpc>
-                <a:spcPts val="1200"/>
+                <a:spcPts val="1100"/>
               </a:lnSpc>
               <a:buNone/>
             </a:pPr>
             <a:r>
-              <a:rPr lang="en-US" sz="900" dirty="0">
+              <a:rPr lang="en-US" sz="800" dirty="0">
                 <a:solidFill>
                   <a:srgbClr val="1E2761"/>
                 </a:solidFill>
@@ -2096,17 +2096,17 @@
               </a:rPr>
               <a:t>💹 Rate Transmission</a:t>
             </a:r>
-            <a:endParaRPr lang="en-US" sz="900" dirty="0"/>
+            <a:endParaRPr lang="en-US" sz="800" dirty="0"/>
           </a:p>
           <a:p>
             <a:pPr indent="0" marL="0">
               <a:lnSpc>
-                <a:spcPts val="1200"/>
+                <a:spcPts val="1100"/>
               </a:lnSpc>
               <a:buNone/>
             </a:pPr>
             <a:r>
-              <a:rPr lang="en-US" sz="900" dirty="0">
+              <a:rPr lang="en-US" sz="800" dirty="0">
                 <a:solidFill>
                   <a:srgbClr val="1E2761"/>
                 </a:solidFill>
@@ -2114,9 +2114,9 @@
                 <a:ea typeface="Arial" pitchFamily="34" charset="-122"/>
                 <a:cs typeface="Arial" pitchFamily="34" charset="-120"/>
               </a:rPr>
-              <a:t>MIBOR-linked rates vs slower MCLR transmission</a:t>
-            </a:r>
-            <a:endParaRPr lang="en-US" sz="900" dirty="0"/>
+              <a:t>MIBOR-linked vs slower MCLR</a:t>
+            </a:r>
+            <a:endParaRPr lang="en-US" sz="800" dirty="0"/>
           </a:p>
         </p:txBody>
       </p:sp>
@@ -2128,8 +2128,8 @@
         </p:nvSpPr>
         <p:spPr>
           <a:xfrm>
-            <a:off x="3108960" y="4114800"/>
-            <a:ext cx="2468880" cy="365760"/>
+            <a:off x="2743200" y="3611880"/>
+            <a:ext cx="2194560" cy="411480"/>
           </a:xfrm>
           <a:prstGeom prst="rect">
             <a:avLst/>
@@ -2143,12 +2143,12 @@
           <a:p>
             <a:pPr indent="0" marL="0">
               <a:lnSpc>
-                <a:spcPts val="1200"/>
+                <a:spcPts val="1100"/>
               </a:lnSpc>
               <a:buNone/>
             </a:pPr>
             <a:r>
-              <a:rPr lang="en-US" sz="900" dirty="0">
+              <a:rPr lang="en-US" sz="800" dirty="0">
                 <a:solidFill>
                   <a:srgbClr val="1E2761"/>
                 </a:solidFill>
@@ -2158,17 +2158,17 @@
               </a:rPr>
               <a:t>🔄 Roll-over Efficiency</a:t>
             </a:r>
-            <a:endParaRPr lang="en-US" sz="900" dirty="0"/>
+            <a:endParaRPr lang="en-US" sz="800" dirty="0"/>
           </a:p>
           <a:p>
             <a:pPr indent="0" marL="0">
               <a:lnSpc>
-                <a:spcPts val="1200"/>
+                <a:spcPts val="1100"/>
               </a:lnSpc>
               <a:buNone/>
             </a:pPr>
             <a:r>
-              <a:rPr lang="en-US" sz="900" dirty="0">
+              <a:rPr lang="en-US" sz="800" dirty="0">
                 <a:solidFill>
                   <a:srgbClr val="1E2761"/>
                 </a:solidFill>
@@ -2176,9 +2176,9 @@
                 <a:ea typeface="Arial" pitchFamily="34" charset="-122"/>
                 <a:cs typeface="Arial" pitchFamily="34" charset="-120"/>
               </a:rPr>
-              <a:t>Reduced refinancing risk vs short-term CP</a:t>
-            </a:r>
-            <a:endParaRPr lang="en-US" sz="900" dirty="0"/>
+              <a:t>Reduced risk vs short-term CP</a:t>
+            </a:r>
+            <a:endParaRPr lang="en-US" sz="800" dirty="0"/>
           </a:p>
         </p:txBody>
       </p:sp>
@@ -2190,12 +2190,12 @@
         </p:nvSpPr>
         <p:spPr>
           <a:xfrm>
-            <a:off x="5943600" y="3337560"/>
-            <a:ext cx="3474720" cy="1143000"/>
+            <a:off x="5257800" y="2834640"/>
+            <a:ext cx="3246120" cy="1234440"/>
           </a:xfrm>
           <a:prstGeom prst="roundRect">
             <a:avLst>
-              <a:gd name="adj" fmla="val 4000"/>
+              <a:gd name="adj" fmla="val 2963"/>
             </a:avLst>
           </a:prstGeom>
           <a:solidFill>
@@ -2217,14 +2217,14 @@
         </p:nvSpPr>
         <p:spPr>
           <a:xfrm>
-            <a:off x="5943600" y="3337560"/>
-            <a:ext cx="3474720" cy="274320"/>
-          </a:xfrm>
-          <a:prstGeom prst="rect">
-            <a:avLst/>
-          </a:prstGeom>
-          <a:solidFill>
-            <a:srgbClr val="FBBF24"/>
+            <a:off x="5257800" y="2834640"/>
+            <a:ext cx="3246120" cy="237744"/>
+          </a:xfrm>
+          <a:prstGeom prst="rect">
+            <a:avLst/>
+          </a:prstGeom>
+          <a:solidFill>
+            <a:srgbClr val="D97706"/>
           </a:solidFill>
           <a:ln/>
         </p:spPr>
@@ -2237,8 +2237,8 @@
         </p:nvSpPr>
         <p:spPr>
           <a:xfrm>
-            <a:off x="6035040" y="3383280"/>
-            <a:ext cx="3291840" cy="182880"/>
+            <a:off x="5349240" y="2871216"/>
+            <a:ext cx="3063240" cy="164592"/>
           </a:xfrm>
           <a:prstGeom prst="rect">
             <a:avLst/>
@@ -2254,17 +2254,17 @@
               <a:buNone/>
             </a:pPr>
             <a:r>
-              <a:rPr lang="en-US" sz="1200" b="1" dirty="0">
-                <a:solidFill>
-                  <a:srgbClr val="92400E"/>
-                </a:solidFill>
-                <a:latin typeface="Arial" pitchFamily="34" charset="0"/>
-                <a:ea typeface="Arial" pitchFamily="34" charset="-122"/>
-                <a:cs typeface="Arial" pitchFamily="34" charset="-120"/>
-              </a:rPr>
-              <a:t>⚡ Immediate Actions (Next 30 Days)</a:t>
-            </a:r>
-            <a:endParaRPr lang="en-US" sz="1200" dirty="0"/>
+              <a:rPr lang="en-US" sz="1100" b="1" dirty="0">
+                <a:solidFill>
+                  <a:srgbClr val="FFFFFF"/>
+                </a:solidFill>
+                <a:latin typeface="Arial" pitchFamily="34" charset="0"/>
+                <a:ea typeface="Arial" pitchFamily="34" charset="-122"/>
+                <a:cs typeface="Arial" pitchFamily="34" charset="-120"/>
+              </a:rPr>
+              <a:t>⚡ Immediate Actions (30 Days)</a:t>
+            </a:r>
+            <a:endParaRPr lang="en-US" sz="1100" dirty="0"/>
           </a:p>
         </p:txBody>
       </p:sp>
@@ -2276,12 +2276,12 @@
         </p:nvSpPr>
         <p:spPr>
           <a:xfrm>
-            <a:off x="6126480" y="3703320"/>
-            <a:ext cx="457200" cy="164592"/>
+            <a:off x="5394960" y="3182112"/>
+            <a:ext cx="411480" cy="146304"/>
           </a:xfrm>
           <a:prstGeom prst="roundRect">
             <a:avLst>
-              <a:gd name="adj" fmla="val 11111"/>
+              <a:gd name="adj" fmla="val 12500"/>
             </a:avLst>
           </a:prstGeom>
           <a:solidFill>
@@ -2298,8 +2298,8 @@
         </p:nvSpPr>
         <p:spPr>
           <a:xfrm>
-            <a:off x="6126480" y="3703320"/>
-            <a:ext cx="457200" cy="164592"/>
+            <a:off x="5394960" y="3182112"/>
+            <a:ext cx="411480" cy="146304"/>
           </a:xfrm>
           <a:prstGeom prst="rect">
             <a:avLst/>
@@ -2337,8 +2337,8 @@
         </p:nvSpPr>
         <p:spPr>
           <a:xfrm>
-            <a:off x="6675120" y="3703320"/>
-            <a:ext cx="2560320" cy="164592"/>
+            <a:off x="5897880" y="3182112"/>
+            <a:ext cx="2468880" cy="146304"/>
           </a:xfrm>
           <a:prstGeom prst="rect">
             <a:avLst/>
@@ -2354,7 +2354,7 @@
               <a:buNone/>
             </a:pPr>
             <a:r>
-              <a:rPr lang="en-US" sz="1000" dirty="0">
+              <a:rPr lang="en-US" sz="900" dirty="0">
                 <a:solidFill>
                   <a:srgbClr val="1E2761"/>
                 </a:solidFill>
@@ -2364,7 +2364,7 @@
               </a:rPr>
               <a:t>CCIL/NDS-OM Registration</a:t>
             </a:r>
-            <a:endParaRPr lang="en-US" sz="1000" dirty="0"/>
+            <a:endParaRPr lang="en-US" sz="900" dirty="0"/>
           </a:p>
         </p:txBody>
       </p:sp>
@@ -2376,12 +2376,12 @@
         </p:nvSpPr>
         <p:spPr>
           <a:xfrm>
-            <a:off x="6126480" y="3931920"/>
-            <a:ext cx="457200" cy="164592"/>
+            <a:off x="5394960" y="3401568"/>
+            <a:ext cx="411480" cy="146304"/>
           </a:xfrm>
           <a:prstGeom prst="roundRect">
             <a:avLst>
-              <a:gd name="adj" fmla="val 11111"/>
+              <a:gd name="adj" fmla="val 12500"/>
             </a:avLst>
           </a:prstGeom>
           <a:solidFill>
@@ -2398,8 +2398,8 @@
         </p:nvSpPr>
         <p:spPr>
           <a:xfrm>
-            <a:off x="6126480" y="3931920"/>
-            <a:ext cx="457200" cy="164592"/>
+            <a:off x="5394960" y="3401568"/>
+            <a:ext cx="411480" cy="146304"/>
           </a:xfrm>
           <a:prstGeom prst="rect">
             <a:avLst/>
@@ -2437,8 +2437,8 @@
         </p:nvSpPr>
         <p:spPr>
           <a:xfrm>
-            <a:off x="6675120" y="3931920"/>
-            <a:ext cx="2560320" cy="164592"/>
+            <a:off x="5897880" y="3401568"/>
+            <a:ext cx="2468880" cy="146304"/>
           </a:xfrm>
           <a:prstGeom prst="rect">
             <a:avLst/>
@@ -2454,7 +2454,7 @@
               <a:buNone/>
             </a:pPr>
             <a:r>
-              <a:rPr lang="en-US" sz="1000" dirty="0">
+              <a:rPr lang="en-US" sz="900" dirty="0">
                 <a:solidFill>
                   <a:srgbClr val="1E2761"/>
                 </a:solidFill>
@@ -2462,9 +2462,9 @@
                 <a:ea typeface="Arial" pitchFamily="34" charset="-122"/>
                 <a:cs typeface="Arial" pitchFamily="34" charset="-120"/>
               </a:rPr>
-              <a:t>Update Treasury Policy Framework</a:t>
-            </a:r>
-            <a:endParaRPr lang="en-US" sz="1000" dirty="0"/>
+              <a:t>Update Treasury Policy</a:t>
+            </a:r>
+            <a:endParaRPr lang="en-US" sz="900" dirty="0"/>
           </a:p>
         </p:txBody>
       </p:sp>
@@ -2476,12 +2476,12 @@
         </p:nvSpPr>
         <p:spPr>
           <a:xfrm>
-            <a:off x="6126480" y="4160520"/>
-            <a:ext cx="457200" cy="164592"/>
+            <a:off x="5394960" y="3621024"/>
+            <a:ext cx="411480" cy="146304"/>
           </a:xfrm>
           <a:prstGeom prst="roundRect">
             <a:avLst>
-              <a:gd name="adj" fmla="val 11111"/>
+              <a:gd name="adj" fmla="val 12500"/>
             </a:avLst>
           </a:prstGeom>
           <a:solidFill>
@@ -2498,8 +2498,8 @@
         </p:nvSpPr>
         <p:spPr>
           <a:xfrm>
-            <a:off x="6126480" y="4160520"/>
-            <a:ext cx="457200" cy="164592"/>
+            <a:off x="5394960" y="3621024"/>
+            <a:ext cx="411480" cy="146304"/>
           </a:xfrm>
           <a:prstGeom prst="rect">
             <a:avLst/>
@@ -2537,8 +2537,8 @@
         </p:nvSpPr>
         <p:spPr>
           <a:xfrm>
-            <a:off x="6675120" y="4160520"/>
-            <a:ext cx="2560320" cy="164592"/>
+            <a:off x="5897880" y="3621024"/>
+            <a:ext cx="2468880" cy="146304"/>
           </a:xfrm>
           <a:prstGeom prst="rect">
             <a:avLst/>
@@ -2554,7 +2554,7 @@
               <a:buNone/>
             </a:pPr>
             <a:r>
-              <a:rPr lang="en-US" sz="1000" dirty="0">
+              <a:rPr lang="en-US" sz="900" dirty="0">
                 <a:solidFill>
                   <a:srgbClr val="1E2761"/>
                 </a:solidFill>
@@ -2562,9 +2562,9 @@
                 <a:ea typeface="Arial" pitchFamily="34" charset="-122"/>
                 <a:cs typeface="Arial" pitchFamily="34" charset="-120"/>
               </a:rPr>
-              <a:t>Trading Infrastructure Setup</a:t>
-            </a:r>
-            <a:endParaRPr lang="en-US" sz="1000" dirty="0"/>
+              <a:t>Trading Infrastructure</a:t>
+            </a:r>
+            <a:endParaRPr lang="en-US" sz="900" dirty="0"/>
           </a:p>
         </p:txBody>
       </p:sp>
@@ -2576,8 +2576,8 @@
         </p:nvSpPr>
         <p:spPr>
           <a:xfrm>
-            <a:off x="0" y="4572000"/>
-            <a:ext cx="9144000" cy="320040"/>
+            <a:off x="0" y="4206240"/>
+            <a:ext cx="9144000" cy="292608"/>
           </a:xfrm>
           <a:prstGeom prst="rect">
             <a:avLst/>
@@ -2596,8 +2596,8 @@
         </p:nvSpPr>
         <p:spPr>
           <a:xfrm>
-            <a:off x="274320" y="4617720"/>
-            <a:ext cx="8229600" cy="228600"/>
+            <a:off x="365760" y="4233672"/>
+            <a:ext cx="7315200" cy="164592"/>
           </a:xfrm>
           <a:prstGeom prst="rect">
             <a:avLst/>
@@ -2613,7 +2613,7 @@
               <a:buNone/>
             </a:pPr>
             <a:r>
-              <a:rPr lang="en-US" sz="900" dirty="0">
+              <a:rPr lang="en-US" sz="800" dirty="0">
                 <a:solidFill>
                   <a:srgbClr val="CADCFC"/>
                 </a:solidFill>
@@ -2621,9 +2621,9 @@
                 <a:ea typeface="Arial" pitchFamily="34" charset="-122"/>
                 <a:cs typeface="Arial" pitchFamily="34" charset="-120"/>
               </a:rPr>
-              <a:t>Hero FinCorp Treasury Analysis | RBI Circular Dated: April 9, 2026 | Classification: Internal Use</a:t>
-            </a:r>
-            <a:endParaRPr lang="en-US" sz="900" dirty="0"/>
+              <a:t>Hero FinCorp Treasury | RBI Circular: April 9, 2026 | Internal Use Only</a:t>
+            </a:r>
+            <a:endParaRPr lang="en-US" sz="800" dirty="0"/>
           </a:p>
         </p:txBody>
       </p:sp>
@@ -2635,8 +2635,8 @@
         </p:nvSpPr>
         <p:spPr>
           <a:xfrm>
-            <a:off x="274320" y="4736592"/>
-            <a:ext cx="8229600" cy="137160"/>
+            <a:off x="365760" y="4370832"/>
+            <a:ext cx="7315200" cy="109728"/>
           </a:xfrm>
           <a:prstGeom prst="rect">
             <a:avLst/>
@@ -2660,7 +2660,7 @@
                 <a:ea typeface="Arial" pitchFamily="34" charset="-122"/>
                 <a:cs typeface="Arial" pitchFamily="34" charset="-120"/>
               </a:rPr>
-              <a:t>Projections are estimates based on market conditions. Actual savings depend on credit rating, market depth, and participation scale.</a:t>
+              <a:t>Projections are estimates. Actual savings depend on credit rating, market depth, and participation scale.</a:t>
             </a:r>
             <a:endParaRPr lang="en-US" sz="700" dirty="0"/>
           </a:p>

</xml_diff>

<commit_message>
Fix PowerPoint layout v3 - conservative spacing, adjusted all boxes
</commit_message>
<xml_diff>
--- a/RBI_Term_Money_Market_HeroFinCorp_Analysis.pptx
+++ b/RBI_Term_Money_Market_HeroFinCorp_Analysis.pptx
@@ -857,7 +857,7 @@
     <p:bg>
       <p:bgPr>
         <a:solidFill>
-          <a:srgbClr val="F8FAFC"/>
+          <a:srgbClr val="FFFFFF"/>
         </a:solidFill>
       </p:bgPr>
     </p:bg>
@@ -884,7 +884,7 @@
         <p:spPr>
           <a:xfrm>
             <a:off x="0" y="0"/>
-            <a:ext cx="9144000" cy="594360"/>
+            <a:ext cx="9144000" cy="548640"/>
           </a:xfrm>
           <a:prstGeom prst="rect">
             <a:avLst/>
@@ -903,34 +903,34 @@
         </p:nvSpPr>
         <p:spPr>
           <a:xfrm>
-            <a:off x="365760" y="109728"/>
-            <a:ext cx="7315200" cy="320040"/>
-          </a:xfrm>
-          <a:prstGeom prst="rect">
-            <a:avLst/>
-          </a:prstGeom>
-          <a:noFill/>
-          <a:ln/>
-        </p:spPr>
-        <p:txBody>
-          <a:bodyPr wrap="square" rtlCol="0" anchor="ctr"/>
-          <a:lstStyle/>
-          <a:p>
-            <a:pPr indent="0" marL="0">
-              <a:buNone/>
-            </a:pPr>
-            <a:r>
-              <a:rPr lang="en-US" sz="2000" b="1" dirty="0">
+            <a:off x="274320" y="137160"/>
+            <a:ext cx="8229600" cy="320040"/>
+          </a:xfrm>
+          <a:prstGeom prst="rect">
+            <a:avLst/>
+          </a:prstGeom>
+          <a:noFill/>
+          <a:ln/>
+        </p:spPr>
+        <p:txBody>
+          <a:bodyPr wrap="square" rtlCol="0" anchor="ctr"/>
+          <a:lstStyle/>
+          <a:p>
+            <a:pPr indent="0" marL="0">
+              <a:buNone/>
+            </a:pPr>
+            <a:r>
+              <a:rPr lang="en-US" sz="1600" b="1" dirty="0">
                 <a:solidFill>
                   <a:srgbClr val="FFFFFF"/>
                 </a:solidFill>
-                <a:latin typeface="Arial" pitchFamily="34" charset="0"/>
-                <a:ea typeface="Arial" pitchFamily="34" charset="-122"/>
-                <a:cs typeface="Arial" pitchFamily="34" charset="-120"/>
-              </a:rPr>
-              <a:t>🏛️ RBI Term Money Market Expansion</a:t>
-            </a:r>
-            <a:endParaRPr lang="en-US" sz="2000" dirty="0"/>
+                <a:latin typeface="Calibri" pitchFamily="34" charset="0"/>
+                <a:ea typeface="Calibri" pitchFamily="34" charset="-122"/>
+                <a:cs typeface="Calibri" pitchFamily="34" charset="-120"/>
+              </a:rPr>
+              <a:t>🏛️ RBI Term Money Market Expansion — Strategic Impact for Hero FinCorp</a:t>
+            </a:r>
+            <a:endParaRPr lang="en-US" sz="1600" dirty="0"/>
           </a:p>
         </p:txBody>
       </p:sp>
@@ -942,98 +942,59 @@
         </p:nvSpPr>
         <p:spPr>
           <a:xfrm>
-            <a:off x="365760" y="347472"/>
-            <a:ext cx="5486400" cy="182880"/>
-          </a:xfrm>
-          <a:prstGeom prst="rect">
-            <a:avLst/>
-          </a:prstGeom>
-          <a:noFill/>
-          <a:ln/>
-        </p:spPr>
-        <p:txBody>
-          <a:bodyPr wrap="square" rtlCol="0" anchor="ctr"/>
-          <a:lstStyle/>
-          <a:p>
-            <a:pPr indent="0" marL="0">
-              <a:buNone/>
-            </a:pPr>
-            <a:r>
-              <a:rPr lang="en-US" sz="1000" dirty="0">
+            <a:off x="7772400" y="137160"/>
+            <a:ext cx="1828800" cy="320040"/>
+          </a:xfrm>
+          <a:prstGeom prst="rect">
+            <a:avLst/>
+          </a:prstGeom>
+          <a:noFill/>
+          <a:ln/>
+        </p:spPr>
+        <p:txBody>
+          <a:bodyPr wrap="square" rtlCol="0" anchor="ctr"/>
+          <a:lstStyle/>
+          <a:p>
+            <a:pPr algn="r" indent="0" marL="0">
+              <a:buNone/>
+            </a:pPr>
+            <a:r>
+              <a:rPr lang="en-US" sz="900" dirty="0">
                 <a:solidFill>
                   <a:srgbClr val="CADCFC"/>
                 </a:solidFill>
-                <a:latin typeface="Arial" pitchFamily="34" charset="0"/>
-                <a:ea typeface="Arial" pitchFamily="34" charset="-122"/>
-                <a:cs typeface="Arial" pitchFamily="34" charset="-120"/>
-              </a:rPr>
-              <a:t>Strategic Impact Analysis for Hero FinCorp | April 9, 2026</a:t>
-            </a:r>
-            <a:endParaRPr lang="en-US" sz="1000" dirty="0"/>
-          </a:p>
-        </p:txBody>
-      </p:sp>
-      <p:sp>
-        <p:nvSpPr>
-          <p:cNvPr id="5" name="Text 3"/>
-          <p:cNvSpPr/>
-          <p:nvPr/>
-        </p:nvSpPr>
-        <p:spPr>
-          <a:xfrm>
-            <a:off x="7772400" y="182880"/>
-            <a:ext cx="1645920" cy="274320"/>
-          </a:xfrm>
-          <a:prstGeom prst="rect">
-            <a:avLst/>
-          </a:prstGeom>
-          <a:noFill/>
-          <a:ln/>
-        </p:spPr>
-        <p:txBody>
-          <a:bodyPr wrap="square" rtlCol="0" anchor="ctr"/>
-          <a:lstStyle/>
-          <a:p>
-            <a:pPr algn="r" indent="0" marL="0">
-              <a:buNone/>
-            </a:pPr>
-            <a:r>
-              <a:rPr lang="en-US" sz="1000" dirty="0">
-                <a:solidFill>
-                  <a:srgbClr val="FFFFFF"/>
-                </a:solidFill>
-                <a:latin typeface="Arial" pitchFamily="34" charset="0"/>
-                <a:ea typeface="Arial" pitchFamily="34" charset="-122"/>
-                <a:cs typeface="Arial" pitchFamily="34" charset="-120"/>
-              </a:rPr>
-              <a:t>NBFC-ML Treasury</a:t>
-            </a:r>
-            <a:endParaRPr lang="en-US" sz="1000" dirty="0"/>
-          </a:p>
-        </p:txBody>
-      </p:sp>
-      <p:sp>
-        <p:nvSpPr>
-          <p:cNvPr id="6" name="Shape 4"/>
-          <p:cNvSpPr/>
-          <p:nvPr/>
-        </p:nvSpPr>
-        <p:spPr>
-          <a:xfrm>
-            <a:off x="365760" y="713232"/>
-            <a:ext cx="2148840" cy="548640"/>
+                <a:latin typeface="Calibri" pitchFamily="34" charset="0"/>
+                <a:ea typeface="Calibri" pitchFamily="34" charset="-122"/>
+                <a:cs typeface="Calibri" pitchFamily="34" charset="-120"/>
+              </a:rPr>
+              <a:t>April 9, 2026 | NBFC-ML Treasury Strategy</a:t>
+            </a:r>
+            <a:endParaRPr lang="en-US" sz="900" dirty="0"/>
+          </a:p>
+        </p:txBody>
+      </p:sp>
+      <p:sp>
+        <p:nvSpPr>
+          <p:cNvPr id="5" name="Shape 3"/>
+          <p:cNvSpPr/>
+          <p:nvPr/>
+        </p:nvSpPr>
+        <p:spPr>
+          <a:xfrm>
+            <a:off x="274320" y="685800"/>
+            <a:ext cx="2194560" cy="502920"/>
           </a:xfrm>
           <a:prstGeom prst="roundRect">
             <a:avLst>
-              <a:gd name="adj" fmla="val 6667"/>
+              <a:gd name="adj" fmla="val 5455"/>
             </a:avLst>
           </a:prstGeom>
           <a:solidFill>
-            <a:srgbClr val="FFFFFF"/>
-          </a:solidFill>
-          <a:ln w="19050">
+            <a:srgbClr val="EFF6FF"/>
+          </a:solidFill>
+          <a:ln w="12700">
             <a:solidFill>
-              <a:srgbClr val="1E2761"/>
+              <a:srgbClr val="2563EB"/>
             </a:solidFill>
             <a:prstDash val="solid"/>
           </a:ln>
@@ -1041,53 +1002,53 @@
       </p:sp>
       <p:sp>
         <p:nvSpPr>
+          <p:cNvPr id="6" name="Text 4"/>
+          <p:cNvSpPr/>
+          <p:nvPr/>
+        </p:nvSpPr>
+        <p:spPr>
+          <a:xfrm>
+            <a:off x="365760" y="731520"/>
+            <a:ext cx="2011680" cy="256032"/>
+          </a:xfrm>
+          <a:prstGeom prst="rect">
+            <a:avLst/>
+          </a:prstGeom>
+          <a:noFill/>
+          <a:ln/>
+        </p:spPr>
+        <p:txBody>
+          <a:bodyPr wrap="square" rtlCol="0" anchor="ctr"/>
+          <a:lstStyle/>
+          <a:p>
+            <a:pPr indent="0" marL="0">
+              <a:buNone/>
+            </a:pPr>
+            <a:r>
+              <a:rPr lang="en-US" sz="1600" b="1" dirty="0">
+                <a:solidFill>
+                  <a:srgbClr val="1E40AF"/>
+                </a:solidFill>
+                <a:latin typeface="Calibri" pitchFamily="34" charset="0"/>
+                <a:ea typeface="Calibri" pitchFamily="34" charset="-122"/>
+                <a:cs typeface="Calibri" pitchFamily="34" charset="-120"/>
+              </a:rPr>
+              <a:t>15-40 bps</a:t>
+            </a:r>
+            <a:endParaRPr lang="en-US" sz="1600" dirty="0"/>
+          </a:p>
+        </p:txBody>
+      </p:sp>
+      <p:sp>
+        <p:nvSpPr>
           <p:cNvPr id="7" name="Text 5"/>
           <p:cNvSpPr/>
           <p:nvPr/>
         </p:nvSpPr>
         <p:spPr>
           <a:xfrm>
-            <a:off x="457200" y="768096"/>
-            <a:ext cx="1965960" cy="256032"/>
-          </a:xfrm>
-          <a:prstGeom prst="rect">
-            <a:avLst/>
-          </a:prstGeom>
-          <a:noFill/>
-          <a:ln/>
-        </p:spPr>
-        <p:txBody>
-          <a:bodyPr wrap="square" rtlCol="0" anchor="ctr"/>
-          <a:lstStyle/>
-          <a:p>
-            <a:pPr indent="0" marL="0">
-              <a:buNone/>
-            </a:pPr>
-            <a:r>
-              <a:rPr lang="en-US" sz="1800" b="1" dirty="0">
-                <a:solidFill>
-                  <a:srgbClr val="1E2761"/>
-                </a:solidFill>
-                <a:latin typeface="Arial" pitchFamily="34" charset="0"/>
-                <a:ea typeface="Arial" pitchFamily="34" charset="-122"/>
-                <a:cs typeface="Arial" pitchFamily="34" charset="-120"/>
-              </a:rPr>
-              <a:t>15-40 bps</a:t>
-            </a:r>
-            <a:endParaRPr lang="en-US" sz="1800" dirty="0"/>
-          </a:p>
-        </p:txBody>
-      </p:sp>
-      <p:sp>
-        <p:nvSpPr>
-          <p:cNvPr id="8" name="Text 6"/>
-          <p:cNvSpPr/>
-          <p:nvPr/>
-        </p:nvSpPr>
-        <p:spPr>
-          <a:xfrm>
-            <a:off x="457200" y="1005840"/>
-            <a:ext cx="1965960" cy="201168"/>
+            <a:off x="365760" y="978408"/>
+            <a:ext cx="2011680" cy="182880"/>
           </a:xfrm>
           <a:prstGeom prst="rect">
             <a:avLst/>
@@ -1107,11 +1068,11 @@
                 <a:solidFill>
                   <a:srgbClr val="4B5563"/>
                 </a:solidFill>
-                <a:latin typeface="Arial" pitchFamily="34" charset="0"/>
-                <a:ea typeface="Arial" pitchFamily="34" charset="-122"/>
-                <a:cs typeface="Arial" pitchFamily="34" charset="-120"/>
-              </a:rPr>
-              <a:t>💰 Cost Savings vs Bank Credit</a:t>
+                <a:latin typeface="Calibri" pitchFamily="34" charset="0"/>
+                <a:ea typeface="Calibri" pitchFamily="34" charset="-122"/>
+                <a:cs typeface="Calibri" pitchFamily="34" charset="-120"/>
+              </a:rPr>
+              <a:t>Cost Savings vs Bank Credit</a:t>
             </a:r>
             <a:endParaRPr lang="en-US" sz="800" dirty="0"/>
           </a:p>
@@ -1119,26 +1080,26 @@
       </p:sp>
       <p:sp>
         <p:nvSpPr>
-          <p:cNvPr id="9" name="Shape 7"/>
-          <p:cNvSpPr/>
-          <p:nvPr/>
-        </p:nvSpPr>
-        <p:spPr>
-          <a:xfrm>
-            <a:off x="2633472" y="713232"/>
-            <a:ext cx="2148840" cy="548640"/>
+          <p:cNvPr id="8" name="Shape 6"/>
+          <p:cNvSpPr/>
+          <p:nvPr/>
+        </p:nvSpPr>
+        <p:spPr>
+          <a:xfrm>
+            <a:off x="2587752" y="685800"/>
+            <a:ext cx="2194560" cy="502920"/>
           </a:xfrm>
           <a:prstGeom prst="roundRect">
             <a:avLst>
-              <a:gd name="adj" fmla="val 6667"/>
+              <a:gd name="adj" fmla="val 5455"/>
             </a:avLst>
           </a:prstGeom>
           <a:solidFill>
-            <a:srgbClr val="FFFFFF"/>
-          </a:solidFill>
-          <a:ln w="19050">
+            <a:srgbClr val="ECFDF5"/>
+          </a:solidFill>
+          <a:ln w="12700">
             <a:solidFill>
-              <a:srgbClr val="10B981"/>
+              <a:srgbClr val="059669"/>
             </a:solidFill>
             <a:prstDash val="solid"/>
           </a:ln>
@@ -1146,53 +1107,53 @@
       </p:sp>
       <p:sp>
         <p:nvSpPr>
+          <p:cNvPr id="9" name="Text 7"/>
+          <p:cNvSpPr/>
+          <p:nvPr/>
+        </p:nvSpPr>
+        <p:spPr>
+          <a:xfrm>
+            <a:off x="2679192" y="731520"/>
+            <a:ext cx="2011680" cy="256032"/>
+          </a:xfrm>
+          <a:prstGeom prst="rect">
+            <a:avLst/>
+          </a:prstGeom>
+          <a:noFill/>
+          <a:ln/>
+        </p:spPr>
+        <p:txBody>
+          <a:bodyPr wrap="square" rtlCol="0" anchor="ctr"/>
+          <a:lstStyle/>
+          <a:p>
+            <a:pPr indent="0" marL="0">
+              <a:buNone/>
+            </a:pPr>
+            <a:r>
+              <a:rPr lang="en-US" sz="1600" b="1" dirty="0">
+                <a:solidFill>
+                  <a:srgbClr val="059669"/>
+                </a:solidFill>
+                <a:latin typeface="Calibri" pitchFamily="34" charset="0"/>
+                <a:ea typeface="Calibri" pitchFamily="34" charset="-122"/>
+                <a:cs typeface="Calibri" pitchFamily="34" charset="-120"/>
+              </a:rPr>
+              <a:t>₹3-12 Cr</a:t>
+            </a:r>
+            <a:endParaRPr lang="en-US" sz="1600" dirty="0"/>
+          </a:p>
+        </p:txBody>
+      </p:sp>
+      <p:sp>
+        <p:nvSpPr>
           <p:cNvPr id="10" name="Text 8"/>
           <p:cNvSpPr/>
           <p:nvPr/>
         </p:nvSpPr>
         <p:spPr>
           <a:xfrm>
-            <a:off x="2724912" y="768096"/>
-            <a:ext cx="1965960" cy="256032"/>
-          </a:xfrm>
-          <a:prstGeom prst="rect">
-            <a:avLst/>
-          </a:prstGeom>
-          <a:noFill/>
-          <a:ln/>
-        </p:spPr>
-        <p:txBody>
-          <a:bodyPr wrap="square" rtlCol="0" anchor="ctr"/>
-          <a:lstStyle/>
-          <a:p>
-            <a:pPr indent="0" marL="0">
-              <a:buNone/>
-            </a:pPr>
-            <a:r>
-              <a:rPr lang="en-US" sz="1800" b="1" dirty="0">
-                <a:solidFill>
-                  <a:srgbClr val="10B981"/>
-                </a:solidFill>
-                <a:latin typeface="Arial" pitchFamily="34" charset="0"/>
-                <a:ea typeface="Arial" pitchFamily="34" charset="-122"/>
-                <a:cs typeface="Arial" pitchFamily="34" charset="-120"/>
-              </a:rPr>
-              <a:t>₹3-12 Cr</a:t>
-            </a:r>
-            <a:endParaRPr lang="en-US" sz="1800" dirty="0"/>
-          </a:p>
-        </p:txBody>
-      </p:sp>
-      <p:sp>
-        <p:nvSpPr>
-          <p:cNvPr id="11" name="Text 9"/>
-          <p:cNvSpPr/>
-          <p:nvPr/>
-        </p:nvSpPr>
-        <p:spPr>
-          <a:xfrm>
-            <a:off x="2724912" y="1005840"/>
-            <a:ext cx="1965960" cy="201168"/>
+            <a:off x="2679192" y="978408"/>
+            <a:ext cx="2011680" cy="182880"/>
           </a:xfrm>
           <a:prstGeom prst="rect">
             <a:avLst/>
@@ -1212,11 +1173,11 @@
                 <a:solidFill>
                   <a:srgbClr val="4B5563"/>
                 </a:solidFill>
-                <a:latin typeface="Arial" pitchFamily="34" charset="0"/>
-                <a:ea typeface="Arial" pitchFamily="34" charset="-122"/>
-                <a:cs typeface="Arial" pitchFamily="34" charset="-120"/>
-              </a:rPr>
-              <a:t>📈 Annual Interest Savings</a:t>
+                <a:latin typeface="Calibri" pitchFamily="34" charset="0"/>
+                <a:ea typeface="Calibri" pitchFamily="34" charset="-122"/>
+                <a:cs typeface="Calibri" pitchFamily="34" charset="-120"/>
+              </a:rPr>
+              <a:t>Annual Interest Savings</a:t>
             </a:r>
             <a:endParaRPr lang="en-US" sz="800" dirty="0"/>
           </a:p>
@@ -1224,26 +1185,26 @@
       </p:sp>
       <p:sp>
         <p:nvSpPr>
-          <p:cNvPr id="12" name="Shape 10"/>
-          <p:cNvSpPr/>
-          <p:nvPr/>
-        </p:nvSpPr>
-        <p:spPr>
-          <a:xfrm>
-            <a:off x="4901184" y="713232"/>
-            <a:ext cx="2148840" cy="548640"/>
+          <p:cNvPr id="11" name="Shape 9"/>
+          <p:cNvSpPr/>
+          <p:nvPr/>
+        </p:nvSpPr>
+        <p:spPr>
+          <a:xfrm>
+            <a:off x="4901184" y="685800"/>
+            <a:ext cx="2194560" cy="502920"/>
           </a:xfrm>
           <a:prstGeom prst="roundRect">
             <a:avLst>
-              <a:gd name="adj" fmla="val 6667"/>
+              <a:gd name="adj" fmla="val 5455"/>
             </a:avLst>
           </a:prstGeom>
           <a:solidFill>
-            <a:srgbClr val="FFFFFF"/>
-          </a:solidFill>
-          <a:ln w="19050">
+            <a:srgbClr val="FFFBEB"/>
+          </a:solidFill>
+          <a:ln w="12700">
             <a:solidFill>
-              <a:srgbClr val="D97706"/>
+              <a:srgbClr val="F59E0B"/>
             </a:solidFill>
             <a:prstDash val="solid"/>
           </a:ln>
@@ -1251,53 +1212,53 @@
       </p:sp>
       <p:sp>
         <p:nvSpPr>
+          <p:cNvPr id="12" name="Text 10"/>
+          <p:cNvSpPr/>
+          <p:nvPr/>
+        </p:nvSpPr>
+        <p:spPr>
+          <a:xfrm>
+            <a:off x="4992624" y="731520"/>
+            <a:ext cx="2011680" cy="256032"/>
+          </a:xfrm>
+          <a:prstGeom prst="rect">
+            <a:avLst/>
+          </a:prstGeom>
+          <a:noFill/>
+          <a:ln/>
+        </p:spPr>
+        <p:txBody>
+          <a:bodyPr wrap="square" rtlCol="0" anchor="ctr"/>
+          <a:lstStyle/>
+          <a:p>
+            <a:pPr indent="0" marL="0">
+              <a:buNone/>
+            </a:pPr>
+            <a:r>
+              <a:rPr lang="en-US" sz="1600" b="1" dirty="0">
+                <a:solidFill>
+                  <a:srgbClr val="B45309"/>
+                </a:solidFill>
+                <a:latin typeface="Calibri" pitchFamily="34" charset="0"/>
+                <a:ea typeface="Calibri" pitchFamily="34" charset="-122"/>
+                <a:cs typeface="Calibri" pitchFamily="34" charset="-120"/>
+              </a:rPr>
+              <a:t>Direct Access</a:t>
+            </a:r>
+            <a:endParaRPr lang="en-US" sz="1600" dirty="0"/>
+          </a:p>
+        </p:txBody>
+      </p:sp>
+      <p:sp>
+        <p:nvSpPr>
           <p:cNvPr id="13" name="Text 11"/>
           <p:cNvSpPr/>
           <p:nvPr/>
         </p:nvSpPr>
         <p:spPr>
           <a:xfrm>
-            <a:off x="4992624" y="768096"/>
-            <a:ext cx="1965960" cy="256032"/>
-          </a:xfrm>
-          <a:prstGeom prst="rect">
-            <a:avLst/>
-          </a:prstGeom>
-          <a:noFill/>
-          <a:ln/>
-        </p:spPr>
-        <p:txBody>
-          <a:bodyPr wrap="square" rtlCol="0" anchor="ctr"/>
-          <a:lstStyle/>
-          <a:p>
-            <a:pPr indent="0" marL="0">
-              <a:buNone/>
-            </a:pPr>
-            <a:r>
-              <a:rPr lang="en-US" sz="1800" b="1" dirty="0">
-                <a:solidFill>
-                  <a:srgbClr val="D97706"/>
-                </a:solidFill>
-                <a:latin typeface="Arial" pitchFamily="34" charset="0"/>
-                <a:ea typeface="Arial" pitchFamily="34" charset="-122"/>
-                <a:cs typeface="Arial" pitchFamily="34" charset="-120"/>
-              </a:rPr>
-              <a:t>Direct</a:t>
-            </a:r>
-            <a:endParaRPr lang="en-US" sz="1800" dirty="0"/>
-          </a:p>
-        </p:txBody>
-      </p:sp>
-      <p:sp>
-        <p:nvSpPr>
-          <p:cNvPr id="14" name="Text 12"/>
-          <p:cNvSpPr/>
-          <p:nvPr/>
-        </p:nvSpPr>
-        <p:spPr>
-          <a:xfrm>
-            <a:off x="4992624" y="1005840"/>
-            <a:ext cx="1965960" cy="201168"/>
+            <a:off x="4992624" y="978408"/>
+            <a:ext cx="2011680" cy="182880"/>
           </a:xfrm>
           <a:prstGeom prst="rect">
             <a:avLst/>
@@ -1317,11 +1278,11 @@
                 <a:solidFill>
                   <a:srgbClr val="4B5563"/>
                 </a:solidFill>
-                <a:latin typeface="Arial" pitchFamily="34" charset="0"/>
-                <a:ea typeface="Arial" pitchFamily="34" charset="-122"/>
-                <a:cs typeface="Arial" pitchFamily="34" charset="-120"/>
-              </a:rPr>
-              <a:t>🔓 No Bank Intermediary</a:t>
+                <a:latin typeface="Calibri" pitchFamily="34" charset="0"/>
+                <a:ea typeface="Calibri" pitchFamily="34" charset="-122"/>
+                <a:cs typeface="Calibri" pitchFamily="34" charset="-120"/>
+              </a:rPr>
+              <a:t>No Bank Intermediary</a:t>
             </a:r>
             <a:endParaRPr lang="en-US" sz="800" dirty="0"/>
           </a:p>
@@ -1329,26 +1290,26 @@
       </p:sp>
       <p:sp>
         <p:nvSpPr>
-          <p:cNvPr id="15" name="Shape 13"/>
-          <p:cNvSpPr/>
-          <p:nvPr/>
-        </p:nvSpPr>
-        <p:spPr>
-          <a:xfrm>
-            <a:off x="7168896" y="713232"/>
-            <a:ext cx="2148840" cy="548640"/>
+          <p:cNvPr id="14" name="Shape 12"/>
+          <p:cNvSpPr/>
+          <p:nvPr/>
+        </p:nvSpPr>
+        <p:spPr>
+          <a:xfrm>
+            <a:off x="7214616" y="685800"/>
+            <a:ext cx="2194560" cy="502920"/>
           </a:xfrm>
           <a:prstGeom prst="roundRect">
             <a:avLst>
-              <a:gd name="adj" fmla="val 6667"/>
+              <a:gd name="adj" fmla="val 5455"/>
             </a:avLst>
           </a:prstGeom>
           <a:solidFill>
-            <a:srgbClr val="FFFFFF"/>
-          </a:solidFill>
-          <a:ln w="19050">
+            <a:srgbClr val="EFF6FF"/>
+          </a:solidFill>
+          <a:ln w="12700">
             <a:solidFill>
-              <a:srgbClr val="1E2761"/>
+              <a:srgbClr val="2563EB"/>
             </a:solidFill>
             <a:prstDash val="solid"/>
           </a:ln>
@@ -1356,53 +1317,53 @@
       </p:sp>
       <p:sp>
         <p:nvSpPr>
+          <p:cNvPr id="15" name="Text 13"/>
+          <p:cNvSpPr/>
+          <p:nvPr/>
+        </p:nvSpPr>
+        <p:spPr>
+          <a:xfrm>
+            <a:off x="7306056" y="731520"/>
+            <a:ext cx="2011680" cy="256032"/>
+          </a:xfrm>
+          <a:prstGeom prst="rect">
+            <a:avLst/>
+          </a:prstGeom>
+          <a:noFill/>
+          <a:ln/>
+        </p:spPr>
+        <p:txBody>
+          <a:bodyPr wrap="square" rtlCol="0" anchor="ctr"/>
+          <a:lstStyle/>
+          <a:p>
+            <a:pPr indent="0" marL="0">
+              <a:buNone/>
+            </a:pPr>
+            <a:r>
+              <a:rPr lang="en-US" sz="1600" b="1" dirty="0">
+                <a:solidFill>
+                  <a:srgbClr val="1E40AF"/>
+                </a:solidFill>
+                <a:latin typeface="Calibri" pitchFamily="34" charset="0"/>
+                <a:ea typeface="Calibri" pitchFamily="34" charset="-122"/>
+                <a:cs typeface="Calibri" pitchFamily="34" charset="-120"/>
+              </a:rPr>
+              <a:t>10-15%</a:t>
+            </a:r>
+            <a:endParaRPr lang="en-US" sz="1600" dirty="0"/>
+          </a:p>
+        </p:txBody>
+      </p:sp>
+      <p:sp>
+        <p:nvSpPr>
           <p:cNvPr id="16" name="Text 14"/>
           <p:cNvSpPr/>
           <p:nvPr/>
         </p:nvSpPr>
         <p:spPr>
           <a:xfrm>
-            <a:off x="7260336" y="768096"/>
-            <a:ext cx="1965960" cy="256032"/>
-          </a:xfrm>
-          <a:prstGeom prst="rect">
-            <a:avLst/>
-          </a:prstGeom>
-          <a:noFill/>
-          <a:ln/>
-        </p:spPr>
-        <p:txBody>
-          <a:bodyPr wrap="square" rtlCol="0" anchor="ctr"/>
-          <a:lstStyle/>
-          <a:p>
-            <a:pPr indent="0" marL="0">
-              <a:buNone/>
-            </a:pPr>
-            <a:r>
-              <a:rPr lang="en-US" sz="1800" b="1" dirty="0">
-                <a:solidFill>
-                  <a:srgbClr val="1E2761"/>
-                </a:solidFill>
-                <a:latin typeface="Arial" pitchFamily="34" charset="0"/>
-                <a:ea typeface="Arial" pitchFamily="34" charset="-122"/>
-                <a:cs typeface="Arial" pitchFamily="34" charset="-120"/>
-              </a:rPr>
-              <a:t>10-15%</a:t>
-            </a:r>
-            <a:endParaRPr lang="en-US" sz="1800" dirty="0"/>
-          </a:p>
-        </p:txBody>
-      </p:sp>
-      <p:sp>
-        <p:nvSpPr>
-          <p:cNvPr id="17" name="Text 15"/>
-          <p:cNvSpPr/>
-          <p:nvPr/>
-        </p:nvSpPr>
-        <p:spPr>
-          <a:xfrm>
-            <a:off x="7260336" y="1005840"/>
-            <a:ext cx="1965960" cy="201168"/>
+            <a:off x="7306056" y="978408"/>
+            <a:ext cx="2011680" cy="182880"/>
           </a:xfrm>
           <a:prstGeom prst="rect">
             <a:avLst/>
@@ -1422,11 +1383,11 @@
                 <a:solidFill>
                   <a:srgbClr val="4B5563"/>
                 </a:solidFill>
-                <a:latin typeface="Arial" pitchFamily="34" charset="0"/>
-                <a:ea typeface="Arial" pitchFamily="34" charset="-122"/>
-                <a:cs typeface="Arial" pitchFamily="34" charset="-120"/>
-              </a:rPr>
-              <a:t>🎯 Target Funding Mix</a:t>
+                <a:latin typeface="Calibri" pitchFamily="34" charset="0"/>
+                <a:ea typeface="Calibri" pitchFamily="34" charset="-122"/>
+                <a:cs typeface="Calibri" pitchFamily="34" charset="-120"/>
+              </a:rPr>
+              <a:t>Target Funding Mix</a:t>
             </a:r>
             <a:endParaRPr lang="en-US" sz="800" dirty="0"/>
           </a:p>
@@ -1434,18 +1395,18 @@
       </p:sp>
       <p:sp>
         <p:nvSpPr>
-          <p:cNvPr id="18" name="Shape 16"/>
-          <p:cNvSpPr/>
-          <p:nvPr/>
-        </p:nvSpPr>
-        <p:spPr>
-          <a:xfrm>
-            <a:off x="365760" y="1353312"/>
-            <a:ext cx="4434840" cy="1371600"/>
+          <p:cNvPr id="17" name="Shape 15"/>
+          <p:cNvSpPr/>
+          <p:nvPr/>
+        </p:nvSpPr>
+        <p:spPr>
+          <a:xfrm>
+            <a:off x="274320" y="1325880"/>
+            <a:ext cx="4389120" cy="1234440"/>
           </a:xfrm>
           <a:prstGeom prst="roundRect">
             <a:avLst>
-              <a:gd name="adj" fmla="val 2667"/>
+              <a:gd name="adj" fmla="val 2963"/>
             </a:avLst>
           </a:prstGeom>
           <a:solidFill>
@@ -1461,23 +1422,62 @@
       </p:sp>
       <p:sp>
         <p:nvSpPr>
-          <p:cNvPr id="19" name="Shape 17"/>
+          <p:cNvPr id="18" name="Shape 16"/>
+          <p:cNvSpPr/>
+          <p:nvPr/>
+        </p:nvSpPr>
+        <p:spPr>
+          <a:xfrm>
+            <a:off x="274320" y="1325880"/>
+            <a:ext cx="4389120" cy="228600"/>
+          </a:xfrm>
+          <a:prstGeom prst="rect">
+            <a:avLst/>
+          </a:prstGeom>
+          <a:solidFill>
+            <a:srgbClr val="DC2626"/>
+          </a:solidFill>
+          <a:ln/>
+        </p:spPr>
+      </p:sp>
+      <p:sp>
+        <p:nvSpPr>
+          <p:cNvPr id="19" name="Text 17"/>
           <p:cNvSpPr/>
           <p:nvPr/>
         </p:nvSpPr>
         <p:spPr>
           <a:xfrm>
             <a:off x="365760" y="1353312"/>
-            <a:ext cx="4434840" cy="256032"/>
-          </a:xfrm>
-          <a:prstGeom prst="rect">
-            <a:avLst/>
-          </a:prstGeom>
-          <a:solidFill>
-            <a:srgbClr val="DC2626"/>
-          </a:solidFill>
-          <a:ln/>
-        </p:spPr>
+            <a:ext cx="4206240" cy="182880"/>
+          </a:xfrm>
+          <a:prstGeom prst="rect">
+            <a:avLst/>
+          </a:prstGeom>
+          <a:noFill/>
+          <a:ln/>
+        </p:spPr>
+        <p:txBody>
+          <a:bodyPr wrap="square" rtlCol="0" anchor="ctr"/>
+          <a:lstStyle/>
+          <a:p>
+            <a:pPr indent="0" marL="0">
+              <a:buNone/>
+            </a:pPr>
+            <a:r>
+              <a:rPr lang="en-US" sz="1000" b="1" dirty="0">
+                <a:solidFill>
+                  <a:srgbClr val="FFFFFF"/>
+                </a:solidFill>
+                <a:latin typeface="Calibri" pitchFamily="34" charset="0"/>
+                <a:ea typeface="Calibri" pitchFamily="34" charset="-122"/>
+                <a:cs typeface="Calibri" pitchFamily="34" charset="-120"/>
+              </a:rPr>
+              <a:t>❌ PRE-EXPANSION (Before Apr 9, 2026)</a:t>
+            </a:r>
+            <a:endParaRPr lang="en-US" sz="1000" dirty="0"/>
+          </a:p>
+        </p:txBody>
       </p:sp>
       <p:sp>
         <p:nvSpPr>
@@ -1487,47 +1487,8 @@
         </p:nvSpPr>
         <p:spPr>
           <a:xfrm>
-            <a:off x="457200" y="1389888"/>
-            <a:ext cx="4251960" cy="182880"/>
-          </a:xfrm>
-          <a:prstGeom prst="rect">
-            <a:avLst/>
-          </a:prstGeom>
-          <a:noFill/>
-          <a:ln/>
-        </p:spPr>
-        <p:txBody>
-          <a:bodyPr wrap="square" rtlCol="0" anchor="ctr"/>
-          <a:lstStyle/>
-          <a:p>
-            <a:pPr indent="0" marL="0">
-              <a:buNone/>
-            </a:pPr>
-            <a:r>
-              <a:rPr lang="en-US" sz="1000" b="1" dirty="0">
-                <a:solidFill>
-                  <a:srgbClr val="FFFFFF"/>
-                </a:solidFill>
-                <a:latin typeface="Arial" pitchFamily="34" charset="0"/>
-                <a:ea typeface="Arial" pitchFamily="34" charset="-122"/>
-                <a:cs typeface="Arial" pitchFamily="34" charset="-120"/>
-              </a:rPr>
-              <a:t>❌ PRE-EXPANSION</a:t>
-            </a:r>
-            <a:endParaRPr lang="en-US" sz="1000" dirty="0"/>
-          </a:p>
-        </p:txBody>
-      </p:sp>
-      <p:sp>
-        <p:nvSpPr>
-          <p:cNvPr id="21" name="Text 19"/>
-          <p:cNvSpPr/>
-          <p:nvPr/>
-        </p:nvSpPr>
-        <p:spPr>
-          <a:xfrm>
-            <a:off x="457200" y="1664208"/>
-            <a:ext cx="4251960" cy="1005840"/>
+            <a:off x="365760" y="1618488"/>
+            <a:ext cx="4206240" cy="868680"/>
           </a:xfrm>
           <a:prstGeom prst="rect">
             <a:avLst/>
@@ -1541,7 +1502,7 @@
           <a:p>
             <a:pPr indent="0" marL="0">
               <a:lnSpc>
-                <a:spcPts val="1300"/>
+                <a:spcPts val="1200"/>
               </a:lnSpc>
               <a:buNone/>
             </a:pPr>
@@ -1550,18 +1511,18 @@
                 <a:solidFill>
                   <a:srgbClr val="7F1D1D"/>
                 </a:solidFill>
-                <a:latin typeface="Arial" pitchFamily="34" charset="0"/>
-                <a:ea typeface="Arial" pitchFamily="34" charset="-122"/>
-                <a:cs typeface="Arial" pitchFamily="34" charset="-120"/>
-              </a:rPr>
-              <a:t>• Term money restricted to banks &amp; PDs</a:t>
+                <a:latin typeface="Calibri" pitchFamily="34" charset="0"/>
+                <a:ea typeface="Calibri" pitchFamily="34" charset="-122"/>
+                <a:cs typeface="Calibri" pitchFamily="34" charset="-120"/>
+              </a:rPr>
+              <a:t>• Term money restricted to banks &amp; PDs only</a:t>
             </a:r>
             <a:endParaRPr lang="en-US" sz="900" dirty="0"/>
           </a:p>
           <a:p>
             <a:pPr indent="0" marL="0">
               <a:lnSpc>
-                <a:spcPts val="1300"/>
+                <a:spcPts val="1200"/>
               </a:lnSpc>
               <a:buNone/>
             </a:pPr>
@@ -1570,9 +1531,9 @@
                 <a:solidFill>
                   <a:srgbClr val="7F1D1D"/>
                 </a:solidFill>
-                <a:latin typeface="Arial" pitchFamily="34" charset="0"/>
-                <a:ea typeface="Arial" pitchFamily="34" charset="-122"/>
-                <a:cs typeface="Arial" pitchFamily="34" charset="-120"/>
+                <a:latin typeface="Calibri" pitchFamily="34" charset="0"/>
+                <a:ea typeface="Calibri" pitchFamily="34" charset="-122"/>
+                <a:cs typeface="Calibri" pitchFamily="34" charset="-120"/>
               </a:rPr>
               <a:t>• NBFCs dependent on bank intermediation</a:t>
             </a:r>
@@ -1581,7 +1542,7 @@
           <a:p>
             <a:pPr indent="0" marL="0">
               <a:lnSpc>
-                <a:spcPts val="1300"/>
+                <a:spcPts val="1200"/>
               </a:lnSpc>
               <a:buNone/>
             </a:pPr>
@@ -1590,9 +1551,9 @@
                 <a:solidFill>
                   <a:srgbClr val="7F1D1D"/>
                 </a:solidFill>
-                <a:latin typeface="Arial" pitchFamily="34" charset="0"/>
-                <a:ea typeface="Arial" pitchFamily="34" charset="-122"/>
-                <a:cs typeface="Arial" pitchFamily="34" charset="-120"/>
+                <a:latin typeface="Calibri" pitchFamily="34" charset="0"/>
+                <a:ea typeface="Calibri" pitchFamily="34" charset="-122"/>
+                <a:cs typeface="Calibri" pitchFamily="34" charset="-120"/>
               </a:rPr>
               <a:t>• Limited 6M-1Y price transparency</a:t>
             </a:r>
@@ -1601,7 +1562,7 @@
           <a:p>
             <a:pPr indent="0" marL="0">
               <a:lnSpc>
-                <a:spcPts val="1300"/>
+                <a:spcPts val="1200"/>
               </a:lnSpc>
               <a:buNone/>
             </a:pPr>
@@ -1610,254 +1571,26 @@
                 <a:solidFill>
                   <a:srgbClr val="7F1D1D"/>
                 </a:solidFill>
-                <a:latin typeface="Arial" pitchFamily="34" charset="0"/>
-                <a:ea typeface="Arial" pitchFamily="34" charset="-122"/>
-                <a:cs typeface="Arial" pitchFamily="34" charset="-120"/>
-              </a:rPr>
-              <a:t>• ALM gaps from tenor mismatches</a:t>
+                <a:latin typeface="Calibri" pitchFamily="34" charset="0"/>
+                <a:ea typeface="Calibri" pitchFamily="34" charset="-122"/>
+                <a:cs typeface="Calibri" pitchFamily="34" charset="-120"/>
+              </a:rPr>
+              <a:t>• Bank funding concentration: 70-75%</a:t>
             </a:r>
             <a:endParaRPr lang="en-US" sz="900" dirty="0"/>
           </a:p>
-          <a:p>
-            <a:pPr indent="0" marL="0">
-              <a:lnSpc>
-                <a:spcPts val="1300"/>
-              </a:lnSpc>
-              <a:buNone/>
-            </a:pPr>
-            <a:r>
-              <a:rPr lang="en-US" sz="900" dirty="0">
-                <a:solidFill>
-                  <a:srgbClr val="7F1D1D"/>
-                </a:solidFill>
-                <a:latin typeface="Arial" pitchFamily="34" charset="0"/>
-                <a:ea typeface="Arial" pitchFamily="34" charset="-122"/>
-                <a:cs typeface="Arial" pitchFamily="34" charset="-120"/>
-              </a:rPr>
-              <a:t>• Bank funding concentration (70-75%)</a:t>
-            </a:r>
-            <a:endParaRPr lang="en-US" sz="900" dirty="0"/>
-          </a:p>
-        </p:txBody>
-      </p:sp>
-      <p:sp>
-        <p:nvSpPr>
-          <p:cNvPr id="22" name="Shape 20"/>
-          <p:cNvSpPr/>
-          <p:nvPr/>
-        </p:nvSpPr>
-        <p:spPr>
-          <a:xfrm>
-            <a:off x="4983480" y="1353312"/>
-            <a:ext cx="4434840" cy="1371600"/>
-          </a:xfrm>
-          <a:prstGeom prst="roundRect">
-            <a:avLst>
-              <a:gd name="adj" fmla="val 2667"/>
-            </a:avLst>
-          </a:prstGeom>
-          <a:solidFill>
-            <a:srgbClr val="F0FDF4"/>
-          </a:solidFill>
-          <a:ln w="19050">
-            <a:solidFill>
-              <a:srgbClr val="16A34A"/>
-            </a:solidFill>
-            <a:prstDash val="solid"/>
-          </a:ln>
-        </p:spPr>
-      </p:sp>
-      <p:sp>
-        <p:nvSpPr>
-          <p:cNvPr id="23" name="Shape 21"/>
-          <p:cNvSpPr/>
-          <p:nvPr/>
-        </p:nvSpPr>
-        <p:spPr>
-          <a:xfrm>
-            <a:off x="4983480" y="1353312"/>
-            <a:ext cx="4434840" cy="256032"/>
-          </a:xfrm>
-          <a:prstGeom prst="rect">
-            <a:avLst/>
-          </a:prstGeom>
-          <a:solidFill>
-            <a:srgbClr val="16A34A"/>
-          </a:solidFill>
-          <a:ln/>
-        </p:spPr>
-      </p:sp>
-      <p:sp>
-        <p:nvSpPr>
-          <p:cNvPr id="24" name="Text 22"/>
-          <p:cNvSpPr/>
-          <p:nvPr/>
-        </p:nvSpPr>
-        <p:spPr>
-          <a:xfrm>
-            <a:off x="5074920" y="1389888"/>
-            <a:ext cx="4251960" cy="182880"/>
-          </a:xfrm>
-          <a:prstGeom prst="rect">
-            <a:avLst/>
-          </a:prstGeom>
-          <a:noFill/>
-          <a:ln/>
-        </p:spPr>
-        <p:txBody>
-          <a:bodyPr wrap="square" rtlCol="0" anchor="ctr"/>
-          <a:lstStyle/>
-          <a:p>
-            <a:pPr indent="0" marL="0">
-              <a:buNone/>
-            </a:pPr>
-            <a:r>
-              <a:rPr lang="en-US" sz="1000" b="1" dirty="0">
-                <a:solidFill>
-                  <a:srgbClr val="FFFFFF"/>
-                </a:solidFill>
-                <a:latin typeface="Arial" pitchFamily="34" charset="0"/>
-                <a:ea typeface="Arial" pitchFamily="34" charset="-122"/>
-                <a:cs typeface="Arial" pitchFamily="34" charset="-120"/>
-              </a:rPr>
-              <a:t>✅ POST-EXPANSION</a:t>
-            </a:r>
-            <a:endParaRPr lang="en-US" sz="1000" dirty="0"/>
-          </a:p>
-        </p:txBody>
-      </p:sp>
-      <p:sp>
-        <p:nvSpPr>
-          <p:cNvPr id="25" name="Text 23"/>
-          <p:cNvSpPr/>
-          <p:nvPr/>
-        </p:nvSpPr>
-        <p:spPr>
-          <a:xfrm>
-            <a:off x="5074920" y="1664208"/>
-            <a:ext cx="4251960" cy="1005840"/>
-          </a:xfrm>
-          <a:prstGeom prst="rect">
-            <a:avLst/>
-          </a:prstGeom>
-          <a:noFill/>
-          <a:ln/>
-        </p:spPr>
-        <p:txBody>
-          <a:bodyPr wrap="square" rtlCol="0" anchor="ctr"/>
-          <a:lstStyle/>
-          <a:p>
-            <a:pPr indent="0" marL="0">
-              <a:lnSpc>
-                <a:spcPts val="1300"/>
-              </a:lnSpc>
-              <a:buNone/>
-            </a:pPr>
-            <a:r>
-              <a:rPr lang="en-US" sz="900" dirty="0">
-                <a:solidFill>
-                  <a:srgbClr val="14532D"/>
-                </a:solidFill>
-                <a:latin typeface="Arial" pitchFamily="34" charset="0"/>
-                <a:ea typeface="Arial" pitchFamily="34" charset="-122"/>
-                <a:cs typeface="Arial" pitchFamily="34" charset="-120"/>
-              </a:rPr>
-              <a:t>• Direct NBFC participation in term market</a:t>
-            </a:r>
-            <a:endParaRPr lang="en-US" sz="900" dirty="0"/>
-          </a:p>
-          <a:p>
-            <a:pPr indent="0" marL="0">
-              <a:lnSpc>
-                <a:spcPts val="1300"/>
-              </a:lnSpc>
-              <a:buNone/>
-            </a:pPr>
-            <a:r>
-              <a:rPr lang="en-US" sz="900" dirty="0">
-                <a:solidFill>
-                  <a:srgbClr val="14532D"/>
-                </a:solidFill>
-                <a:latin typeface="Arial" pitchFamily="34" charset="0"/>
-                <a:ea typeface="Arial" pitchFamily="34" charset="-122"/>
-                <a:cs typeface="Arial" pitchFamily="34" charset="-120"/>
-              </a:rPr>
-              <a:t>• Reduced bank costs (15-40 bps savings)</a:t>
-            </a:r>
-            <a:endParaRPr lang="en-US" sz="900" dirty="0"/>
-          </a:p>
-          <a:p>
-            <a:pPr indent="0" marL="0">
-              <a:lnSpc>
-                <a:spcPts val="1300"/>
-              </a:lnSpc>
-              <a:buNone/>
-            </a:pPr>
-            <a:r>
-              <a:rPr lang="en-US" sz="900" dirty="0">
-                <a:solidFill>
-                  <a:srgbClr val="14532D"/>
-                </a:solidFill>
-                <a:latin typeface="Arial" pitchFamily="34" charset="0"/>
-                <a:ea typeface="Arial" pitchFamily="34" charset="-122"/>
-                <a:cs typeface="Arial" pitchFamily="34" charset="-120"/>
-              </a:rPr>
-              <a:t>• Market-driven rates (MIBOR-linked)</a:t>
-            </a:r>
-            <a:endParaRPr lang="en-US" sz="900" dirty="0"/>
-          </a:p>
-          <a:p>
-            <a:pPr indent="0" marL="0">
-              <a:lnSpc>
-                <a:spcPts val="1300"/>
-              </a:lnSpc>
-              <a:buNone/>
-            </a:pPr>
-            <a:r>
-              <a:rPr lang="en-US" sz="900" dirty="0">
-                <a:solidFill>
-                  <a:srgbClr val="14532D"/>
-                </a:solidFill>
-                <a:latin typeface="Arial" pitchFamily="34" charset="0"/>
-                <a:ea typeface="Arial" pitchFamily="34" charset="-122"/>
-                <a:cs typeface="Arial" pitchFamily="34" charset="-120"/>
-              </a:rPr>
-              <a:t>• Flexible tenor: 14D to 1Y for ALM</a:t>
-            </a:r>
-            <a:endParaRPr lang="en-US" sz="900" dirty="0"/>
-          </a:p>
-          <a:p>
-            <a:pPr indent="0" marL="0">
-              <a:lnSpc>
-                <a:spcPts val="1300"/>
-              </a:lnSpc>
-              <a:buNone/>
-            </a:pPr>
-            <a:r>
-              <a:rPr lang="en-US" sz="900" dirty="0">
-                <a:solidFill>
-                  <a:srgbClr val="14532D"/>
-                </a:solidFill>
-                <a:latin typeface="Arial" pitchFamily="34" charset="0"/>
-                <a:ea typeface="Arial" pitchFamily="34" charset="-122"/>
-                <a:cs typeface="Arial" pitchFamily="34" charset="-120"/>
-              </a:rPr>
-              <a:t>• Diversified funding (target 60-65% bank)</a:t>
-            </a:r>
-            <a:endParaRPr lang="en-US" sz="900" dirty="0"/>
-          </a:p>
-        </p:txBody>
-      </p:sp>
-      <p:sp>
-        <p:nvSpPr>
-          <p:cNvPr id="26" name="Shape 24"/>
-          <p:cNvSpPr/>
-          <p:nvPr/>
-        </p:nvSpPr>
-        <p:spPr>
-          <a:xfrm>
-            <a:off x="365760" y="2834640"/>
-            <a:ext cx="4754880" cy="1234440"/>
+        </p:txBody>
+      </p:sp>
+      <p:sp>
+        <p:nvSpPr>
+          <p:cNvPr id="21" name="Shape 19"/>
+          <p:cNvSpPr/>
+          <p:nvPr/>
+        </p:nvSpPr>
+        <p:spPr>
+          <a:xfrm>
+            <a:off x="4846320" y="1325880"/>
+            <a:ext cx="4389120" cy="1234440"/>
           </a:xfrm>
           <a:prstGeom prst="roundRect">
             <a:avLst>
@@ -1865,11 +1598,11 @@
             </a:avLst>
           </a:prstGeom>
           <a:solidFill>
-            <a:srgbClr val="FFFFFF"/>
-          </a:solidFill>
-          <a:ln w="12700">
+            <a:srgbClr val="F0FDF4"/>
+          </a:solidFill>
+          <a:ln w="19050">
             <a:solidFill>
-              <a:srgbClr val="1E2761"/>
+              <a:srgbClr val="059669"/>
             </a:solidFill>
             <a:prstDash val="solid"/>
           </a:ln>
@@ -1877,73 +1610,73 @@
       </p:sp>
       <p:sp>
         <p:nvSpPr>
-          <p:cNvPr id="27" name="Shape 25"/>
-          <p:cNvSpPr/>
-          <p:nvPr/>
-        </p:nvSpPr>
-        <p:spPr>
-          <a:xfrm>
-            <a:off x="365760" y="2834640"/>
-            <a:ext cx="4754880" cy="237744"/>
-          </a:xfrm>
-          <a:prstGeom prst="rect">
-            <a:avLst/>
-          </a:prstGeom>
-          <a:solidFill>
-            <a:srgbClr val="1E2761"/>
-          </a:solidFill>
-          <a:ln/>
-        </p:spPr>
-      </p:sp>
-      <p:sp>
-        <p:nvSpPr>
-          <p:cNvPr id="28" name="Text 26"/>
-          <p:cNvSpPr/>
-          <p:nvPr/>
-        </p:nvSpPr>
-        <p:spPr>
-          <a:xfrm>
-            <a:off x="457200" y="2871216"/>
-            <a:ext cx="4572000" cy="164592"/>
-          </a:xfrm>
-          <a:prstGeom prst="rect">
-            <a:avLst/>
-          </a:prstGeom>
-          <a:noFill/>
-          <a:ln/>
-        </p:spPr>
-        <p:txBody>
-          <a:bodyPr wrap="square" rtlCol="0" anchor="ctr"/>
-          <a:lstStyle/>
-          <a:p>
-            <a:pPr indent="0" marL="0">
-              <a:buNone/>
-            </a:pPr>
-            <a:r>
-              <a:rPr lang="en-US" sz="1100" b="1" dirty="0">
+          <p:cNvPr id="22" name="Shape 20"/>
+          <p:cNvSpPr/>
+          <p:nvPr/>
+        </p:nvSpPr>
+        <p:spPr>
+          <a:xfrm>
+            <a:off x="4846320" y="1325880"/>
+            <a:ext cx="4389120" cy="228600"/>
+          </a:xfrm>
+          <a:prstGeom prst="rect">
+            <a:avLst/>
+          </a:prstGeom>
+          <a:solidFill>
+            <a:srgbClr val="059669"/>
+          </a:solidFill>
+          <a:ln/>
+        </p:spPr>
+      </p:sp>
+      <p:sp>
+        <p:nvSpPr>
+          <p:cNvPr id="23" name="Text 21"/>
+          <p:cNvSpPr/>
+          <p:nvPr/>
+        </p:nvSpPr>
+        <p:spPr>
+          <a:xfrm>
+            <a:off x="4937760" y="1353312"/>
+            <a:ext cx="4206240" cy="182880"/>
+          </a:xfrm>
+          <a:prstGeom prst="rect">
+            <a:avLst/>
+          </a:prstGeom>
+          <a:noFill/>
+          <a:ln/>
+        </p:spPr>
+        <p:txBody>
+          <a:bodyPr wrap="square" rtlCol="0" anchor="ctr"/>
+          <a:lstStyle/>
+          <a:p>
+            <a:pPr indent="0" marL="0">
+              <a:buNone/>
+            </a:pPr>
+            <a:r>
+              <a:rPr lang="en-US" sz="1000" b="1" dirty="0">
                 <a:solidFill>
                   <a:srgbClr val="FFFFFF"/>
                 </a:solidFill>
-                <a:latin typeface="Arial" pitchFamily="34" charset="0"/>
-                <a:ea typeface="Arial" pitchFamily="34" charset="-122"/>
-                <a:cs typeface="Arial" pitchFamily="34" charset="-120"/>
-              </a:rPr>
-              <a:t>🎯 Strategic Benefits</a:t>
-            </a:r>
-            <a:endParaRPr lang="en-US" sz="1100" dirty="0"/>
-          </a:p>
-        </p:txBody>
-      </p:sp>
-      <p:sp>
-        <p:nvSpPr>
-          <p:cNvPr id="29" name="Text 27"/>
-          <p:cNvSpPr/>
-          <p:nvPr/>
-        </p:nvSpPr>
-        <p:spPr>
-          <a:xfrm>
-            <a:off x="548640" y="3154680"/>
-            <a:ext cx="2011680" cy="411480"/>
+                <a:latin typeface="Calibri" pitchFamily="34" charset="0"/>
+                <a:ea typeface="Calibri" pitchFamily="34" charset="-122"/>
+                <a:cs typeface="Calibri" pitchFamily="34" charset="-120"/>
+              </a:rPr>
+              <a:t>✅ POST-EXPANSION (After Apr 9, 2026)</a:t>
+            </a:r>
+            <a:endParaRPr lang="en-US" sz="1000" dirty="0"/>
+          </a:p>
+        </p:txBody>
+      </p:sp>
+      <p:sp>
+        <p:nvSpPr>
+          <p:cNvPr id="24" name="Text 22"/>
+          <p:cNvSpPr/>
+          <p:nvPr/>
+        </p:nvSpPr>
+        <p:spPr>
+          <a:xfrm>
+            <a:off x="4937760" y="1618488"/>
+            <a:ext cx="4206240" cy="868680"/>
           </a:xfrm>
           <a:prstGeom prst="rect">
             <a:avLst/>
@@ -1957,253 +1690,107 @@
           <a:p>
             <a:pPr indent="0" marL="0">
               <a:lnSpc>
-                <a:spcPts val="1100"/>
+                <a:spcPts val="1200"/>
               </a:lnSpc>
               <a:buNone/>
             </a:pPr>
             <a:r>
-              <a:rPr lang="en-US" sz="800" dirty="0">
-                <a:solidFill>
-                  <a:srgbClr val="1E2761"/>
-                </a:solidFill>
-                <a:latin typeface="Arial" pitchFamily="34" charset="0"/>
-                <a:ea typeface="Arial" pitchFamily="34" charset="-122"/>
-                <a:cs typeface="Arial" pitchFamily="34" charset="-120"/>
-              </a:rPr>
-              <a:t>📊 ALM Optimization</a:t>
-            </a:r>
-            <a:endParaRPr lang="en-US" sz="800" dirty="0"/>
+              <a:rPr lang="en-US" sz="900" dirty="0">
+                <a:solidFill>
+                  <a:srgbClr val="14532D"/>
+                </a:solidFill>
+                <a:latin typeface="Calibri" pitchFamily="34" charset="0"/>
+                <a:ea typeface="Calibri" pitchFamily="34" charset="-122"/>
+                <a:cs typeface="Calibri" pitchFamily="34" charset="-120"/>
+              </a:rPr>
+              <a:t>• Direct NBFC participation in term market</a:t>
+            </a:r>
+            <a:endParaRPr lang="en-US" sz="900" dirty="0"/>
           </a:p>
           <a:p>
             <a:pPr indent="0" marL="0">
               <a:lnSpc>
-                <a:spcPts val="1100"/>
+                <a:spcPts val="1200"/>
               </a:lnSpc>
               <a:buNone/>
             </a:pPr>
             <a:r>
-              <a:rPr lang="en-US" sz="800" dirty="0">
-                <a:solidFill>
-                  <a:srgbClr val="1E2761"/>
-                </a:solidFill>
-                <a:latin typeface="Arial" pitchFamily="34" charset="0"/>
-                <a:ea typeface="Arial" pitchFamily="34" charset="-122"/>
-                <a:cs typeface="Arial" pitchFamily="34" charset="-120"/>
-              </a:rPr>
-              <a:t>Granular tenor for 2W/3W portfolios</a:t>
-            </a:r>
-            <a:endParaRPr lang="en-US" sz="800" dirty="0"/>
-          </a:p>
-        </p:txBody>
-      </p:sp>
-      <p:sp>
-        <p:nvSpPr>
-          <p:cNvPr id="30" name="Text 28"/>
-          <p:cNvSpPr/>
-          <p:nvPr/>
-        </p:nvSpPr>
-        <p:spPr>
-          <a:xfrm>
-            <a:off x="2743200" y="3154680"/>
-            <a:ext cx="2194560" cy="411480"/>
-          </a:xfrm>
-          <a:prstGeom prst="rect">
-            <a:avLst/>
-          </a:prstGeom>
-          <a:noFill/>
-          <a:ln/>
-        </p:spPr>
-        <p:txBody>
-          <a:bodyPr wrap="square" rtlCol="0" anchor="ctr"/>
-          <a:lstStyle/>
+              <a:rPr lang="en-US" sz="900" dirty="0">
+                <a:solidFill>
+                  <a:srgbClr val="14532D"/>
+                </a:solidFill>
+                <a:latin typeface="Calibri" pitchFamily="34" charset="0"/>
+                <a:ea typeface="Calibri" pitchFamily="34" charset="-122"/>
+                <a:cs typeface="Calibri" pitchFamily="34" charset="-120"/>
+              </a:rPr>
+              <a:t>• 15-40 bps savings via market-driven rates</a:t>
+            </a:r>
+            <a:endParaRPr lang="en-US" sz="900" dirty="0"/>
+          </a:p>
           <a:p>
             <a:pPr indent="0" marL="0">
               <a:lnSpc>
-                <a:spcPts val="1100"/>
+                <a:spcPts val="1200"/>
               </a:lnSpc>
               <a:buNone/>
             </a:pPr>
             <a:r>
-              <a:rPr lang="en-US" sz="800" dirty="0">
-                <a:solidFill>
-                  <a:srgbClr val="1E2761"/>
-                </a:solidFill>
-                <a:latin typeface="Arial" pitchFamily="34" charset="0"/>
-                <a:ea typeface="Arial" pitchFamily="34" charset="-122"/>
-                <a:cs typeface="Arial" pitchFamily="34" charset="-120"/>
-              </a:rPr>
-              <a:t>⚡ Liquidity Buffer</a:t>
-            </a:r>
-            <a:endParaRPr lang="en-US" sz="800" dirty="0"/>
+              <a:rPr lang="en-US" sz="900" dirty="0">
+                <a:solidFill>
+                  <a:srgbClr val="14532D"/>
+                </a:solidFill>
+                <a:latin typeface="Calibri" pitchFamily="34" charset="0"/>
+                <a:ea typeface="Calibri" pitchFamily="34" charset="-122"/>
+                <a:cs typeface="Calibri" pitchFamily="34" charset="-120"/>
+              </a:rPr>
+              <a:t>• Flexible tenor: 14D to 1Y for ALM</a:t>
+            </a:r>
+            <a:endParaRPr lang="en-US" sz="900" dirty="0"/>
           </a:p>
           <a:p>
             <a:pPr indent="0" marL="0">
               <a:lnSpc>
-                <a:spcPts val="1100"/>
+                <a:spcPts val="1200"/>
               </a:lnSpc>
               <a:buNone/>
             </a:pPr>
             <a:r>
-              <a:rPr lang="en-US" sz="800" dirty="0">
-                <a:solidFill>
-                  <a:srgbClr val="1E2761"/>
-                </a:solidFill>
-                <a:latin typeface="Arial" pitchFamily="34" charset="0"/>
-                <a:ea typeface="Arial" pitchFamily="34" charset="-122"/>
-                <a:cs typeface="Arial" pitchFamily="34" charset="-120"/>
-              </a:rPr>
-              <a:t>LCR source without bank dependence</a:t>
-            </a:r>
-            <a:endParaRPr lang="en-US" sz="800" dirty="0"/>
-          </a:p>
-        </p:txBody>
-      </p:sp>
-      <p:sp>
-        <p:nvSpPr>
-          <p:cNvPr id="31" name="Text 29"/>
-          <p:cNvSpPr/>
-          <p:nvPr/>
-        </p:nvSpPr>
-        <p:spPr>
-          <a:xfrm>
-            <a:off x="548640" y="3611880"/>
-            <a:ext cx="2011680" cy="411480"/>
-          </a:xfrm>
-          <a:prstGeom prst="rect">
-            <a:avLst/>
-          </a:prstGeom>
-          <a:noFill/>
-          <a:ln/>
-        </p:spPr>
-        <p:txBody>
-          <a:bodyPr wrap="square" rtlCol="0" anchor="ctr"/>
-          <a:lstStyle/>
-          <a:p>
-            <a:pPr indent="0" marL="0">
-              <a:lnSpc>
-                <a:spcPts val="1100"/>
-              </a:lnSpc>
-              <a:buNone/>
-            </a:pPr>
-            <a:r>
-              <a:rPr lang="en-US" sz="800" dirty="0">
-                <a:solidFill>
-                  <a:srgbClr val="1E2761"/>
-                </a:solidFill>
-                <a:latin typeface="Arial" pitchFamily="34" charset="0"/>
-                <a:ea typeface="Arial" pitchFamily="34" charset="-122"/>
-                <a:cs typeface="Arial" pitchFamily="34" charset="-120"/>
-              </a:rPr>
-              <a:t>💹 Rate Transmission</a:t>
-            </a:r>
-            <a:endParaRPr lang="en-US" sz="800" dirty="0"/>
-          </a:p>
-          <a:p>
-            <a:pPr indent="0" marL="0">
-              <a:lnSpc>
-                <a:spcPts val="1100"/>
-              </a:lnSpc>
-              <a:buNone/>
-            </a:pPr>
-            <a:r>
-              <a:rPr lang="en-US" sz="800" dirty="0">
-                <a:solidFill>
-                  <a:srgbClr val="1E2761"/>
-                </a:solidFill>
-                <a:latin typeface="Arial" pitchFamily="34" charset="0"/>
-                <a:ea typeface="Arial" pitchFamily="34" charset="-122"/>
-                <a:cs typeface="Arial" pitchFamily="34" charset="-120"/>
-              </a:rPr>
-              <a:t>MIBOR-linked vs slower MCLR</a:t>
-            </a:r>
-            <a:endParaRPr lang="en-US" sz="800" dirty="0"/>
-          </a:p>
-        </p:txBody>
-      </p:sp>
-      <p:sp>
-        <p:nvSpPr>
-          <p:cNvPr id="32" name="Text 30"/>
-          <p:cNvSpPr/>
-          <p:nvPr/>
-        </p:nvSpPr>
-        <p:spPr>
-          <a:xfrm>
-            <a:off x="2743200" y="3611880"/>
-            <a:ext cx="2194560" cy="411480"/>
-          </a:xfrm>
-          <a:prstGeom prst="rect">
-            <a:avLst/>
-          </a:prstGeom>
-          <a:noFill/>
-          <a:ln/>
-        </p:spPr>
-        <p:txBody>
-          <a:bodyPr wrap="square" rtlCol="0" anchor="ctr"/>
-          <a:lstStyle/>
-          <a:p>
-            <a:pPr indent="0" marL="0">
-              <a:lnSpc>
-                <a:spcPts val="1100"/>
-              </a:lnSpc>
-              <a:buNone/>
-            </a:pPr>
-            <a:r>
-              <a:rPr lang="en-US" sz="800" dirty="0">
-                <a:solidFill>
-                  <a:srgbClr val="1E2761"/>
-                </a:solidFill>
-                <a:latin typeface="Arial" pitchFamily="34" charset="0"/>
-                <a:ea typeface="Arial" pitchFamily="34" charset="-122"/>
-                <a:cs typeface="Arial" pitchFamily="34" charset="-120"/>
-              </a:rPr>
-              <a:t>🔄 Roll-over Efficiency</a:t>
-            </a:r>
-            <a:endParaRPr lang="en-US" sz="800" dirty="0"/>
-          </a:p>
-          <a:p>
-            <a:pPr indent="0" marL="0">
-              <a:lnSpc>
-                <a:spcPts val="1100"/>
-              </a:lnSpc>
-              <a:buNone/>
-            </a:pPr>
-            <a:r>
-              <a:rPr lang="en-US" sz="800" dirty="0">
-                <a:solidFill>
-                  <a:srgbClr val="1E2761"/>
-                </a:solidFill>
-                <a:latin typeface="Arial" pitchFamily="34" charset="0"/>
-                <a:ea typeface="Arial" pitchFamily="34" charset="-122"/>
-                <a:cs typeface="Arial" pitchFamily="34" charset="-120"/>
-              </a:rPr>
-              <a:t>Reduced risk vs short-term CP</a:t>
-            </a:r>
-            <a:endParaRPr lang="en-US" sz="800" dirty="0"/>
-          </a:p>
-        </p:txBody>
-      </p:sp>
-      <p:sp>
-        <p:nvSpPr>
-          <p:cNvPr id="33" name="Shape 31"/>
-          <p:cNvSpPr/>
-          <p:nvPr/>
-        </p:nvSpPr>
-        <p:spPr>
-          <a:xfrm>
-            <a:off x="5257800" y="2834640"/>
-            <a:ext cx="3246120" cy="1234440"/>
+              <a:rPr lang="en-US" sz="900" dirty="0">
+                <a:solidFill>
+                  <a:srgbClr val="14532D"/>
+                </a:solidFill>
+                <a:latin typeface="Calibri" pitchFamily="34" charset="0"/>
+                <a:ea typeface="Calibri" pitchFamily="34" charset="-122"/>
+                <a:cs typeface="Calibri" pitchFamily="34" charset="-120"/>
+              </a:rPr>
+              <a:t>• Target bank funding: 60-65% (vs 70-75%)</a:t>
+            </a:r>
+            <a:endParaRPr lang="en-US" sz="900" dirty="0"/>
+          </a:p>
+        </p:txBody>
+      </p:sp>
+      <p:sp>
+        <p:nvSpPr>
+          <p:cNvPr id="25" name="Shape 23"/>
+          <p:cNvSpPr/>
+          <p:nvPr/>
+        </p:nvSpPr>
+        <p:spPr>
+          <a:xfrm>
+            <a:off x="274320" y="2697480"/>
+            <a:ext cx="4709160" cy="1143000"/>
           </a:xfrm>
           <a:prstGeom prst="roundRect">
             <a:avLst>
-              <a:gd name="adj" fmla="val 2963"/>
+              <a:gd name="adj" fmla="val 3200"/>
             </a:avLst>
           </a:prstGeom>
           <a:solidFill>
-            <a:srgbClr val="FFFBEB"/>
+            <a:srgbClr val="F8FAFC"/>
           </a:solidFill>
           <a:ln w="12700">
             <a:solidFill>
-              <a:srgbClr val="FBBF24"/>
+              <a:srgbClr val="E2E8F0"/>
             </a:solidFill>
             <a:prstDash val="solid"/>
           </a:ln>
@@ -2211,23 +1798,335 @@
       </p:sp>
       <p:sp>
         <p:nvSpPr>
-          <p:cNvPr id="34" name="Shape 32"/>
-          <p:cNvSpPr/>
-          <p:nvPr/>
-        </p:nvSpPr>
-        <p:spPr>
-          <a:xfrm>
-            <a:off x="5257800" y="2834640"/>
-            <a:ext cx="3246120" cy="237744"/>
-          </a:xfrm>
-          <a:prstGeom prst="rect">
-            <a:avLst/>
-          </a:prstGeom>
-          <a:solidFill>
-            <a:srgbClr val="D97706"/>
-          </a:solidFill>
-          <a:ln/>
-        </p:spPr>
+          <p:cNvPr id="26" name="Shape 24"/>
+          <p:cNvSpPr/>
+          <p:nvPr/>
+        </p:nvSpPr>
+        <p:spPr>
+          <a:xfrm>
+            <a:off x="274320" y="2697480"/>
+            <a:ext cx="4709160" cy="201168"/>
+          </a:xfrm>
+          <a:prstGeom prst="rect">
+            <a:avLst/>
+          </a:prstGeom>
+          <a:solidFill>
+            <a:srgbClr val="1E2761"/>
+          </a:solidFill>
+          <a:ln/>
+        </p:spPr>
+      </p:sp>
+      <p:sp>
+        <p:nvSpPr>
+          <p:cNvPr id="27" name="Text 25"/>
+          <p:cNvSpPr/>
+          <p:nvPr/>
+        </p:nvSpPr>
+        <p:spPr>
+          <a:xfrm>
+            <a:off x="365760" y="2724912"/>
+            <a:ext cx="4526280" cy="146304"/>
+          </a:xfrm>
+          <a:prstGeom prst="rect">
+            <a:avLst/>
+          </a:prstGeom>
+          <a:noFill/>
+          <a:ln/>
+        </p:spPr>
+        <p:txBody>
+          <a:bodyPr wrap="square" rtlCol="0" anchor="ctr"/>
+          <a:lstStyle/>
+          <a:p>
+            <a:pPr indent="0" marL="0">
+              <a:buNone/>
+            </a:pPr>
+            <a:r>
+              <a:rPr lang="en-US" sz="1000" b="1" dirty="0">
+                <a:solidFill>
+                  <a:srgbClr val="FFFFFF"/>
+                </a:solidFill>
+                <a:latin typeface="Calibri" pitchFamily="34" charset="0"/>
+                <a:ea typeface="Calibri" pitchFamily="34" charset="-122"/>
+                <a:cs typeface="Calibri" pitchFamily="34" charset="-120"/>
+              </a:rPr>
+              <a:t>🎯 Strategic Benefits</a:t>
+            </a:r>
+            <a:endParaRPr lang="en-US" sz="1000" dirty="0"/>
+          </a:p>
+        </p:txBody>
+      </p:sp>
+      <p:sp>
+        <p:nvSpPr>
+          <p:cNvPr id="28" name="Text 26"/>
+          <p:cNvSpPr/>
+          <p:nvPr/>
+        </p:nvSpPr>
+        <p:spPr>
+          <a:xfrm>
+            <a:off x="365760" y="2971800"/>
+            <a:ext cx="2011680" cy="137160"/>
+          </a:xfrm>
+          <a:prstGeom prst="rect">
+            <a:avLst/>
+          </a:prstGeom>
+          <a:noFill/>
+          <a:ln/>
+        </p:spPr>
+        <p:txBody>
+          <a:bodyPr wrap="square" rtlCol="0" anchor="ctr"/>
+          <a:lstStyle/>
+          <a:p>
+            <a:pPr indent="0" marL="0">
+              <a:buNone/>
+            </a:pPr>
+            <a:r>
+              <a:rPr lang="en-US" sz="900" b="1" dirty="0">
+                <a:solidFill>
+                  <a:srgbClr val="1E40AF"/>
+                </a:solidFill>
+                <a:latin typeface="Calibri" pitchFamily="34" charset="0"/>
+                <a:ea typeface="Calibri" pitchFamily="34" charset="-122"/>
+                <a:cs typeface="Calibri" pitchFamily="34" charset="-120"/>
+              </a:rPr>
+              <a:t>📊 ALM Optimization</a:t>
+            </a:r>
+            <a:endParaRPr lang="en-US" sz="900" dirty="0"/>
+          </a:p>
+        </p:txBody>
+      </p:sp>
+      <p:sp>
+        <p:nvSpPr>
+          <p:cNvPr id="29" name="Text 27"/>
+          <p:cNvSpPr/>
+          <p:nvPr/>
+        </p:nvSpPr>
+        <p:spPr>
+          <a:xfrm>
+            <a:off x="365760" y="3108960"/>
+            <a:ext cx="2011680" cy="320040"/>
+          </a:xfrm>
+          <a:prstGeom prst="rect">
+            <a:avLst/>
+          </a:prstGeom>
+          <a:noFill/>
+          <a:ln/>
+        </p:spPr>
+        <p:txBody>
+          <a:bodyPr wrap="square" rtlCol="0" anchor="ctr"/>
+          <a:lstStyle/>
+          <a:p>
+            <a:pPr indent="0" marL="0">
+              <a:buNone/>
+            </a:pPr>
+            <a:r>
+              <a:rPr lang="en-US" sz="800" dirty="0">
+                <a:solidFill>
+                  <a:srgbClr val="4B5563"/>
+                </a:solidFill>
+                <a:latin typeface="Calibri" pitchFamily="34" charset="0"/>
+                <a:ea typeface="Calibri" pitchFamily="34" charset="-122"/>
+                <a:cs typeface="Calibri" pitchFamily="34" charset="-120"/>
+              </a:rPr>
+              <a:t>Granular tenor matching for 2W/3W portfolios</a:t>
+            </a:r>
+            <a:endParaRPr lang="en-US" sz="800" dirty="0"/>
+          </a:p>
+        </p:txBody>
+      </p:sp>
+      <p:sp>
+        <p:nvSpPr>
+          <p:cNvPr id="30" name="Text 28"/>
+          <p:cNvSpPr/>
+          <p:nvPr/>
+        </p:nvSpPr>
+        <p:spPr>
+          <a:xfrm>
+            <a:off x="2560320" y="2971800"/>
+            <a:ext cx="2194560" cy="137160"/>
+          </a:xfrm>
+          <a:prstGeom prst="rect">
+            <a:avLst/>
+          </a:prstGeom>
+          <a:noFill/>
+          <a:ln/>
+        </p:spPr>
+        <p:txBody>
+          <a:bodyPr wrap="square" rtlCol="0" anchor="ctr"/>
+          <a:lstStyle/>
+          <a:p>
+            <a:pPr indent="0" marL="0">
+              <a:buNone/>
+            </a:pPr>
+            <a:r>
+              <a:rPr lang="en-US" sz="900" b="1" dirty="0">
+                <a:solidFill>
+                  <a:srgbClr val="1E40AF"/>
+                </a:solidFill>
+                <a:latin typeface="Calibri" pitchFamily="34" charset="0"/>
+                <a:ea typeface="Calibri" pitchFamily="34" charset="-122"/>
+                <a:cs typeface="Calibri" pitchFamily="34" charset="-120"/>
+              </a:rPr>
+              <a:t>⚡ Liquidity Buffer</a:t>
+            </a:r>
+            <a:endParaRPr lang="en-US" sz="900" dirty="0"/>
+          </a:p>
+        </p:txBody>
+      </p:sp>
+      <p:sp>
+        <p:nvSpPr>
+          <p:cNvPr id="31" name="Text 29"/>
+          <p:cNvSpPr/>
+          <p:nvPr/>
+        </p:nvSpPr>
+        <p:spPr>
+          <a:xfrm>
+            <a:off x="2560320" y="3108960"/>
+            <a:ext cx="2194560" cy="320040"/>
+          </a:xfrm>
+          <a:prstGeom prst="rect">
+            <a:avLst/>
+          </a:prstGeom>
+          <a:noFill/>
+          <a:ln/>
+        </p:spPr>
+        <p:txBody>
+          <a:bodyPr wrap="square" rtlCol="0" anchor="ctr"/>
+          <a:lstStyle/>
+          <a:p>
+            <a:pPr indent="0" marL="0">
+              <a:buNone/>
+            </a:pPr>
+            <a:r>
+              <a:rPr lang="en-US" sz="800" dirty="0">
+                <a:solidFill>
+                  <a:srgbClr val="4B5563"/>
+                </a:solidFill>
+                <a:latin typeface="Calibri" pitchFamily="34" charset="0"/>
+                <a:ea typeface="Calibri" pitchFamily="34" charset="-122"/>
+                <a:cs typeface="Calibri" pitchFamily="34" charset="-120"/>
+              </a:rPr>
+              <a:t>Additional LCR source without bank dependence</a:t>
+            </a:r>
+            <a:endParaRPr lang="en-US" sz="800" dirty="0"/>
+          </a:p>
+        </p:txBody>
+      </p:sp>
+      <p:sp>
+        <p:nvSpPr>
+          <p:cNvPr id="32" name="Text 30"/>
+          <p:cNvSpPr/>
+          <p:nvPr/>
+        </p:nvSpPr>
+        <p:spPr>
+          <a:xfrm>
+            <a:off x="365760" y="3383280"/>
+            <a:ext cx="2011680" cy="137160"/>
+          </a:xfrm>
+          <a:prstGeom prst="rect">
+            <a:avLst/>
+          </a:prstGeom>
+          <a:noFill/>
+          <a:ln/>
+        </p:spPr>
+        <p:txBody>
+          <a:bodyPr wrap="square" rtlCol="0" anchor="ctr"/>
+          <a:lstStyle/>
+          <a:p>
+            <a:pPr indent="0" marL="0">
+              <a:buNone/>
+            </a:pPr>
+            <a:r>
+              <a:rPr lang="en-US" sz="900" b="1" dirty="0">
+                <a:solidFill>
+                  <a:srgbClr val="1E40AF"/>
+                </a:solidFill>
+                <a:latin typeface="Calibri" pitchFamily="34" charset="0"/>
+                <a:ea typeface="Calibri" pitchFamily="34" charset="-122"/>
+                <a:cs typeface="Calibri" pitchFamily="34" charset="-120"/>
+              </a:rPr>
+              <a:t>💹 Rate Transmission</a:t>
+            </a:r>
+            <a:endParaRPr lang="en-US" sz="900" dirty="0"/>
+          </a:p>
+        </p:txBody>
+      </p:sp>
+      <p:sp>
+        <p:nvSpPr>
+          <p:cNvPr id="33" name="Text 31"/>
+          <p:cNvSpPr/>
+          <p:nvPr/>
+        </p:nvSpPr>
+        <p:spPr>
+          <a:xfrm>
+            <a:off x="365760" y="3520440"/>
+            <a:ext cx="2011680" cy="228600"/>
+          </a:xfrm>
+          <a:prstGeom prst="rect">
+            <a:avLst/>
+          </a:prstGeom>
+          <a:noFill/>
+          <a:ln/>
+        </p:spPr>
+        <p:txBody>
+          <a:bodyPr wrap="square" rtlCol="0" anchor="ctr"/>
+          <a:lstStyle/>
+          <a:p>
+            <a:pPr indent="0" marL="0">
+              <a:buNone/>
+            </a:pPr>
+            <a:r>
+              <a:rPr lang="en-US" sz="800" dirty="0">
+                <a:solidFill>
+                  <a:srgbClr val="4B5563"/>
+                </a:solidFill>
+                <a:latin typeface="Calibri" pitchFamily="34" charset="0"/>
+                <a:ea typeface="Calibri" pitchFamily="34" charset="-122"/>
+                <a:cs typeface="Calibri" pitchFamily="34" charset="-120"/>
+              </a:rPr>
+              <a:t>MIBOR-linked rates vs slower MCLR</a:t>
+            </a:r>
+            <a:endParaRPr lang="en-US" sz="800" dirty="0"/>
+          </a:p>
+        </p:txBody>
+      </p:sp>
+      <p:sp>
+        <p:nvSpPr>
+          <p:cNvPr id="34" name="Text 32"/>
+          <p:cNvSpPr/>
+          <p:nvPr/>
+        </p:nvSpPr>
+        <p:spPr>
+          <a:xfrm>
+            <a:off x="2560320" y="3383280"/>
+            <a:ext cx="2194560" cy="137160"/>
+          </a:xfrm>
+          <a:prstGeom prst="rect">
+            <a:avLst/>
+          </a:prstGeom>
+          <a:noFill/>
+          <a:ln/>
+        </p:spPr>
+        <p:txBody>
+          <a:bodyPr wrap="square" rtlCol="0" anchor="ctr"/>
+          <a:lstStyle/>
+          <a:p>
+            <a:pPr indent="0" marL="0">
+              <a:buNone/>
+            </a:pPr>
+            <a:r>
+              <a:rPr lang="en-US" sz="900" b="1" dirty="0">
+                <a:solidFill>
+                  <a:srgbClr val="1E40AF"/>
+                </a:solidFill>
+                <a:latin typeface="Calibri" pitchFamily="34" charset="0"/>
+                <a:ea typeface="Calibri" pitchFamily="34" charset="-122"/>
+                <a:cs typeface="Calibri" pitchFamily="34" charset="-120"/>
+              </a:rPr>
+              <a:t>🔄 Roll-over Efficiency</a:t>
+            </a:r>
+            <a:endParaRPr lang="en-US" sz="900" dirty="0"/>
+          </a:p>
+        </p:txBody>
       </p:sp>
       <p:sp>
         <p:nvSpPr>
@@ -2237,34 +2136,34 @@
         </p:nvSpPr>
         <p:spPr>
           <a:xfrm>
-            <a:off x="5349240" y="2871216"/>
-            <a:ext cx="3063240" cy="164592"/>
-          </a:xfrm>
-          <a:prstGeom prst="rect">
-            <a:avLst/>
-          </a:prstGeom>
-          <a:noFill/>
-          <a:ln/>
-        </p:spPr>
-        <p:txBody>
-          <a:bodyPr wrap="square" rtlCol="0" anchor="ctr"/>
-          <a:lstStyle/>
-          <a:p>
-            <a:pPr indent="0" marL="0">
-              <a:buNone/>
-            </a:pPr>
-            <a:r>
-              <a:rPr lang="en-US" sz="1100" b="1" dirty="0">
-                <a:solidFill>
-                  <a:srgbClr val="FFFFFF"/>
-                </a:solidFill>
-                <a:latin typeface="Arial" pitchFamily="34" charset="0"/>
-                <a:ea typeface="Arial" pitchFamily="34" charset="-122"/>
-                <a:cs typeface="Arial" pitchFamily="34" charset="-120"/>
-              </a:rPr>
-              <a:t>⚡ Immediate Actions (30 Days)</a:t>
-            </a:r>
-            <a:endParaRPr lang="en-US" sz="1100" dirty="0"/>
+            <a:off x="2560320" y="3520440"/>
+            <a:ext cx="2194560" cy="228600"/>
+          </a:xfrm>
+          <a:prstGeom prst="rect">
+            <a:avLst/>
+          </a:prstGeom>
+          <a:noFill/>
+          <a:ln/>
+        </p:spPr>
+        <p:txBody>
+          <a:bodyPr wrap="square" rtlCol="0" anchor="ctr"/>
+          <a:lstStyle/>
+          <a:p>
+            <a:pPr indent="0" marL="0">
+              <a:buNone/>
+            </a:pPr>
+            <a:r>
+              <a:rPr lang="en-US" sz="800" dirty="0">
+                <a:solidFill>
+                  <a:srgbClr val="4B5563"/>
+                </a:solidFill>
+                <a:latin typeface="Calibri" pitchFamily="34" charset="0"/>
+                <a:ea typeface="Calibri" pitchFamily="34" charset="-122"/>
+                <a:cs typeface="Calibri" pitchFamily="34" charset="-120"/>
+              </a:rPr>
+              <a:t>Reduced refinancing risk vs short-term CP</a:t>
+            </a:r>
+            <a:endParaRPr lang="en-US" sz="800" dirty="0"/>
           </a:p>
         </p:txBody>
       </p:sp>
@@ -2276,95 +2175,81 @@
         </p:nvSpPr>
         <p:spPr>
           <a:xfrm>
-            <a:off x="5394960" y="3182112"/>
-            <a:ext cx="411480" cy="146304"/>
+            <a:off x="5074920" y="2697480"/>
+            <a:ext cx="3520440" cy="1143000"/>
           </a:xfrm>
           <a:prstGeom prst="roundRect">
             <a:avLst>
-              <a:gd name="adj" fmla="val 12500"/>
+              <a:gd name="adj" fmla="val 3200"/>
             </a:avLst>
           </a:prstGeom>
           <a:solidFill>
-            <a:srgbClr val="DC2626"/>
-          </a:solidFill>
-          <a:ln/>
-        </p:spPr>
-      </p:sp>
-      <p:sp>
-        <p:nvSpPr>
-          <p:cNvPr id="37" name="Text 35"/>
-          <p:cNvSpPr/>
-          <p:nvPr/>
-        </p:nvSpPr>
-        <p:spPr>
-          <a:xfrm>
-            <a:off x="5394960" y="3182112"/>
-            <a:ext cx="411480" cy="146304"/>
-          </a:xfrm>
-          <a:prstGeom prst="rect">
-            <a:avLst/>
-          </a:prstGeom>
-          <a:noFill/>
-          <a:ln/>
-        </p:spPr>
-        <p:txBody>
-          <a:bodyPr wrap="square" rtlCol="0" anchor="ctr"/>
-          <a:lstStyle/>
-          <a:p>
-            <a:pPr algn="ctr" indent="0" marL="0">
-              <a:buNone/>
-            </a:pPr>
-            <a:r>
-              <a:rPr lang="en-US" sz="700" b="1" dirty="0">
+            <a:srgbClr val="FFFBEB"/>
+          </a:solidFill>
+          <a:ln w="12700">
+            <a:solidFill>
+              <a:srgbClr val="FCD34D"/>
+            </a:solidFill>
+            <a:prstDash val="solid"/>
+          </a:ln>
+        </p:spPr>
+      </p:sp>
+      <p:sp>
+        <p:nvSpPr>
+          <p:cNvPr id="37" name="Shape 35"/>
+          <p:cNvSpPr/>
+          <p:nvPr/>
+        </p:nvSpPr>
+        <p:spPr>
+          <a:xfrm>
+            <a:off x="5074920" y="2697480"/>
+            <a:ext cx="3520440" cy="201168"/>
+          </a:xfrm>
+          <a:prstGeom prst="rect">
+            <a:avLst/>
+          </a:prstGeom>
+          <a:solidFill>
+            <a:srgbClr val="D97706"/>
+          </a:solidFill>
+          <a:ln/>
+        </p:spPr>
+      </p:sp>
+      <p:sp>
+        <p:nvSpPr>
+          <p:cNvPr id="38" name="Text 36"/>
+          <p:cNvSpPr/>
+          <p:nvPr/>
+        </p:nvSpPr>
+        <p:spPr>
+          <a:xfrm>
+            <a:off x="5166360" y="2724912"/>
+            <a:ext cx="3337560" cy="146304"/>
+          </a:xfrm>
+          <a:prstGeom prst="rect">
+            <a:avLst/>
+          </a:prstGeom>
+          <a:noFill/>
+          <a:ln/>
+        </p:spPr>
+        <p:txBody>
+          <a:bodyPr wrap="square" rtlCol="0" anchor="ctr"/>
+          <a:lstStyle/>
+          <a:p>
+            <a:pPr indent="0" marL="0">
+              <a:buNone/>
+            </a:pPr>
+            <a:r>
+              <a:rPr lang="en-US" sz="1000" b="1" dirty="0">
                 <a:solidFill>
                   <a:srgbClr val="FFFFFF"/>
                 </a:solidFill>
-                <a:latin typeface="Arial" pitchFamily="34" charset="0"/>
-                <a:ea typeface="Arial" pitchFamily="34" charset="-122"/>
-                <a:cs typeface="Arial" pitchFamily="34" charset="-120"/>
-              </a:rPr>
-              <a:t>HIGH</a:t>
-            </a:r>
-            <a:endParaRPr lang="en-US" sz="700" dirty="0"/>
-          </a:p>
-        </p:txBody>
-      </p:sp>
-      <p:sp>
-        <p:nvSpPr>
-          <p:cNvPr id="38" name="Text 36"/>
-          <p:cNvSpPr/>
-          <p:nvPr/>
-        </p:nvSpPr>
-        <p:spPr>
-          <a:xfrm>
-            <a:off x="5897880" y="3182112"/>
-            <a:ext cx="2468880" cy="146304"/>
-          </a:xfrm>
-          <a:prstGeom prst="rect">
-            <a:avLst/>
-          </a:prstGeom>
-          <a:noFill/>
-          <a:ln/>
-        </p:spPr>
-        <p:txBody>
-          <a:bodyPr wrap="square" rtlCol="0" anchor="ctr"/>
-          <a:lstStyle/>
-          <a:p>
-            <a:pPr indent="0" marL="0">
-              <a:buNone/>
-            </a:pPr>
-            <a:r>
-              <a:rPr lang="en-US" sz="900" dirty="0">
-                <a:solidFill>
-                  <a:srgbClr val="1E2761"/>
-                </a:solidFill>
-                <a:latin typeface="Arial" pitchFamily="34" charset="0"/>
-                <a:ea typeface="Arial" pitchFamily="34" charset="-122"/>
-                <a:cs typeface="Arial" pitchFamily="34" charset="-120"/>
-              </a:rPr>
-              <a:t>CCIL/NDS-OM Registration</a:t>
-            </a:r>
-            <a:endParaRPr lang="en-US" sz="900" dirty="0"/>
+                <a:latin typeface="Calibri" pitchFamily="34" charset="0"/>
+                <a:ea typeface="Calibri" pitchFamily="34" charset="-122"/>
+                <a:cs typeface="Calibri" pitchFamily="34" charset="-120"/>
+              </a:rPr>
+              <a:t>⚡ Immediate Actions (Next 30 Days)</a:t>
+            </a:r>
+            <a:endParaRPr lang="en-US" sz="1000" dirty="0"/>
           </a:p>
         </p:txBody>
       </p:sp>
@@ -2376,12 +2261,12 @@
         </p:nvSpPr>
         <p:spPr>
           <a:xfrm>
-            <a:off x="5394960" y="3401568"/>
-            <a:ext cx="411480" cy="146304"/>
+            <a:off x="5212080" y="2990088"/>
+            <a:ext cx="365760" cy="128016"/>
           </a:xfrm>
           <a:prstGeom prst="roundRect">
             <a:avLst>
-              <a:gd name="adj" fmla="val 12500"/>
+              <a:gd name="adj" fmla="val 14286"/>
             </a:avLst>
           </a:prstGeom>
           <a:solidFill>
@@ -2398,8 +2283,8 @@
         </p:nvSpPr>
         <p:spPr>
           <a:xfrm>
-            <a:off x="5394960" y="3401568"/>
-            <a:ext cx="411480" cy="146304"/>
+            <a:off x="5212080" y="2990088"/>
+            <a:ext cx="365760" cy="128016"/>
           </a:xfrm>
           <a:prstGeom prst="rect">
             <a:avLst/>
@@ -2415,17 +2300,17 @@
               <a:buNone/>
             </a:pPr>
             <a:r>
-              <a:rPr lang="en-US" sz="700" b="1" dirty="0">
+              <a:rPr lang="en-US" sz="600" b="1" dirty="0">
                 <a:solidFill>
                   <a:srgbClr val="FFFFFF"/>
                 </a:solidFill>
-                <a:latin typeface="Arial" pitchFamily="34" charset="0"/>
-                <a:ea typeface="Arial" pitchFamily="34" charset="-122"/>
-                <a:cs typeface="Arial" pitchFamily="34" charset="-120"/>
+                <a:latin typeface="Calibri" pitchFamily="34" charset="0"/>
+                <a:ea typeface="Calibri" pitchFamily="34" charset="-122"/>
+                <a:cs typeface="Calibri" pitchFamily="34" charset="-120"/>
               </a:rPr>
               <a:t>HIGH</a:t>
             </a:r>
-            <a:endParaRPr lang="en-US" sz="700" dirty="0"/>
+            <a:endParaRPr lang="en-US" sz="600" dirty="0"/>
           </a:p>
         </p:txBody>
       </p:sp>
@@ -2437,8 +2322,8 @@
         </p:nvSpPr>
         <p:spPr>
           <a:xfrm>
-            <a:off x="5897880" y="3401568"/>
-            <a:ext cx="2468880" cy="146304"/>
+            <a:off x="5669280" y="2990088"/>
+            <a:ext cx="2743200" cy="128016"/>
           </a:xfrm>
           <a:prstGeom prst="rect">
             <a:avLst/>
@@ -2456,13 +2341,13 @@
             <a:r>
               <a:rPr lang="en-US" sz="900" dirty="0">
                 <a:solidFill>
-                  <a:srgbClr val="1E2761"/>
-                </a:solidFill>
-                <a:latin typeface="Arial" pitchFamily="34" charset="0"/>
-                <a:ea typeface="Arial" pitchFamily="34" charset="-122"/>
-                <a:cs typeface="Arial" pitchFamily="34" charset="-120"/>
-              </a:rPr>
-              <a:t>Update Treasury Policy</a:t>
+                  <a:srgbClr val="374151"/>
+                </a:solidFill>
+                <a:latin typeface="Calibri" pitchFamily="34" charset="0"/>
+                <a:ea typeface="Calibri" pitchFamily="34" charset="-122"/>
+                <a:cs typeface="Calibri" pitchFamily="34" charset="-120"/>
+              </a:rPr>
+              <a:t>CCIL/NDS-OM Registration</a:t>
             </a:r>
             <a:endParaRPr lang="en-US" sz="900" dirty="0"/>
           </a:p>
@@ -2476,15 +2361,115 @@
         </p:nvSpPr>
         <p:spPr>
           <a:xfrm>
-            <a:off x="5394960" y="3621024"/>
-            <a:ext cx="411480" cy="146304"/>
+            <a:off x="5212080" y="3182112"/>
+            <a:ext cx="365760" cy="128016"/>
           </a:xfrm>
           <a:prstGeom prst="roundRect">
             <a:avLst>
-              <a:gd name="adj" fmla="val 12500"/>
+              <a:gd name="adj" fmla="val 14286"/>
             </a:avLst>
           </a:prstGeom>
           <a:solidFill>
+            <a:srgbClr val="DC2626"/>
+          </a:solidFill>
+          <a:ln/>
+        </p:spPr>
+      </p:sp>
+      <p:sp>
+        <p:nvSpPr>
+          <p:cNvPr id="43" name="Text 41"/>
+          <p:cNvSpPr/>
+          <p:nvPr/>
+        </p:nvSpPr>
+        <p:spPr>
+          <a:xfrm>
+            <a:off x="5212080" y="3182112"/>
+            <a:ext cx="365760" cy="128016"/>
+          </a:xfrm>
+          <a:prstGeom prst="rect">
+            <a:avLst/>
+          </a:prstGeom>
+          <a:noFill/>
+          <a:ln/>
+        </p:spPr>
+        <p:txBody>
+          <a:bodyPr wrap="square" rtlCol="0" anchor="ctr"/>
+          <a:lstStyle/>
+          <a:p>
+            <a:pPr algn="ctr" indent="0" marL="0">
+              <a:buNone/>
+            </a:pPr>
+            <a:r>
+              <a:rPr lang="en-US" sz="600" b="1" dirty="0">
+                <a:solidFill>
+                  <a:srgbClr val="FFFFFF"/>
+                </a:solidFill>
+                <a:latin typeface="Calibri" pitchFamily="34" charset="0"/>
+                <a:ea typeface="Calibri" pitchFamily="34" charset="-122"/>
+                <a:cs typeface="Calibri" pitchFamily="34" charset="-120"/>
+              </a:rPr>
+              <a:t>HIGH</a:t>
+            </a:r>
+            <a:endParaRPr lang="en-US" sz="600" dirty="0"/>
+          </a:p>
+        </p:txBody>
+      </p:sp>
+      <p:sp>
+        <p:nvSpPr>
+          <p:cNvPr id="44" name="Text 42"/>
+          <p:cNvSpPr/>
+          <p:nvPr/>
+        </p:nvSpPr>
+        <p:spPr>
+          <a:xfrm>
+            <a:off x="5669280" y="3182112"/>
+            <a:ext cx="2743200" cy="128016"/>
+          </a:xfrm>
+          <a:prstGeom prst="rect">
+            <a:avLst/>
+          </a:prstGeom>
+          <a:noFill/>
+          <a:ln/>
+        </p:spPr>
+        <p:txBody>
+          <a:bodyPr wrap="square" rtlCol="0" anchor="ctr"/>
+          <a:lstStyle/>
+          <a:p>
+            <a:pPr indent="0" marL="0">
+              <a:buNone/>
+            </a:pPr>
+            <a:r>
+              <a:rPr lang="en-US" sz="900" dirty="0">
+                <a:solidFill>
+                  <a:srgbClr val="374151"/>
+                </a:solidFill>
+                <a:latin typeface="Calibri" pitchFamily="34" charset="0"/>
+                <a:ea typeface="Calibri" pitchFamily="34" charset="-122"/>
+                <a:cs typeface="Calibri" pitchFamily="34" charset="-120"/>
+              </a:rPr>
+              <a:t>Update Treasury Policy Framework</a:t>
+            </a:r>
+            <a:endParaRPr lang="en-US" sz="900" dirty="0"/>
+          </a:p>
+        </p:txBody>
+      </p:sp>
+      <p:sp>
+        <p:nvSpPr>
+          <p:cNvPr id="45" name="Shape 43"/>
+          <p:cNvSpPr/>
+          <p:nvPr/>
+        </p:nvSpPr>
+        <p:spPr>
+          <a:xfrm>
+            <a:off x="5212080" y="3374136"/>
+            <a:ext cx="365760" cy="128016"/>
+          </a:xfrm>
+          <a:prstGeom prst="roundRect">
+            <a:avLst>
+              <a:gd name="adj" fmla="val 14286"/>
+            </a:avLst>
+          </a:prstGeom>
+          <a:solidFill>
             <a:srgbClr val="D97706"/>
           </a:solidFill>
           <a:ln/>
@@ -2492,14 +2477,14 @@
       </p:sp>
       <p:sp>
         <p:nvSpPr>
-          <p:cNvPr id="43" name="Text 41"/>
-          <p:cNvSpPr/>
-          <p:nvPr/>
-        </p:nvSpPr>
-        <p:spPr>
-          <a:xfrm>
-            <a:off x="5394960" y="3621024"/>
-            <a:ext cx="411480" cy="146304"/>
+          <p:cNvPr id="46" name="Text 44"/>
+          <p:cNvSpPr/>
+          <p:nvPr/>
+        </p:nvSpPr>
+        <p:spPr>
+          <a:xfrm>
+            <a:off x="5212080" y="3374136"/>
+            <a:ext cx="365760" cy="128016"/>
           </a:xfrm>
           <a:prstGeom prst="rect">
             <a:avLst/>
@@ -2515,30 +2500,30 @@
               <a:buNone/>
             </a:pPr>
             <a:r>
-              <a:rPr lang="en-US" sz="700" b="1" dirty="0">
+              <a:rPr lang="en-US" sz="600" b="1" dirty="0">
                 <a:solidFill>
                   <a:srgbClr val="FFFFFF"/>
                 </a:solidFill>
-                <a:latin typeface="Arial" pitchFamily="34" charset="0"/>
-                <a:ea typeface="Arial" pitchFamily="34" charset="-122"/>
-                <a:cs typeface="Arial" pitchFamily="34" charset="-120"/>
+                <a:latin typeface="Calibri" pitchFamily="34" charset="0"/>
+                <a:ea typeface="Calibri" pitchFamily="34" charset="-122"/>
+                <a:cs typeface="Calibri" pitchFamily="34" charset="-120"/>
               </a:rPr>
               <a:t>MED</a:t>
             </a:r>
-            <a:endParaRPr lang="en-US" sz="700" dirty="0"/>
-          </a:p>
-        </p:txBody>
-      </p:sp>
-      <p:sp>
-        <p:nvSpPr>
-          <p:cNvPr id="44" name="Text 42"/>
-          <p:cNvSpPr/>
-          <p:nvPr/>
-        </p:nvSpPr>
-        <p:spPr>
-          <a:xfrm>
-            <a:off x="5897880" y="3621024"/>
-            <a:ext cx="2468880" cy="146304"/>
+            <a:endParaRPr lang="en-US" sz="600" dirty="0"/>
+          </a:p>
+        </p:txBody>
+      </p:sp>
+      <p:sp>
+        <p:nvSpPr>
+          <p:cNvPr id="47" name="Text 45"/>
+          <p:cNvSpPr/>
+          <p:nvPr/>
+        </p:nvSpPr>
+        <p:spPr>
+          <a:xfrm>
+            <a:off x="5669280" y="3374136"/>
+            <a:ext cx="2743200" cy="128016"/>
           </a:xfrm>
           <a:prstGeom prst="rect">
             <a:avLst/>
@@ -2556,13 +2541,13 @@
             <a:r>
               <a:rPr lang="en-US" sz="900" dirty="0">
                 <a:solidFill>
-                  <a:srgbClr val="1E2761"/>
-                </a:solidFill>
-                <a:latin typeface="Arial" pitchFamily="34" charset="0"/>
-                <a:ea typeface="Arial" pitchFamily="34" charset="-122"/>
-                <a:cs typeface="Arial" pitchFamily="34" charset="-120"/>
-              </a:rPr>
-              <a:t>Trading Infrastructure</a:t>
+                  <a:srgbClr val="374151"/>
+                </a:solidFill>
+                <a:latin typeface="Calibri" pitchFamily="34" charset="0"/>
+                <a:ea typeface="Calibri" pitchFamily="34" charset="-122"/>
+                <a:cs typeface="Calibri" pitchFamily="34" charset="-120"/>
+              </a:rPr>
+              <a:t>Trading Infrastructure Setup</a:t>
             </a:r>
             <a:endParaRPr lang="en-US" sz="900" dirty="0"/>
           </a:p>
@@ -2570,14 +2555,114 @@
       </p:sp>
       <p:sp>
         <p:nvSpPr>
-          <p:cNvPr id="45" name="Shape 43"/>
-          <p:cNvSpPr/>
-          <p:nvPr/>
-        </p:nvSpPr>
-        <p:spPr>
-          <a:xfrm>
-            <a:off x="0" y="4206240"/>
-            <a:ext cx="9144000" cy="292608"/>
+          <p:cNvPr id="48" name="Shape 46"/>
+          <p:cNvSpPr/>
+          <p:nvPr/>
+        </p:nvSpPr>
+        <p:spPr>
+          <a:xfrm>
+            <a:off x="5212080" y="3566160"/>
+            <a:ext cx="365760" cy="128016"/>
+          </a:xfrm>
+          <a:prstGeom prst="roundRect">
+            <a:avLst>
+              <a:gd name="adj" fmla="val 14286"/>
+            </a:avLst>
+          </a:prstGeom>
+          <a:solidFill>
+            <a:srgbClr val="D97706"/>
+          </a:solidFill>
+          <a:ln/>
+        </p:spPr>
+      </p:sp>
+      <p:sp>
+        <p:nvSpPr>
+          <p:cNvPr id="49" name="Text 47"/>
+          <p:cNvSpPr/>
+          <p:nvPr/>
+        </p:nvSpPr>
+        <p:spPr>
+          <a:xfrm>
+            <a:off x="5212080" y="3566160"/>
+            <a:ext cx="365760" cy="128016"/>
+          </a:xfrm>
+          <a:prstGeom prst="rect">
+            <a:avLst/>
+          </a:prstGeom>
+          <a:noFill/>
+          <a:ln/>
+        </p:spPr>
+        <p:txBody>
+          <a:bodyPr wrap="square" rtlCol="0" anchor="ctr"/>
+          <a:lstStyle/>
+          <a:p>
+            <a:pPr algn="ctr" indent="0" marL="0">
+              <a:buNone/>
+            </a:pPr>
+            <a:r>
+              <a:rPr lang="en-US" sz="600" b="1" dirty="0">
+                <a:solidFill>
+                  <a:srgbClr val="FFFFFF"/>
+                </a:solidFill>
+                <a:latin typeface="Calibri" pitchFamily="34" charset="0"/>
+                <a:ea typeface="Calibri" pitchFamily="34" charset="-122"/>
+                <a:cs typeface="Calibri" pitchFamily="34" charset="-120"/>
+              </a:rPr>
+              <a:t>MED</a:t>
+            </a:r>
+            <a:endParaRPr lang="en-US" sz="600" dirty="0"/>
+          </a:p>
+        </p:txBody>
+      </p:sp>
+      <p:sp>
+        <p:nvSpPr>
+          <p:cNvPr id="50" name="Text 48"/>
+          <p:cNvSpPr/>
+          <p:nvPr/>
+        </p:nvSpPr>
+        <p:spPr>
+          <a:xfrm>
+            <a:off x="5669280" y="3566160"/>
+            <a:ext cx="2743200" cy="128016"/>
+          </a:xfrm>
+          <a:prstGeom prst="rect">
+            <a:avLst/>
+          </a:prstGeom>
+          <a:noFill/>
+          <a:ln/>
+        </p:spPr>
+        <p:txBody>
+          <a:bodyPr wrap="square" rtlCol="0" anchor="ctr"/>
+          <a:lstStyle/>
+          <a:p>
+            <a:pPr indent="0" marL="0">
+              <a:buNone/>
+            </a:pPr>
+            <a:r>
+              <a:rPr lang="en-US" sz="900" dirty="0">
+                <a:solidFill>
+                  <a:srgbClr val="374151"/>
+                </a:solidFill>
+                <a:latin typeface="Calibri" pitchFamily="34" charset="0"/>
+                <a:ea typeface="Calibri" pitchFamily="34" charset="-122"/>
+                <a:cs typeface="Calibri" pitchFamily="34" charset="-120"/>
+              </a:rPr>
+              <a:t>Counterparty Due Diligence</a:t>
+            </a:r>
+            <a:endParaRPr lang="en-US" sz="900" dirty="0"/>
+          </a:p>
+        </p:txBody>
+      </p:sp>
+      <p:sp>
+        <p:nvSpPr>
+          <p:cNvPr id="51" name="Shape 49"/>
+          <p:cNvSpPr/>
+          <p:nvPr/>
+        </p:nvSpPr>
+        <p:spPr>
+          <a:xfrm>
+            <a:off x="0" y="4023360"/>
+            <a:ext cx="9144000" cy="256032"/>
           </a:xfrm>
           <a:prstGeom prst="rect">
             <a:avLst/>
@@ -2590,14 +2675,14 @@
       </p:sp>
       <p:sp>
         <p:nvSpPr>
-          <p:cNvPr id="46" name="Text 44"/>
-          <p:cNvSpPr/>
-          <p:nvPr/>
-        </p:nvSpPr>
-        <p:spPr>
-          <a:xfrm>
-            <a:off x="365760" y="4233672"/>
-            <a:ext cx="7315200" cy="164592"/>
+          <p:cNvPr id="52" name="Text 50"/>
+          <p:cNvSpPr/>
+          <p:nvPr/>
+        </p:nvSpPr>
+        <p:spPr>
+          <a:xfrm>
+            <a:off x="274320" y="4050792"/>
+            <a:ext cx="8229600" cy="109728"/>
           </a:xfrm>
           <a:prstGeom prst="rect">
             <a:avLst/>
@@ -2617,9 +2702,9 @@
                 <a:solidFill>
                   <a:srgbClr val="CADCFC"/>
                 </a:solidFill>
-                <a:latin typeface="Arial" pitchFamily="34" charset="0"/>
-                <a:ea typeface="Arial" pitchFamily="34" charset="-122"/>
-                <a:cs typeface="Arial" pitchFamily="34" charset="-120"/>
+                <a:latin typeface="Calibri" pitchFamily="34" charset="0"/>
+                <a:ea typeface="Calibri" pitchFamily="34" charset="-122"/>
+                <a:cs typeface="Calibri" pitchFamily="34" charset="-120"/>
               </a:rPr>
               <a:t>Hero FinCorp Treasury | RBI Circular: April 9, 2026 | Internal Use Only</a:t>
             </a:r>
@@ -2629,14 +2714,14 @@
       </p:sp>
       <p:sp>
         <p:nvSpPr>
-          <p:cNvPr id="47" name="Text 45"/>
-          <p:cNvSpPr/>
-          <p:nvPr/>
-        </p:nvSpPr>
-        <p:spPr>
-          <a:xfrm>
-            <a:off x="365760" y="4370832"/>
-            <a:ext cx="7315200" cy="109728"/>
+          <p:cNvPr id="53" name="Text 51"/>
+          <p:cNvSpPr/>
+          <p:nvPr/>
+        </p:nvSpPr>
+        <p:spPr>
+          <a:xfrm>
+            <a:off x="274320" y="4160520"/>
+            <a:ext cx="8229600" cy="91440"/>
           </a:xfrm>
           <a:prstGeom prst="rect">
             <a:avLst/>
@@ -2656,11 +2741,11 @@
                 <a:solidFill>
                   <a:srgbClr val="9CA3AF"/>
                 </a:solidFill>
-                <a:latin typeface="Arial" pitchFamily="34" charset="0"/>
-                <a:ea typeface="Arial" pitchFamily="34" charset="-122"/>
-                <a:cs typeface="Arial" pitchFamily="34" charset="-120"/>
-              </a:rPr>
-              <a:t>Projections are estimates. Actual savings depend on credit rating, market depth, and participation scale.</a:t>
+                <a:latin typeface="Calibri" pitchFamily="34" charset="0"/>
+                <a:ea typeface="Calibri" pitchFamily="34" charset="-122"/>
+                <a:cs typeface="Calibri" pitchFamily="34" charset="-120"/>
+              </a:rPr>
+              <a:t>Projections are estimates based on market conditions.</a:t>
             </a:r>
             <a:endParaRPr lang="en-US" sz="700" dirty="0"/>
           </a:p>

</xml_diff>

<commit_message>
Fix PowerPoint v4 - conservative 0.5 margins, compact layout, verified spacing
</commit_message>
<xml_diff>
--- a/RBI_Term_Money_Market_HeroFinCorp_Analysis.pptx
+++ b/RBI_Term_Money_Market_HeroFinCorp_Analysis.pptx
@@ -884,13 +884,13 @@
         <p:spPr>
           <a:xfrm>
             <a:off x="0" y="0"/>
-            <a:ext cx="9144000" cy="548640"/>
-          </a:xfrm>
-          <a:prstGeom prst="rect">
-            <a:avLst/>
-          </a:prstGeom>
-          <a:solidFill>
-            <a:srgbClr val="1E2761"/>
+            <a:ext cx="9144000" cy="457200"/>
+          </a:xfrm>
+          <a:prstGeom prst="rect">
+            <a:avLst/>
+          </a:prstGeom>
+          <a:solidFill>
+            <a:srgbClr val="1E3A8A"/>
           </a:solidFill>
           <a:ln/>
         </p:spPr>
@@ -903,34 +903,34 @@
         </p:nvSpPr>
         <p:spPr>
           <a:xfrm>
-            <a:off x="274320" y="137160"/>
-            <a:ext cx="8229600" cy="320040"/>
-          </a:xfrm>
-          <a:prstGeom prst="rect">
-            <a:avLst/>
-          </a:prstGeom>
-          <a:noFill/>
-          <a:ln/>
-        </p:spPr>
-        <p:txBody>
-          <a:bodyPr wrap="square" rtlCol="0" anchor="ctr"/>
-          <a:lstStyle/>
-          <a:p>
-            <a:pPr indent="0" marL="0">
-              <a:buNone/>
-            </a:pPr>
-            <a:r>
-              <a:rPr lang="en-US" sz="1600" b="1" dirty="0">
+            <a:off x="457200" y="118872"/>
+            <a:ext cx="8229600" cy="274320"/>
+          </a:xfrm>
+          <a:prstGeom prst="rect">
+            <a:avLst/>
+          </a:prstGeom>
+          <a:noFill/>
+          <a:ln/>
+        </p:spPr>
+        <p:txBody>
+          <a:bodyPr wrap="square" rtlCol="0" anchor="ctr"/>
+          <a:lstStyle/>
+          <a:p>
+            <a:pPr indent="0" marL="0">
+              <a:buNone/>
+            </a:pPr>
+            <a:r>
+              <a:rPr lang="en-US" sz="1400" b="1" dirty="0">
                 <a:solidFill>
                   <a:srgbClr val="FFFFFF"/>
                 </a:solidFill>
-                <a:latin typeface="Calibri" pitchFamily="34" charset="0"/>
-                <a:ea typeface="Calibri" pitchFamily="34" charset="-122"/>
-                <a:cs typeface="Calibri" pitchFamily="34" charset="-120"/>
-              </a:rPr>
-              <a:t>🏛️ RBI Term Money Market Expansion — Strategic Impact for Hero FinCorp</a:t>
-            </a:r>
-            <a:endParaRPr lang="en-US" sz="1600" dirty="0"/>
+                <a:latin typeface="Arial" pitchFamily="34" charset="0"/>
+                <a:ea typeface="Arial" pitchFamily="34" charset="-122"/>
+                <a:cs typeface="Arial" pitchFamily="34" charset="-120"/>
+              </a:rPr>
+              <a:t>RBI Term Money Market Expansion — Hero FinCorp Impact Analysis</a:t>
+            </a:r>
+            <a:endParaRPr lang="en-US" sz="1400" dirty="0"/>
           </a:p>
         </p:txBody>
       </p:sp>
@@ -942,8 +942,8 @@
         </p:nvSpPr>
         <p:spPr>
           <a:xfrm>
-            <a:off x="7772400" y="137160"/>
-            <a:ext cx="1828800" cy="320040"/>
+            <a:off x="7772400" y="118872"/>
+            <a:ext cx="1371600" cy="274320"/>
           </a:xfrm>
           <a:prstGeom prst="rect">
             <a:avLst/>
@@ -959,17 +959,17 @@
               <a:buNone/>
             </a:pPr>
             <a:r>
-              <a:rPr lang="en-US" sz="900" dirty="0">
-                <a:solidFill>
-                  <a:srgbClr val="CADCFC"/>
-                </a:solidFill>
-                <a:latin typeface="Calibri" pitchFamily="34" charset="0"/>
-                <a:ea typeface="Calibri" pitchFamily="34" charset="-122"/>
-                <a:cs typeface="Calibri" pitchFamily="34" charset="-120"/>
-              </a:rPr>
-              <a:t>April 9, 2026 | NBFC-ML Treasury Strategy</a:t>
-            </a:r>
-            <a:endParaRPr lang="en-US" sz="900" dirty="0"/>
+              <a:rPr lang="en-US" sz="1000" dirty="0">
+                <a:solidFill>
+                  <a:srgbClr val="E0E7FF"/>
+                </a:solidFill>
+                <a:latin typeface="Arial" pitchFamily="34" charset="0"/>
+                <a:ea typeface="Arial" pitchFamily="34" charset="-122"/>
+                <a:cs typeface="Arial" pitchFamily="34" charset="-120"/>
+              </a:rPr>
+              <a:t>April 9, 2026</a:t>
+            </a:r>
+            <a:endParaRPr lang="en-US" sz="1000" dirty="0"/>
           </a:p>
         </p:txBody>
       </p:sp>
@@ -981,16 +981,16 @@
         </p:nvSpPr>
         <p:spPr>
           <a:xfrm>
-            <a:off x="274320" y="685800"/>
-            <a:ext cx="2194560" cy="502920"/>
+            <a:off x="457200" y="548640"/>
+            <a:ext cx="1965960" cy="457200"/>
           </a:xfrm>
           <a:prstGeom prst="roundRect">
             <a:avLst>
-              <a:gd name="adj" fmla="val 5455"/>
+              <a:gd name="adj" fmla="val 6000"/>
             </a:avLst>
           </a:prstGeom>
           <a:solidFill>
-            <a:srgbClr val="EFF6FF"/>
+            <a:srgbClr val="DBEAFE"/>
           </a:solidFill>
           <a:ln w="12700">
             <a:solidFill>
@@ -1008,34 +1008,34 @@
         </p:nvSpPr>
         <p:spPr>
           <a:xfrm>
-            <a:off x="365760" y="731520"/>
-            <a:ext cx="2011680" cy="256032"/>
-          </a:xfrm>
-          <a:prstGeom prst="rect">
-            <a:avLst/>
-          </a:prstGeom>
-          <a:noFill/>
-          <a:ln/>
-        </p:spPr>
-        <p:txBody>
-          <a:bodyPr wrap="square" rtlCol="0" anchor="ctr"/>
-          <a:lstStyle/>
-          <a:p>
-            <a:pPr indent="0" marL="0">
-              <a:buNone/>
-            </a:pPr>
-            <a:r>
-              <a:rPr lang="en-US" sz="1600" b="1" dirty="0">
+            <a:off x="548640" y="594360"/>
+            <a:ext cx="1783080" cy="228600"/>
+          </a:xfrm>
+          <a:prstGeom prst="rect">
+            <a:avLst/>
+          </a:prstGeom>
+          <a:noFill/>
+          <a:ln/>
+        </p:spPr>
+        <p:txBody>
+          <a:bodyPr wrap="square" rtlCol="0" anchor="ctr"/>
+          <a:lstStyle/>
+          <a:p>
+            <a:pPr indent="0" marL="0">
+              <a:buNone/>
+            </a:pPr>
+            <a:r>
+              <a:rPr lang="en-US" sz="1400" b="1" dirty="0">
                 <a:solidFill>
                   <a:srgbClr val="1E40AF"/>
                 </a:solidFill>
-                <a:latin typeface="Calibri" pitchFamily="34" charset="0"/>
-                <a:ea typeface="Calibri" pitchFamily="34" charset="-122"/>
-                <a:cs typeface="Calibri" pitchFamily="34" charset="-120"/>
+                <a:latin typeface="Arial" pitchFamily="34" charset="0"/>
+                <a:ea typeface="Arial" pitchFamily="34" charset="-122"/>
+                <a:cs typeface="Arial" pitchFamily="34" charset="-120"/>
               </a:rPr>
               <a:t>15-40 bps</a:t>
             </a:r>
-            <a:endParaRPr lang="en-US" sz="1600" dirty="0"/>
+            <a:endParaRPr lang="en-US" sz="1400" dirty="0"/>
           </a:p>
         </p:txBody>
       </p:sp>
@@ -1047,8 +1047,8 @@
         </p:nvSpPr>
         <p:spPr>
           <a:xfrm>
-            <a:off x="365760" y="978408"/>
-            <a:ext cx="2011680" cy="182880"/>
+            <a:off x="548640" y="804672"/>
+            <a:ext cx="1783080" cy="164592"/>
           </a:xfrm>
           <a:prstGeom prst="rect">
             <a:avLst/>
@@ -1068,11 +1068,11 @@
                 <a:solidFill>
                   <a:srgbClr val="4B5563"/>
                 </a:solidFill>
-                <a:latin typeface="Calibri" pitchFamily="34" charset="0"/>
-                <a:ea typeface="Calibri" pitchFamily="34" charset="-122"/>
-                <a:cs typeface="Calibri" pitchFamily="34" charset="-120"/>
-              </a:rPr>
-              <a:t>Cost Savings vs Bank Credit</a:t>
+                <a:latin typeface="Arial" pitchFamily="34" charset="0"/>
+                <a:ea typeface="Arial" pitchFamily="34" charset="-122"/>
+                <a:cs typeface="Arial" pitchFamily="34" charset="-120"/>
+              </a:rPr>
+              <a:t>Cost Savings</a:t>
             </a:r>
             <a:endParaRPr lang="en-US" sz="800" dirty="0"/>
           </a:p>
@@ -1086,16 +1086,16 @@
         </p:nvSpPr>
         <p:spPr>
           <a:xfrm>
-            <a:off x="2587752" y="685800"/>
-            <a:ext cx="2194560" cy="502920"/>
+            <a:off x="2542032" y="548640"/>
+            <a:ext cx="1965960" cy="457200"/>
           </a:xfrm>
           <a:prstGeom prst="roundRect">
             <a:avLst>
-              <a:gd name="adj" fmla="val 5455"/>
+              <a:gd name="adj" fmla="val 6000"/>
             </a:avLst>
           </a:prstGeom>
           <a:solidFill>
-            <a:srgbClr val="ECFDF5"/>
+            <a:srgbClr val="D1FAE5"/>
           </a:solidFill>
           <a:ln w="12700">
             <a:solidFill>
@@ -1113,34 +1113,34 @@
         </p:nvSpPr>
         <p:spPr>
           <a:xfrm>
-            <a:off x="2679192" y="731520"/>
-            <a:ext cx="2011680" cy="256032"/>
-          </a:xfrm>
-          <a:prstGeom prst="rect">
-            <a:avLst/>
-          </a:prstGeom>
-          <a:noFill/>
-          <a:ln/>
-        </p:spPr>
-        <p:txBody>
-          <a:bodyPr wrap="square" rtlCol="0" anchor="ctr"/>
-          <a:lstStyle/>
-          <a:p>
-            <a:pPr indent="0" marL="0">
-              <a:buNone/>
-            </a:pPr>
-            <a:r>
-              <a:rPr lang="en-US" sz="1600" b="1" dirty="0">
-                <a:solidFill>
-                  <a:srgbClr val="059669"/>
-                </a:solidFill>
-                <a:latin typeface="Calibri" pitchFamily="34" charset="0"/>
-                <a:ea typeface="Calibri" pitchFamily="34" charset="-122"/>
-                <a:cs typeface="Calibri" pitchFamily="34" charset="-120"/>
+            <a:off x="2633472" y="594360"/>
+            <a:ext cx="1783080" cy="228600"/>
+          </a:xfrm>
+          <a:prstGeom prst="rect">
+            <a:avLst/>
+          </a:prstGeom>
+          <a:noFill/>
+          <a:ln/>
+        </p:spPr>
+        <p:txBody>
+          <a:bodyPr wrap="square" rtlCol="0" anchor="ctr"/>
+          <a:lstStyle/>
+          <a:p>
+            <a:pPr indent="0" marL="0">
+              <a:buNone/>
+            </a:pPr>
+            <a:r>
+              <a:rPr lang="en-US" sz="1400" b="1" dirty="0">
+                <a:solidFill>
+                  <a:srgbClr val="065F46"/>
+                </a:solidFill>
+                <a:latin typeface="Arial" pitchFamily="34" charset="0"/>
+                <a:ea typeface="Arial" pitchFamily="34" charset="-122"/>
+                <a:cs typeface="Arial" pitchFamily="34" charset="-120"/>
               </a:rPr>
               <a:t>₹3-12 Cr</a:t>
             </a:r>
-            <a:endParaRPr lang="en-US" sz="1600" dirty="0"/>
+            <a:endParaRPr lang="en-US" sz="1400" dirty="0"/>
           </a:p>
         </p:txBody>
       </p:sp>
@@ -1152,8 +1152,8 @@
         </p:nvSpPr>
         <p:spPr>
           <a:xfrm>
-            <a:off x="2679192" y="978408"/>
-            <a:ext cx="2011680" cy="182880"/>
+            <a:off x="2633472" y="804672"/>
+            <a:ext cx="1783080" cy="164592"/>
           </a:xfrm>
           <a:prstGeom prst="rect">
             <a:avLst/>
@@ -1173,11 +1173,11 @@
                 <a:solidFill>
                   <a:srgbClr val="4B5563"/>
                 </a:solidFill>
-                <a:latin typeface="Calibri" pitchFamily="34" charset="0"/>
-                <a:ea typeface="Calibri" pitchFamily="34" charset="-122"/>
-                <a:cs typeface="Calibri" pitchFamily="34" charset="-120"/>
-              </a:rPr>
-              <a:t>Annual Interest Savings</a:t>
+                <a:latin typeface="Arial" pitchFamily="34" charset="0"/>
+                <a:ea typeface="Arial" pitchFamily="34" charset="-122"/>
+                <a:cs typeface="Arial" pitchFamily="34" charset="-120"/>
+              </a:rPr>
+              <a:t>Annual Savings</a:t>
             </a:r>
             <a:endParaRPr lang="en-US" sz="800" dirty="0"/>
           </a:p>
@@ -1191,20 +1191,20 @@
         </p:nvSpPr>
         <p:spPr>
           <a:xfrm>
-            <a:off x="4901184" y="685800"/>
-            <a:ext cx="2194560" cy="502920"/>
+            <a:off x="4626864" y="548640"/>
+            <a:ext cx="1965960" cy="457200"/>
           </a:xfrm>
           <a:prstGeom prst="roundRect">
             <a:avLst>
-              <a:gd name="adj" fmla="val 5455"/>
+              <a:gd name="adj" fmla="val 6000"/>
             </a:avLst>
           </a:prstGeom>
           <a:solidFill>
-            <a:srgbClr val="FFFBEB"/>
+            <a:srgbClr val="FEF3C7"/>
           </a:solidFill>
           <a:ln w="12700">
             <a:solidFill>
-              <a:srgbClr val="F59E0B"/>
+              <a:srgbClr val="D97706"/>
             </a:solidFill>
             <a:prstDash val="solid"/>
           </a:ln>
@@ -1218,34 +1218,34 @@
         </p:nvSpPr>
         <p:spPr>
           <a:xfrm>
-            <a:off x="4992624" y="731520"/>
-            <a:ext cx="2011680" cy="256032"/>
-          </a:xfrm>
-          <a:prstGeom prst="rect">
-            <a:avLst/>
-          </a:prstGeom>
-          <a:noFill/>
-          <a:ln/>
-        </p:spPr>
-        <p:txBody>
-          <a:bodyPr wrap="square" rtlCol="0" anchor="ctr"/>
-          <a:lstStyle/>
-          <a:p>
-            <a:pPr indent="0" marL="0">
-              <a:buNone/>
-            </a:pPr>
-            <a:r>
-              <a:rPr lang="en-US" sz="1600" b="1" dirty="0">
-                <a:solidFill>
-                  <a:srgbClr val="B45309"/>
-                </a:solidFill>
-                <a:latin typeface="Calibri" pitchFamily="34" charset="0"/>
-                <a:ea typeface="Calibri" pitchFamily="34" charset="-122"/>
-                <a:cs typeface="Calibri" pitchFamily="34" charset="-120"/>
-              </a:rPr>
-              <a:t>Direct Access</a:t>
-            </a:r>
-            <a:endParaRPr lang="en-US" sz="1600" dirty="0"/>
+            <a:off x="4718304" y="594360"/>
+            <a:ext cx="1783080" cy="228600"/>
+          </a:xfrm>
+          <a:prstGeom prst="rect">
+            <a:avLst/>
+          </a:prstGeom>
+          <a:noFill/>
+          <a:ln/>
+        </p:spPr>
+        <p:txBody>
+          <a:bodyPr wrap="square" rtlCol="0" anchor="ctr"/>
+          <a:lstStyle/>
+          <a:p>
+            <a:pPr indent="0" marL="0">
+              <a:buNone/>
+            </a:pPr>
+            <a:r>
+              <a:rPr lang="en-US" sz="1400" b="1" dirty="0">
+                <a:solidFill>
+                  <a:srgbClr val="92400E"/>
+                </a:solidFill>
+                <a:latin typeface="Arial" pitchFamily="34" charset="0"/>
+                <a:ea typeface="Arial" pitchFamily="34" charset="-122"/>
+                <a:cs typeface="Arial" pitchFamily="34" charset="-120"/>
+              </a:rPr>
+              <a:t>Direct</a:t>
+            </a:r>
+            <a:endParaRPr lang="en-US" sz="1400" dirty="0"/>
           </a:p>
         </p:txBody>
       </p:sp>
@@ -1257,8 +1257,8 @@
         </p:nvSpPr>
         <p:spPr>
           <a:xfrm>
-            <a:off x="4992624" y="978408"/>
-            <a:ext cx="2011680" cy="182880"/>
+            <a:off x="4718304" y="804672"/>
+            <a:ext cx="1783080" cy="164592"/>
           </a:xfrm>
           <a:prstGeom prst="rect">
             <a:avLst/>
@@ -1278,11 +1278,11 @@
                 <a:solidFill>
                   <a:srgbClr val="4B5563"/>
                 </a:solidFill>
-                <a:latin typeface="Calibri" pitchFamily="34" charset="0"/>
-                <a:ea typeface="Calibri" pitchFamily="34" charset="-122"/>
-                <a:cs typeface="Calibri" pitchFamily="34" charset="-120"/>
-              </a:rPr>
-              <a:t>No Bank Intermediary</a:t>
+                <a:latin typeface="Arial" pitchFamily="34" charset="0"/>
+                <a:ea typeface="Arial" pitchFamily="34" charset="-122"/>
+                <a:cs typeface="Arial" pitchFamily="34" charset="-120"/>
+              </a:rPr>
+              <a:t>Market Access</a:t>
             </a:r>
             <a:endParaRPr lang="en-US" sz="800" dirty="0"/>
           </a:p>
@@ -1296,16 +1296,16 @@
         </p:nvSpPr>
         <p:spPr>
           <a:xfrm>
-            <a:off x="7214616" y="685800"/>
-            <a:ext cx="2194560" cy="502920"/>
+            <a:off x="6711696" y="548640"/>
+            <a:ext cx="1965960" cy="457200"/>
           </a:xfrm>
           <a:prstGeom prst="roundRect">
             <a:avLst>
-              <a:gd name="adj" fmla="val 5455"/>
+              <a:gd name="adj" fmla="val 6000"/>
             </a:avLst>
           </a:prstGeom>
           <a:solidFill>
-            <a:srgbClr val="EFF6FF"/>
+            <a:srgbClr val="DBEAFE"/>
           </a:solidFill>
           <a:ln w="12700">
             <a:solidFill>
@@ -1323,34 +1323,34 @@
         </p:nvSpPr>
         <p:spPr>
           <a:xfrm>
-            <a:off x="7306056" y="731520"/>
-            <a:ext cx="2011680" cy="256032"/>
-          </a:xfrm>
-          <a:prstGeom prst="rect">
-            <a:avLst/>
-          </a:prstGeom>
-          <a:noFill/>
-          <a:ln/>
-        </p:spPr>
-        <p:txBody>
-          <a:bodyPr wrap="square" rtlCol="0" anchor="ctr"/>
-          <a:lstStyle/>
-          <a:p>
-            <a:pPr indent="0" marL="0">
-              <a:buNone/>
-            </a:pPr>
-            <a:r>
-              <a:rPr lang="en-US" sz="1600" b="1" dirty="0">
+            <a:off x="6803136" y="594360"/>
+            <a:ext cx="1783080" cy="228600"/>
+          </a:xfrm>
+          <a:prstGeom prst="rect">
+            <a:avLst/>
+          </a:prstGeom>
+          <a:noFill/>
+          <a:ln/>
+        </p:spPr>
+        <p:txBody>
+          <a:bodyPr wrap="square" rtlCol="0" anchor="ctr"/>
+          <a:lstStyle/>
+          <a:p>
+            <a:pPr indent="0" marL="0">
+              <a:buNone/>
+            </a:pPr>
+            <a:r>
+              <a:rPr lang="en-US" sz="1400" b="1" dirty="0">
                 <a:solidFill>
                   <a:srgbClr val="1E40AF"/>
                 </a:solidFill>
-                <a:latin typeface="Calibri" pitchFamily="34" charset="0"/>
-                <a:ea typeface="Calibri" pitchFamily="34" charset="-122"/>
-                <a:cs typeface="Calibri" pitchFamily="34" charset="-120"/>
+                <a:latin typeface="Arial" pitchFamily="34" charset="0"/>
+                <a:ea typeface="Arial" pitchFamily="34" charset="-122"/>
+                <a:cs typeface="Arial" pitchFamily="34" charset="-120"/>
               </a:rPr>
               <a:t>10-15%</a:t>
             </a:r>
-            <a:endParaRPr lang="en-US" sz="1600" dirty="0"/>
+            <a:endParaRPr lang="en-US" sz="1400" dirty="0"/>
           </a:p>
         </p:txBody>
       </p:sp>
@@ -1362,8 +1362,8 @@
         </p:nvSpPr>
         <p:spPr>
           <a:xfrm>
-            <a:off x="7306056" y="978408"/>
-            <a:ext cx="2011680" cy="182880"/>
+            <a:off x="6803136" y="804672"/>
+            <a:ext cx="1783080" cy="164592"/>
           </a:xfrm>
           <a:prstGeom prst="rect">
             <a:avLst/>
@@ -1383,11 +1383,11 @@
                 <a:solidFill>
                   <a:srgbClr val="4B5563"/>
                 </a:solidFill>
-                <a:latin typeface="Calibri" pitchFamily="34" charset="0"/>
-                <a:ea typeface="Calibri" pitchFamily="34" charset="-122"/>
-                <a:cs typeface="Calibri" pitchFamily="34" charset="-120"/>
-              </a:rPr>
-              <a:t>Target Funding Mix</a:t>
+                <a:latin typeface="Arial" pitchFamily="34" charset="0"/>
+                <a:ea typeface="Arial" pitchFamily="34" charset="-122"/>
+                <a:cs typeface="Arial" pitchFamily="34" charset="-120"/>
+              </a:rPr>
+              <a:t>Target Mix</a:t>
             </a:r>
             <a:endParaRPr lang="en-US" sz="800" dirty="0"/>
           </a:p>
@@ -1401,12 +1401,12 @@
         </p:nvSpPr>
         <p:spPr>
           <a:xfrm>
-            <a:off x="274320" y="1325880"/>
-            <a:ext cx="4389120" cy="1234440"/>
+            <a:off x="457200" y="1097280"/>
+            <a:ext cx="4069080" cy="1188720"/>
           </a:xfrm>
           <a:prstGeom prst="roundRect">
             <a:avLst>
-              <a:gd name="adj" fmla="val 2963"/>
+              <a:gd name="adj" fmla="val 2308"/>
             </a:avLst>
           </a:prstGeom>
           <a:solidFill>
@@ -1428,8 +1428,8 @@
         </p:nvSpPr>
         <p:spPr>
           <a:xfrm>
-            <a:off x="274320" y="1325880"/>
-            <a:ext cx="4389120" cy="228600"/>
+            <a:off x="457200" y="1097280"/>
+            <a:ext cx="4069080" cy="201168"/>
           </a:xfrm>
           <a:prstGeom prst="rect">
             <a:avLst/>
@@ -1448,34 +1448,34 @@
         </p:nvSpPr>
         <p:spPr>
           <a:xfrm>
-            <a:off x="365760" y="1353312"/>
-            <a:ext cx="4206240" cy="182880"/>
-          </a:xfrm>
-          <a:prstGeom prst="rect">
-            <a:avLst/>
-          </a:prstGeom>
-          <a:noFill/>
-          <a:ln/>
-        </p:spPr>
-        <p:txBody>
-          <a:bodyPr wrap="square" rtlCol="0" anchor="ctr"/>
-          <a:lstStyle/>
-          <a:p>
-            <a:pPr indent="0" marL="0">
-              <a:buNone/>
-            </a:pPr>
-            <a:r>
-              <a:rPr lang="en-US" sz="1000" b="1" dirty="0">
+            <a:off x="548640" y="1124712"/>
+            <a:ext cx="3886200" cy="164592"/>
+          </a:xfrm>
+          <a:prstGeom prst="rect">
+            <a:avLst/>
+          </a:prstGeom>
+          <a:noFill/>
+          <a:ln/>
+        </p:spPr>
+        <p:txBody>
+          <a:bodyPr wrap="square" rtlCol="0" anchor="ctr"/>
+          <a:lstStyle/>
+          <a:p>
+            <a:pPr indent="0" marL="0">
+              <a:buNone/>
+            </a:pPr>
+            <a:r>
+              <a:rPr lang="en-US" sz="900" b="1" dirty="0">
                 <a:solidFill>
                   <a:srgbClr val="FFFFFF"/>
                 </a:solidFill>
-                <a:latin typeface="Calibri" pitchFamily="34" charset="0"/>
-                <a:ea typeface="Calibri" pitchFamily="34" charset="-122"/>
-                <a:cs typeface="Calibri" pitchFamily="34" charset="-120"/>
-              </a:rPr>
-              <a:t>❌ PRE-EXPANSION (Before Apr 9, 2026)</a:t>
-            </a:r>
-            <a:endParaRPr lang="en-US" sz="1000" dirty="0"/>
+                <a:latin typeface="Arial" pitchFamily="34" charset="0"/>
+                <a:ea typeface="Arial" pitchFamily="34" charset="-122"/>
+                <a:cs typeface="Arial" pitchFamily="34" charset="-120"/>
+              </a:rPr>
+              <a:t>PRE-EXPANSION</a:t>
+            </a:r>
+            <a:endParaRPr lang="en-US" sz="900" dirty="0"/>
           </a:p>
         </p:txBody>
       </p:sp>
@@ -1487,8 +1487,8 @@
         </p:nvSpPr>
         <p:spPr>
           <a:xfrm>
-            <a:off x="365760" y="1618488"/>
-            <a:ext cx="4206240" cy="868680"/>
+            <a:off x="548640" y="1353312"/>
+            <a:ext cx="3886200" cy="868680"/>
           </a:xfrm>
           <a:prstGeom prst="rect">
             <a:avLst/>
@@ -1511,11 +1511,11 @@
                 <a:solidFill>
                   <a:srgbClr val="7F1D1D"/>
                 </a:solidFill>
-                <a:latin typeface="Calibri" pitchFamily="34" charset="0"/>
-                <a:ea typeface="Calibri" pitchFamily="34" charset="-122"/>
-                <a:cs typeface="Calibri" pitchFamily="34" charset="-120"/>
-              </a:rPr>
-              <a:t>• Term money restricted to banks &amp; PDs only</a:t>
+                <a:latin typeface="Arial" pitchFamily="34" charset="0"/>
+                <a:ea typeface="Arial" pitchFamily="34" charset="-122"/>
+                <a:cs typeface="Arial" pitchFamily="34" charset="-120"/>
+              </a:rPr>
+              <a:t>• Term money restricted to banks &amp; PDs</a:t>
             </a:r>
             <a:endParaRPr lang="en-US" sz="900" dirty="0"/>
           </a:p>
@@ -1531,9 +1531,9 @@
                 <a:solidFill>
                   <a:srgbClr val="7F1D1D"/>
                 </a:solidFill>
-                <a:latin typeface="Calibri" pitchFamily="34" charset="0"/>
-                <a:ea typeface="Calibri" pitchFamily="34" charset="-122"/>
-                <a:cs typeface="Calibri" pitchFamily="34" charset="-120"/>
+                <a:latin typeface="Arial" pitchFamily="34" charset="0"/>
+                <a:ea typeface="Arial" pitchFamily="34" charset="-122"/>
+                <a:cs typeface="Arial" pitchFamily="34" charset="-120"/>
               </a:rPr>
               <a:t>• NBFCs dependent on bank intermediation</a:t>
             </a:r>
@@ -1551,9 +1551,9 @@
                 <a:solidFill>
                   <a:srgbClr val="7F1D1D"/>
                 </a:solidFill>
-                <a:latin typeface="Calibri" pitchFamily="34" charset="0"/>
-                <a:ea typeface="Calibri" pitchFamily="34" charset="-122"/>
-                <a:cs typeface="Calibri" pitchFamily="34" charset="-120"/>
+                <a:latin typeface="Arial" pitchFamily="34" charset="0"/>
+                <a:ea typeface="Arial" pitchFamily="34" charset="-122"/>
+                <a:cs typeface="Arial" pitchFamily="34" charset="-120"/>
               </a:rPr>
               <a:t>• Limited 6M-1Y price transparency</a:t>
             </a:r>
@@ -1571,9 +1571,9 @@
                 <a:solidFill>
                   <a:srgbClr val="7F1D1D"/>
                 </a:solidFill>
-                <a:latin typeface="Calibri" pitchFamily="34" charset="0"/>
-                <a:ea typeface="Calibri" pitchFamily="34" charset="-122"/>
-                <a:cs typeface="Calibri" pitchFamily="34" charset="-120"/>
+                <a:latin typeface="Arial" pitchFamily="34" charset="0"/>
+                <a:ea typeface="Arial" pitchFamily="34" charset="-122"/>
+                <a:cs typeface="Arial" pitchFamily="34" charset="-120"/>
               </a:rPr>
               <a:t>• Bank funding concentration: 70-75%</a:t>
             </a:r>
@@ -1589,12 +1589,12 @@
         </p:nvSpPr>
         <p:spPr>
           <a:xfrm>
-            <a:off x="4846320" y="1325880"/>
-            <a:ext cx="4389120" cy="1234440"/>
+            <a:off x="4709160" y="1097280"/>
+            <a:ext cx="4069080" cy="1188720"/>
           </a:xfrm>
           <a:prstGeom prst="roundRect">
             <a:avLst>
-              <a:gd name="adj" fmla="val 2963"/>
+              <a:gd name="adj" fmla="val 2308"/>
             </a:avLst>
           </a:prstGeom>
           <a:solidFill>
@@ -1616,8 +1616,8 @@
         </p:nvSpPr>
         <p:spPr>
           <a:xfrm>
-            <a:off x="4846320" y="1325880"/>
-            <a:ext cx="4389120" cy="228600"/>
+            <a:off x="4709160" y="1097280"/>
+            <a:ext cx="4069080" cy="201168"/>
           </a:xfrm>
           <a:prstGeom prst="rect">
             <a:avLst/>
@@ -1636,34 +1636,34 @@
         </p:nvSpPr>
         <p:spPr>
           <a:xfrm>
-            <a:off x="4937760" y="1353312"/>
-            <a:ext cx="4206240" cy="182880"/>
-          </a:xfrm>
-          <a:prstGeom prst="rect">
-            <a:avLst/>
-          </a:prstGeom>
-          <a:noFill/>
-          <a:ln/>
-        </p:spPr>
-        <p:txBody>
-          <a:bodyPr wrap="square" rtlCol="0" anchor="ctr"/>
-          <a:lstStyle/>
-          <a:p>
-            <a:pPr indent="0" marL="0">
-              <a:buNone/>
-            </a:pPr>
-            <a:r>
-              <a:rPr lang="en-US" sz="1000" b="1" dirty="0">
+            <a:off x="4800600" y="1124712"/>
+            <a:ext cx="3886200" cy="164592"/>
+          </a:xfrm>
+          <a:prstGeom prst="rect">
+            <a:avLst/>
+          </a:prstGeom>
+          <a:noFill/>
+          <a:ln/>
+        </p:spPr>
+        <p:txBody>
+          <a:bodyPr wrap="square" rtlCol="0" anchor="ctr"/>
+          <a:lstStyle/>
+          <a:p>
+            <a:pPr indent="0" marL="0">
+              <a:buNone/>
+            </a:pPr>
+            <a:r>
+              <a:rPr lang="en-US" sz="900" b="1" dirty="0">
                 <a:solidFill>
                   <a:srgbClr val="FFFFFF"/>
                 </a:solidFill>
-                <a:latin typeface="Calibri" pitchFamily="34" charset="0"/>
-                <a:ea typeface="Calibri" pitchFamily="34" charset="-122"/>
-                <a:cs typeface="Calibri" pitchFamily="34" charset="-120"/>
-              </a:rPr>
-              <a:t>✅ POST-EXPANSION (After Apr 9, 2026)</a:t>
-            </a:r>
-            <a:endParaRPr lang="en-US" sz="1000" dirty="0"/>
+                <a:latin typeface="Arial" pitchFamily="34" charset="0"/>
+                <a:ea typeface="Arial" pitchFamily="34" charset="-122"/>
+                <a:cs typeface="Arial" pitchFamily="34" charset="-120"/>
+              </a:rPr>
+              <a:t>POST-EXPANSION</a:t>
+            </a:r>
+            <a:endParaRPr lang="en-US" sz="900" dirty="0"/>
           </a:p>
         </p:txBody>
       </p:sp>
@@ -1675,8 +1675,8 @@
         </p:nvSpPr>
         <p:spPr>
           <a:xfrm>
-            <a:off x="4937760" y="1618488"/>
-            <a:ext cx="4206240" cy="868680"/>
+            <a:off x="4800600" y="1353312"/>
+            <a:ext cx="3886200" cy="868680"/>
           </a:xfrm>
           <a:prstGeom prst="rect">
             <a:avLst/>
@@ -1699,11 +1699,11 @@
                 <a:solidFill>
                   <a:srgbClr val="14532D"/>
                 </a:solidFill>
-                <a:latin typeface="Calibri" pitchFamily="34" charset="0"/>
-                <a:ea typeface="Calibri" pitchFamily="34" charset="-122"/>
-                <a:cs typeface="Calibri" pitchFamily="34" charset="-120"/>
-              </a:rPr>
-              <a:t>• Direct NBFC participation in term market</a:t>
+                <a:latin typeface="Arial" pitchFamily="34" charset="0"/>
+                <a:ea typeface="Arial" pitchFamily="34" charset="-122"/>
+                <a:cs typeface="Arial" pitchFamily="34" charset="-120"/>
+              </a:rPr>
+              <a:t>• Direct NBFC participation enabled</a:t>
             </a:r>
             <a:endParaRPr lang="en-US" sz="900" dirty="0"/>
           </a:p>
@@ -1719,11 +1719,11 @@
                 <a:solidFill>
                   <a:srgbClr val="14532D"/>
                 </a:solidFill>
-                <a:latin typeface="Calibri" pitchFamily="34" charset="0"/>
-                <a:ea typeface="Calibri" pitchFamily="34" charset="-122"/>
-                <a:cs typeface="Calibri" pitchFamily="34" charset="-120"/>
-              </a:rPr>
-              <a:t>• 15-40 bps savings via market-driven rates</a:t>
+                <a:latin typeface="Arial" pitchFamily="34" charset="0"/>
+                <a:ea typeface="Arial" pitchFamily="34" charset="-122"/>
+                <a:cs typeface="Arial" pitchFamily="34" charset="-120"/>
+              </a:rPr>
+              <a:t>• 15-40 bps cost savings expected</a:t>
             </a:r>
             <a:endParaRPr lang="en-US" sz="900" dirty="0"/>
           </a:p>
@@ -1739,9 +1739,9 @@
                 <a:solidFill>
                   <a:srgbClr val="14532D"/>
                 </a:solidFill>
-                <a:latin typeface="Calibri" pitchFamily="34" charset="0"/>
-                <a:ea typeface="Calibri" pitchFamily="34" charset="-122"/>
-                <a:cs typeface="Calibri" pitchFamily="34" charset="-120"/>
+                <a:latin typeface="Arial" pitchFamily="34" charset="0"/>
+                <a:ea typeface="Arial" pitchFamily="34" charset="-122"/>
+                <a:cs typeface="Arial" pitchFamily="34" charset="-120"/>
               </a:rPr>
               <a:t>• Flexible tenor: 14D to 1Y for ALM</a:t>
             </a:r>
@@ -1759,11 +1759,11 @@
                 <a:solidFill>
                   <a:srgbClr val="14532D"/>
                 </a:solidFill>
-                <a:latin typeface="Calibri" pitchFamily="34" charset="0"/>
-                <a:ea typeface="Calibri" pitchFamily="34" charset="-122"/>
-                <a:cs typeface="Calibri" pitchFamily="34" charset="-120"/>
-              </a:rPr>
-              <a:t>• Target bank funding: 60-65% (vs 70-75%)</a:t>
+                <a:latin typeface="Arial" pitchFamily="34" charset="0"/>
+                <a:ea typeface="Arial" pitchFamily="34" charset="-122"/>
+                <a:cs typeface="Arial" pitchFamily="34" charset="-120"/>
+              </a:rPr>
+              <a:t>• Diversify: target 60-65% bank funding</a:t>
             </a:r>
             <a:endParaRPr lang="en-US" sz="900" dirty="0"/>
           </a:p>
@@ -1777,12 +1777,12 @@
         </p:nvSpPr>
         <p:spPr>
           <a:xfrm>
-            <a:off x="274320" y="2697480"/>
-            <a:ext cx="4709160" cy="1143000"/>
+            <a:off x="457200" y="2423160"/>
+            <a:ext cx="4663440" cy="1051560"/>
           </a:xfrm>
           <a:prstGeom prst="roundRect">
             <a:avLst>
-              <a:gd name="adj" fmla="val 3200"/>
+              <a:gd name="adj" fmla="val 2609"/>
             </a:avLst>
           </a:prstGeom>
           <a:solidFill>
@@ -1790,7 +1790,7 @@
           </a:solidFill>
           <a:ln w="12700">
             <a:solidFill>
-              <a:srgbClr val="E2E8F0"/>
+              <a:srgbClr val="CBD5E1"/>
             </a:solidFill>
             <a:prstDash val="solid"/>
           </a:ln>
@@ -1804,14 +1804,14 @@
         </p:nvSpPr>
         <p:spPr>
           <a:xfrm>
-            <a:off x="274320" y="2697480"/>
-            <a:ext cx="4709160" cy="201168"/>
-          </a:xfrm>
-          <a:prstGeom prst="rect">
-            <a:avLst/>
-          </a:prstGeom>
-          <a:solidFill>
-            <a:srgbClr val="1E2761"/>
+            <a:off x="457200" y="2423160"/>
+            <a:ext cx="4663440" cy="182880"/>
+          </a:xfrm>
+          <a:prstGeom prst="rect">
+            <a:avLst/>
+          </a:prstGeom>
+          <a:solidFill>
+            <a:srgbClr val="1E3A8A"/>
           </a:solidFill>
           <a:ln/>
         </p:spPr>
@@ -1824,34 +1824,34 @@
         </p:nvSpPr>
         <p:spPr>
           <a:xfrm>
-            <a:off x="365760" y="2724912"/>
-            <a:ext cx="4526280" cy="146304"/>
-          </a:xfrm>
-          <a:prstGeom prst="rect">
-            <a:avLst/>
-          </a:prstGeom>
-          <a:noFill/>
-          <a:ln/>
-        </p:spPr>
-        <p:txBody>
-          <a:bodyPr wrap="square" rtlCol="0" anchor="ctr"/>
-          <a:lstStyle/>
-          <a:p>
-            <a:pPr indent="0" marL="0">
-              <a:buNone/>
-            </a:pPr>
-            <a:r>
-              <a:rPr lang="en-US" sz="1000" b="1" dirty="0">
+            <a:off x="548640" y="2450592"/>
+            <a:ext cx="4480560" cy="137160"/>
+          </a:xfrm>
+          <a:prstGeom prst="rect">
+            <a:avLst/>
+          </a:prstGeom>
+          <a:noFill/>
+          <a:ln/>
+        </p:spPr>
+        <p:txBody>
+          <a:bodyPr wrap="square" rtlCol="0" anchor="ctr"/>
+          <a:lstStyle/>
+          <a:p>
+            <a:pPr indent="0" marL="0">
+              <a:buNone/>
+            </a:pPr>
+            <a:r>
+              <a:rPr lang="en-US" sz="900" b="1" dirty="0">
                 <a:solidFill>
                   <a:srgbClr val="FFFFFF"/>
                 </a:solidFill>
-                <a:latin typeface="Calibri" pitchFamily="34" charset="0"/>
-                <a:ea typeface="Calibri" pitchFamily="34" charset="-122"/>
-                <a:cs typeface="Calibri" pitchFamily="34" charset="-120"/>
-              </a:rPr>
-              <a:t>🎯 Strategic Benefits</a:t>
-            </a:r>
-            <a:endParaRPr lang="en-US" sz="1000" dirty="0"/>
+                <a:latin typeface="Arial" pitchFamily="34" charset="0"/>
+                <a:ea typeface="Arial" pitchFamily="34" charset="-122"/>
+                <a:cs typeface="Arial" pitchFamily="34" charset="-120"/>
+              </a:rPr>
+              <a:t>Strategic Benefits</a:t>
+            </a:r>
+            <a:endParaRPr lang="en-US" sz="900" dirty="0"/>
           </a:p>
         </p:txBody>
       </p:sp>
@@ -1863,8 +1863,8 @@
         </p:nvSpPr>
         <p:spPr>
           <a:xfrm>
-            <a:off x="365760" y="2971800"/>
-            <a:ext cx="2011680" cy="137160"/>
+            <a:off x="594360" y="2679192"/>
+            <a:ext cx="2011680" cy="128016"/>
           </a:xfrm>
           <a:prstGeom prst="rect">
             <a:avLst/>
@@ -1882,13 +1882,13 @@
             <a:r>
               <a:rPr lang="en-US" sz="900" b="1" dirty="0">
                 <a:solidFill>
-                  <a:srgbClr val="1E40AF"/>
-                </a:solidFill>
-                <a:latin typeface="Calibri" pitchFamily="34" charset="0"/>
-                <a:ea typeface="Calibri" pitchFamily="34" charset="-122"/>
-                <a:cs typeface="Calibri" pitchFamily="34" charset="-120"/>
-              </a:rPr>
-              <a:t>📊 ALM Optimization</a:t>
+                  <a:srgbClr val="2563EB"/>
+                </a:solidFill>
+                <a:latin typeface="Arial" pitchFamily="34" charset="0"/>
+                <a:ea typeface="Arial" pitchFamily="34" charset="-122"/>
+                <a:cs typeface="Arial" pitchFamily="34" charset="-120"/>
+              </a:rPr>
+              <a:t>ALM Optimization</a:t>
             </a:r>
             <a:endParaRPr lang="en-US" sz="900" dirty="0"/>
           </a:p>
@@ -1902,8 +1902,8 @@
         </p:nvSpPr>
         <p:spPr>
           <a:xfrm>
-            <a:off x="365760" y="3108960"/>
-            <a:ext cx="2011680" cy="320040"/>
+            <a:off x="594360" y="2807208"/>
+            <a:ext cx="2011680" cy="256032"/>
           </a:xfrm>
           <a:prstGeom prst="rect">
             <a:avLst/>
@@ -1923,11 +1923,11 @@
                 <a:solidFill>
                   <a:srgbClr val="4B5563"/>
                 </a:solidFill>
-                <a:latin typeface="Calibri" pitchFamily="34" charset="0"/>
-                <a:ea typeface="Calibri" pitchFamily="34" charset="-122"/>
-                <a:cs typeface="Calibri" pitchFamily="34" charset="-120"/>
-              </a:rPr>
-              <a:t>Granular tenor matching for 2W/3W portfolios</a:t>
+                <a:latin typeface="Arial" pitchFamily="34" charset="0"/>
+                <a:ea typeface="Arial" pitchFamily="34" charset="-122"/>
+                <a:cs typeface="Arial" pitchFamily="34" charset="-120"/>
+              </a:rPr>
+              <a:t>Granular tenor matching for portfolios</a:t>
             </a:r>
             <a:endParaRPr lang="en-US" sz="800" dirty="0"/>
           </a:p>
@@ -1941,8 +1941,8 @@
         </p:nvSpPr>
         <p:spPr>
           <a:xfrm>
-            <a:off x="2560320" y="2971800"/>
-            <a:ext cx="2194560" cy="137160"/>
+            <a:off x="2743200" y="2679192"/>
+            <a:ext cx="2194560" cy="128016"/>
           </a:xfrm>
           <a:prstGeom prst="rect">
             <a:avLst/>
@@ -1960,13 +1960,13 @@
             <a:r>
               <a:rPr lang="en-US" sz="900" b="1" dirty="0">
                 <a:solidFill>
-                  <a:srgbClr val="1E40AF"/>
-                </a:solidFill>
-                <a:latin typeface="Calibri" pitchFamily="34" charset="0"/>
-                <a:ea typeface="Calibri" pitchFamily="34" charset="-122"/>
-                <a:cs typeface="Calibri" pitchFamily="34" charset="-120"/>
-              </a:rPr>
-              <a:t>⚡ Liquidity Buffer</a:t>
+                  <a:srgbClr val="2563EB"/>
+                </a:solidFill>
+                <a:latin typeface="Arial" pitchFamily="34" charset="0"/>
+                <a:ea typeface="Arial" pitchFamily="34" charset="-122"/>
+                <a:cs typeface="Arial" pitchFamily="34" charset="-120"/>
+              </a:rPr>
+              <a:t>Liquidity Buffer</a:t>
             </a:r>
             <a:endParaRPr lang="en-US" sz="900" dirty="0"/>
           </a:p>
@@ -1980,8 +1980,8 @@
         </p:nvSpPr>
         <p:spPr>
           <a:xfrm>
-            <a:off x="2560320" y="3108960"/>
-            <a:ext cx="2194560" cy="320040"/>
+            <a:off x="2743200" y="2807208"/>
+            <a:ext cx="2194560" cy="256032"/>
           </a:xfrm>
           <a:prstGeom prst="rect">
             <a:avLst/>
@@ -2001,11 +2001,11 @@
                 <a:solidFill>
                   <a:srgbClr val="4B5563"/>
                 </a:solidFill>
-                <a:latin typeface="Calibri" pitchFamily="34" charset="0"/>
-                <a:ea typeface="Calibri" pitchFamily="34" charset="-122"/>
-                <a:cs typeface="Calibri" pitchFamily="34" charset="-120"/>
-              </a:rPr>
-              <a:t>Additional LCR source without bank dependence</a:t>
+                <a:latin typeface="Arial" pitchFamily="34" charset="0"/>
+                <a:ea typeface="Arial" pitchFamily="34" charset="-122"/>
+                <a:cs typeface="Arial" pitchFamily="34" charset="-120"/>
+              </a:rPr>
+              <a:t>LCR source without bank dependence</a:t>
             </a:r>
             <a:endParaRPr lang="en-US" sz="800" dirty="0"/>
           </a:p>
@@ -2019,8 +2019,8 @@
         </p:nvSpPr>
         <p:spPr>
           <a:xfrm>
-            <a:off x="365760" y="3383280"/>
-            <a:ext cx="2011680" cy="137160"/>
+            <a:off x="594360" y="3081528"/>
+            <a:ext cx="2011680" cy="128016"/>
           </a:xfrm>
           <a:prstGeom prst="rect">
             <a:avLst/>
@@ -2038,13 +2038,13 @@
             <a:r>
               <a:rPr lang="en-US" sz="900" b="1" dirty="0">
                 <a:solidFill>
-                  <a:srgbClr val="1E40AF"/>
-                </a:solidFill>
-                <a:latin typeface="Calibri" pitchFamily="34" charset="0"/>
-                <a:ea typeface="Calibri" pitchFamily="34" charset="-122"/>
-                <a:cs typeface="Calibri" pitchFamily="34" charset="-120"/>
-              </a:rPr>
-              <a:t>💹 Rate Transmission</a:t>
+                  <a:srgbClr val="2563EB"/>
+                </a:solidFill>
+                <a:latin typeface="Arial" pitchFamily="34" charset="0"/>
+                <a:ea typeface="Arial" pitchFamily="34" charset="-122"/>
+                <a:cs typeface="Arial" pitchFamily="34" charset="-120"/>
+              </a:rPr>
+              <a:t>Rate Transmission</a:t>
             </a:r>
             <a:endParaRPr lang="en-US" sz="900" dirty="0"/>
           </a:p>
@@ -2058,8 +2058,8 @@
         </p:nvSpPr>
         <p:spPr>
           <a:xfrm>
-            <a:off x="365760" y="3520440"/>
-            <a:ext cx="2011680" cy="228600"/>
+            <a:off x="594360" y="3209544"/>
+            <a:ext cx="2011680" cy="201168"/>
           </a:xfrm>
           <a:prstGeom prst="rect">
             <a:avLst/>
@@ -2079,11 +2079,11 @@
                 <a:solidFill>
                   <a:srgbClr val="4B5563"/>
                 </a:solidFill>
-                <a:latin typeface="Calibri" pitchFamily="34" charset="0"/>
-                <a:ea typeface="Calibri" pitchFamily="34" charset="-122"/>
-                <a:cs typeface="Calibri" pitchFamily="34" charset="-120"/>
-              </a:rPr>
-              <a:t>MIBOR-linked rates vs slower MCLR</a:t>
+                <a:latin typeface="Arial" pitchFamily="34" charset="0"/>
+                <a:ea typeface="Arial" pitchFamily="34" charset="-122"/>
+                <a:cs typeface="Arial" pitchFamily="34" charset="-120"/>
+              </a:rPr>
+              <a:t>MIBOR-linked vs slower MCLR</a:t>
             </a:r>
             <a:endParaRPr lang="en-US" sz="800" dirty="0"/>
           </a:p>
@@ -2097,8 +2097,8 @@
         </p:nvSpPr>
         <p:spPr>
           <a:xfrm>
-            <a:off x="2560320" y="3383280"/>
-            <a:ext cx="2194560" cy="137160"/>
+            <a:off x="2743200" y="3081528"/>
+            <a:ext cx="2194560" cy="128016"/>
           </a:xfrm>
           <a:prstGeom prst="rect">
             <a:avLst/>
@@ -2116,13 +2116,13 @@
             <a:r>
               <a:rPr lang="en-US" sz="900" b="1" dirty="0">
                 <a:solidFill>
-                  <a:srgbClr val="1E40AF"/>
-                </a:solidFill>
-                <a:latin typeface="Calibri" pitchFamily="34" charset="0"/>
-                <a:ea typeface="Calibri" pitchFamily="34" charset="-122"/>
-                <a:cs typeface="Calibri" pitchFamily="34" charset="-120"/>
-              </a:rPr>
-              <a:t>🔄 Roll-over Efficiency</a:t>
+                  <a:srgbClr val="2563EB"/>
+                </a:solidFill>
+                <a:latin typeface="Arial" pitchFamily="34" charset="0"/>
+                <a:ea typeface="Arial" pitchFamily="34" charset="-122"/>
+                <a:cs typeface="Arial" pitchFamily="34" charset="-120"/>
+              </a:rPr>
+              <a:t>Roll-over Efficiency</a:t>
             </a:r>
             <a:endParaRPr lang="en-US" sz="900" dirty="0"/>
           </a:p>
@@ -2136,8 +2136,8 @@
         </p:nvSpPr>
         <p:spPr>
           <a:xfrm>
-            <a:off x="2560320" y="3520440"/>
-            <a:ext cx="2194560" cy="228600"/>
+            <a:off x="2743200" y="3209544"/>
+            <a:ext cx="2194560" cy="201168"/>
           </a:xfrm>
           <a:prstGeom prst="rect">
             <a:avLst/>
@@ -2157,11 +2157,11 @@
                 <a:solidFill>
                   <a:srgbClr val="4B5563"/>
                 </a:solidFill>
-                <a:latin typeface="Calibri" pitchFamily="34" charset="0"/>
-                <a:ea typeface="Calibri" pitchFamily="34" charset="-122"/>
-                <a:cs typeface="Calibri" pitchFamily="34" charset="-120"/>
-              </a:rPr>
-              <a:t>Reduced refinancing risk vs short-term CP</a:t>
+                <a:latin typeface="Arial" pitchFamily="34" charset="0"/>
+                <a:ea typeface="Arial" pitchFamily="34" charset="-122"/>
+                <a:cs typeface="Arial" pitchFamily="34" charset="-120"/>
+              </a:rPr>
+              <a:t>Reduced refinancing risk vs CP</a:t>
             </a:r>
             <a:endParaRPr lang="en-US" sz="800" dirty="0"/>
           </a:p>
@@ -2175,12 +2175,12 @@
         </p:nvSpPr>
         <p:spPr>
           <a:xfrm>
-            <a:off x="5074920" y="2697480"/>
-            <a:ext cx="3520440" cy="1143000"/>
+            <a:off x="5257800" y="2423160"/>
+            <a:ext cx="3657600" cy="1051560"/>
           </a:xfrm>
           <a:prstGeom prst="roundRect">
             <a:avLst>
-              <a:gd name="adj" fmla="val 3200"/>
+              <a:gd name="adj" fmla="val 2609"/>
             </a:avLst>
           </a:prstGeom>
           <a:solidFill>
@@ -2188,7 +2188,7 @@
           </a:solidFill>
           <a:ln w="12700">
             <a:solidFill>
-              <a:srgbClr val="FCD34D"/>
+              <a:srgbClr val="FDE68A"/>
             </a:solidFill>
             <a:prstDash val="solid"/>
           </a:ln>
@@ -2202,8 +2202,8 @@
         </p:nvSpPr>
         <p:spPr>
           <a:xfrm>
-            <a:off x="5074920" y="2697480"/>
-            <a:ext cx="3520440" cy="201168"/>
+            <a:off x="5257800" y="2423160"/>
+            <a:ext cx="3657600" cy="182880"/>
           </a:xfrm>
           <a:prstGeom prst="rect">
             <a:avLst/>
@@ -2222,34 +2222,34 @@
         </p:nvSpPr>
         <p:spPr>
           <a:xfrm>
-            <a:off x="5166360" y="2724912"/>
-            <a:ext cx="3337560" cy="146304"/>
-          </a:xfrm>
-          <a:prstGeom prst="rect">
-            <a:avLst/>
-          </a:prstGeom>
-          <a:noFill/>
-          <a:ln/>
-        </p:spPr>
-        <p:txBody>
-          <a:bodyPr wrap="square" rtlCol="0" anchor="ctr"/>
-          <a:lstStyle/>
-          <a:p>
-            <a:pPr indent="0" marL="0">
-              <a:buNone/>
-            </a:pPr>
-            <a:r>
-              <a:rPr lang="en-US" sz="1000" b="1" dirty="0">
-                <a:solidFill>
-                  <a:srgbClr val="FFFFFF"/>
-                </a:solidFill>
-                <a:latin typeface="Calibri" pitchFamily="34" charset="0"/>
-                <a:ea typeface="Calibri" pitchFamily="34" charset="-122"/>
-                <a:cs typeface="Calibri" pitchFamily="34" charset="-120"/>
-              </a:rPr>
-              <a:t>⚡ Immediate Actions (Next 30 Days)</a:t>
-            </a:r>
-            <a:endParaRPr lang="en-US" sz="1000" dirty="0"/>
+            <a:off x="5349240" y="2450592"/>
+            <a:ext cx="3474720" cy="137160"/>
+          </a:xfrm>
+          <a:prstGeom prst="rect">
+            <a:avLst/>
+          </a:prstGeom>
+          <a:noFill/>
+          <a:ln/>
+        </p:spPr>
+        <p:txBody>
+          <a:bodyPr wrap="square" rtlCol="0" anchor="ctr"/>
+          <a:lstStyle/>
+          <a:p>
+            <a:pPr indent="0" marL="0">
+              <a:buNone/>
+            </a:pPr>
+            <a:r>
+              <a:rPr lang="en-US" sz="900" b="1" dirty="0">
+                <a:solidFill>
+                  <a:srgbClr val="78350F"/>
+                </a:solidFill>
+                <a:latin typeface="Arial" pitchFamily="34" charset="0"/>
+                <a:ea typeface="Arial" pitchFamily="34" charset="-122"/>
+                <a:cs typeface="Arial" pitchFamily="34" charset="-120"/>
+              </a:rPr>
+              <a:t>Immediate Actions (30 Days)</a:t>
+            </a:r>
+            <a:endParaRPr lang="en-US" sz="900" dirty="0"/>
           </a:p>
         </p:txBody>
       </p:sp>
@@ -2261,12 +2261,12 @@
         </p:nvSpPr>
         <p:spPr>
           <a:xfrm>
-            <a:off x="5212080" y="2990088"/>
-            <a:ext cx="365760" cy="128016"/>
+            <a:off x="5349240" y="2679192"/>
+            <a:ext cx="320040" cy="118872"/>
           </a:xfrm>
           <a:prstGeom prst="roundRect">
             <a:avLst>
-              <a:gd name="adj" fmla="val 14286"/>
+              <a:gd name="adj" fmla="val 15385"/>
             </a:avLst>
           </a:prstGeom>
           <a:solidFill>
@@ -2283,8 +2283,8 @@
         </p:nvSpPr>
         <p:spPr>
           <a:xfrm>
-            <a:off x="5212080" y="2990088"/>
-            <a:ext cx="365760" cy="128016"/>
+            <a:off x="5349240" y="2679192"/>
+            <a:ext cx="320040" cy="118872"/>
           </a:xfrm>
           <a:prstGeom prst="rect">
             <a:avLst/>
@@ -2304,9 +2304,9 @@
                 <a:solidFill>
                   <a:srgbClr val="FFFFFF"/>
                 </a:solidFill>
-                <a:latin typeface="Calibri" pitchFamily="34" charset="0"/>
-                <a:ea typeface="Calibri" pitchFamily="34" charset="-122"/>
-                <a:cs typeface="Calibri" pitchFamily="34" charset="-120"/>
+                <a:latin typeface="Arial" pitchFamily="34" charset="0"/>
+                <a:ea typeface="Arial" pitchFamily="34" charset="-122"/>
+                <a:cs typeface="Arial" pitchFamily="34" charset="-120"/>
               </a:rPr>
               <a:t>HIGH</a:t>
             </a:r>
@@ -2322,8 +2322,8 @@
         </p:nvSpPr>
         <p:spPr>
           <a:xfrm>
-            <a:off x="5669280" y="2990088"/>
-            <a:ext cx="2743200" cy="128016"/>
+            <a:off x="5760720" y="2679192"/>
+            <a:ext cx="3017520" cy="118872"/>
           </a:xfrm>
           <a:prstGeom prst="rect">
             <a:avLst/>
@@ -2343,9 +2343,9 @@
                 <a:solidFill>
                   <a:srgbClr val="374151"/>
                 </a:solidFill>
-                <a:latin typeface="Calibri" pitchFamily="34" charset="0"/>
-                <a:ea typeface="Calibri" pitchFamily="34" charset="-122"/>
-                <a:cs typeface="Calibri" pitchFamily="34" charset="-120"/>
+                <a:latin typeface="Arial" pitchFamily="34" charset="0"/>
+                <a:ea typeface="Arial" pitchFamily="34" charset="-122"/>
+                <a:cs typeface="Arial" pitchFamily="34" charset="-120"/>
               </a:rPr>
               <a:t>CCIL/NDS-OM Registration</a:t>
             </a:r>
@@ -2361,12 +2361,12 @@
         </p:nvSpPr>
         <p:spPr>
           <a:xfrm>
-            <a:off x="5212080" y="3182112"/>
-            <a:ext cx="365760" cy="128016"/>
+            <a:off x="5349240" y="2852928"/>
+            <a:ext cx="320040" cy="118872"/>
           </a:xfrm>
           <a:prstGeom prst="roundRect">
             <a:avLst>
-              <a:gd name="adj" fmla="val 14286"/>
+              <a:gd name="adj" fmla="val 15385"/>
             </a:avLst>
           </a:prstGeom>
           <a:solidFill>
@@ -2383,8 +2383,8 @@
         </p:nvSpPr>
         <p:spPr>
           <a:xfrm>
-            <a:off x="5212080" y="3182112"/>
-            <a:ext cx="365760" cy="128016"/>
+            <a:off x="5349240" y="2852928"/>
+            <a:ext cx="320040" cy="118872"/>
           </a:xfrm>
           <a:prstGeom prst="rect">
             <a:avLst/>
@@ -2404,9 +2404,9 @@
                 <a:solidFill>
                   <a:srgbClr val="FFFFFF"/>
                 </a:solidFill>
-                <a:latin typeface="Calibri" pitchFamily="34" charset="0"/>
-                <a:ea typeface="Calibri" pitchFamily="34" charset="-122"/>
-                <a:cs typeface="Calibri" pitchFamily="34" charset="-120"/>
+                <a:latin typeface="Arial" pitchFamily="34" charset="0"/>
+                <a:ea typeface="Arial" pitchFamily="34" charset="-122"/>
+                <a:cs typeface="Arial" pitchFamily="34" charset="-120"/>
               </a:rPr>
               <a:t>HIGH</a:t>
             </a:r>
@@ -2422,8 +2422,8 @@
         </p:nvSpPr>
         <p:spPr>
           <a:xfrm>
-            <a:off x="5669280" y="3182112"/>
-            <a:ext cx="2743200" cy="128016"/>
+            <a:off x="5760720" y="2852928"/>
+            <a:ext cx="3017520" cy="118872"/>
           </a:xfrm>
           <a:prstGeom prst="rect">
             <a:avLst/>
@@ -2443,11 +2443,11 @@
                 <a:solidFill>
                   <a:srgbClr val="374151"/>
                 </a:solidFill>
-                <a:latin typeface="Calibri" pitchFamily="34" charset="0"/>
-                <a:ea typeface="Calibri" pitchFamily="34" charset="-122"/>
-                <a:cs typeface="Calibri" pitchFamily="34" charset="-120"/>
-              </a:rPr>
-              <a:t>Update Treasury Policy Framework</a:t>
+                <a:latin typeface="Arial" pitchFamily="34" charset="0"/>
+                <a:ea typeface="Arial" pitchFamily="34" charset="-122"/>
+                <a:cs typeface="Arial" pitchFamily="34" charset="-120"/>
+              </a:rPr>
+              <a:t>Update Treasury Policy</a:t>
             </a:r>
             <a:endParaRPr lang="en-US" sz="900" dirty="0"/>
           </a:p>
@@ -2461,12 +2461,12 @@
         </p:nvSpPr>
         <p:spPr>
           <a:xfrm>
-            <a:off x="5212080" y="3374136"/>
-            <a:ext cx="365760" cy="128016"/>
+            <a:off x="5349240" y="3026664"/>
+            <a:ext cx="320040" cy="118872"/>
           </a:xfrm>
           <a:prstGeom prst="roundRect">
             <a:avLst>
-              <a:gd name="adj" fmla="val 14286"/>
+              <a:gd name="adj" fmla="val 15385"/>
             </a:avLst>
           </a:prstGeom>
           <a:solidFill>
@@ -2483,8 +2483,8 @@
         </p:nvSpPr>
         <p:spPr>
           <a:xfrm>
-            <a:off x="5212080" y="3374136"/>
-            <a:ext cx="365760" cy="128016"/>
+            <a:off x="5349240" y="3026664"/>
+            <a:ext cx="320040" cy="118872"/>
           </a:xfrm>
           <a:prstGeom prst="rect">
             <a:avLst/>
@@ -2504,9 +2504,9 @@
                 <a:solidFill>
                   <a:srgbClr val="FFFFFF"/>
                 </a:solidFill>
-                <a:latin typeface="Calibri" pitchFamily="34" charset="0"/>
-                <a:ea typeface="Calibri" pitchFamily="34" charset="-122"/>
-                <a:cs typeface="Calibri" pitchFamily="34" charset="-120"/>
+                <a:latin typeface="Arial" pitchFamily="34" charset="0"/>
+                <a:ea typeface="Arial" pitchFamily="34" charset="-122"/>
+                <a:cs typeface="Arial" pitchFamily="34" charset="-120"/>
               </a:rPr>
               <a:t>MED</a:t>
             </a:r>
@@ -2522,8 +2522,8 @@
         </p:nvSpPr>
         <p:spPr>
           <a:xfrm>
-            <a:off x="5669280" y="3374136"/>
-            <a:ext cx="2743200" cy="128016"/>
+            <a:off x="5760720" y="3026664"/>
+            <a:ext cx="3017520" cy="118872"/>
           </a:xfrm>
           <a:prstGeom prst="rect">
             <a:avLst/>
@@ -2543,11 +2543,11 @@
                 <a:solidFill>
                   <a:srgbClr val="374151"/>
                 </a:solidFill>
-                <a:latin typeface="Calibri" pitchFamily="34" charset="0"/>
-                <a:ea typeface="Calibri" pitchFamily="34" charset="-122"/>
-                <a:cs typeface="Calibri" pitchFamily="34" charset="-120"/>
-              </a:rPr>
-              <a:t>Trading Infrastructure Setup</a:t>
+                <a:latin typeface="Arial" pitchFamily="34" charset="0"/>
+                <a:ea typeface="Arial" pitchFamily="34" charset="-122"/>
+                <a:cs typeface="Arial" pitchFamily="34" charset="-120"/>
+              </a:rPr>
+              <a:t>Trading Infrastructure</a:t>
             </a:r>
             <a:endParaRPr lang="en-US" sz="900" dirty="0"/>
           </a:p>
@@ -2561,16 +2561,14 @@
         </p:nvSpPr>
         <p:spPr>
           <a:xfrm>
-            <a:off x="5212080" y="3566160"/>
-            <a:ext cx="365760" cy="128016"/>
-          </a:xfrm>
-          <a:prstGeom prst="roundRect">
-            <a:avLst>
-              <a:gd name="adj" fmla="val 14286"/>
-            </a:avLst>
-          </a:prstGeom>
-          <a:solidFill>
-            <a:srgbClr val="D97706"/>
+            <a:off x="0" y="4572000"/>
+            <a:ext cx="9144000" cy="228600"/>
+          </a:xfrm>
+          <a:prstGeom prst="rect">
+            <a:avLst/>
+          </a:prstGeom>
+          <a:solidFill>
+            <a:srgbClr val="1E3A8A"/>
           </a:solidFill>
           <a:ln/>
         </p:spPr>
@@ -2583,34 +2581,34 @@
         </p:nvSpPr>
         <p:spPr>
           <a:xfrm>
-            <a:off x="5212080" y="3566160"/>
-            <a:ext cx="365760" cy="128016"/>
-          </a:xfrm>
-          <a:prstGeom prst="rect">
-            <a:avLst/>
-          </a:prstGeom>
-          <a:noFill/>
-          <a:ln/>
-        </p:spPr>
-        <p:txBody>
-          <a:bodyPr wrap="square" rtlCol="0" anchor="ctr"/>
-          <a:lstStyle/>
-          <a:p>
-            <a:pPr algn="ctr" indent="0" marL="0">
-              <a:buNone/>
-            </a:pPr>
-            <a:r>
-              <a:rPr lang="en-US" sz="600" b="1" dirty="0">
-                <a:solidFill>
-                  <a:srgbClr val="FFFFFF"/>
-                </a:solidFill>
-                <a:latin typeface="Calibri" pitchFamily="34" charset="0"/>
-                <a:ea typeface="Calibri" pitchFamily="34" charset="-122"/>
-                <a:cs typeface="Calibri" pitchFamily="34" charset="-120"/>
-              </a:rPr>
-              <a:t>MED</a:t>
-            </a:r>
-            <a:endParaRPr lang="en-US" sz="600" dirty="0"/>
+            <a:off x="457200" y="4599432"/>
+            <a:ext cx="8229600" cy="91440"/>
+          </a:xfrm>
+          <a:prstGeom prst="rect">
+            <a:avLst/>
+          </a:prstGeom>
+          <a:noFill/>
+          <a:ln/>
+        </p:spPr>
+        <p:txBody>
+          <a:bodyPr wrap="square" rtlCol="0" anchor="ctr"/>
+          <a:lstStyle/>
+          <a:p>
+            <a:pPr indent="0" marL="0">
+              <a:buNone/>
+            </a:pPr>
+            <a:r>
+              <a:rPr lang="en-US" sz="800" dirty="0">
+                <a:solidFill>
+                  <a:srgbClr val="E0E7FF"/>
+                </a:solidFill>
+                <a:latin typeface="Arial" pitchFamily="34" charset="0"/>
+                <a:ea typeface="Arial" pitchFamily="34" charset="-122"/>
+                <a:cs typeface="Arial" pitchFamily="34" charset="-120"/>
+              </a:rPr>
+              <a:t>Hero FinCorp Treasury | RBI Circular: April 9, 2026 | Internal Use Only</a:t>
+            </a:r>
+            <a:endParaRPr lang="en-US" sz="800" dirty="0"/>
           </a:p>
         </p:txBody>
       </p:sp>
@@ -2622,105 +2620,7 @@
         </p:nvSpPr>
         <p:spPr>
           <a:xfrm>
-            <a:off x="5669280" y="3566160"/>
-            <a:ext cx="2743200" cy="128016"/>
-          </a:xfrm>
-          <a:prstGeom prst="rect">
-            <a:avLst/>
-          </a:prstGeom>
-          <a:noFill/>
-          <a:ln/>
-        </p:spPr>
-        <p:txBody>
-          <a:bodyPr wrap="square" rtlCol="0" anchor="ctr"/>
-          <a:lstStyle/>
-          <a:p>
-            <a:pPr indent="0" marL="0">
-              <a:buNone/>
-            </a:pPr>
-            <a:r>
-              <a:rPr lang="en-US" sz="900" dirty="0">
-                <a:solidFill>
-                  <a:srgbClr val="374151"/>
-                </a:solidFill>
-                <a:latin typeface="Calibri" pitchFamily="34" charset="0"/>
-                <a:ea typeface="Calibri" pitchFamily="34" charset="-122"/>
-                <a:cs typeface="Calibri" pitchFamily="34" charset="-120"/>
-              </a:rPr>
-              <a:t>Counterparty Due Diligence</a:t>
-            </a:r>
-            <a:endParaRPr lang="en-US" sz="900" dirty="0"/>
-          </a:p>
-        </p:txBody>
-      </p:sp>
-      <p:sp>
-        <p:nvSpPr>
-          <p:cNvPr id="51" name="Shape 49"/>
-          <p:cNvSpPr/>
-          <p:nvPr/>
-        </p:nvSpPr>
-        <p:spPr>
-          <a:xfrm>
-            <a:off x="0" y="4023360"/>
-            <a:ext cx="9144000" cy="256032"/>
-          </a:xfrm>
-          <a:prstGeom prst="rect">
-            <a:avLst/>
-          </a:prstGeom>
-          <a:solidFill>
-            <a:srgbClr val="1E2761"/>
-          </a:solidFill>
-          <a:ln/>
-        </p:spPr>
-      </p:sp>
-      <p:sp>
-        <p:nvSpPr>
-          <p:cNvPr id="52" name="Text 50"/>
-          <p:cNvSpPr/>
-          <p:nvPr/>
-        </p:nvSpPr>
-        <p:spPr>
-          <a:xfrm>
-            <a:off x="274320" y="4050792"/>
-            <a:ext cx="8229600" cy="109728"/>
-          </a:xfrm>
-          <a:prstGeom prst="rect">
-            <a:avLst/>
-          </a:prstGeom>
-          <a:noFill/>
-          <a:ln/>
-        </p:spPr>
-        <p:txBody>
-          <a:bodyPr wrap="square" rtlCol="0" anchor="ctr"/>
-          <a:lstStyle/>
-          <a:p>
-            <a:pPr indent="0" marL="0">
-              <a:buNone/>
-            </a:pPr>
-            <a:r>
-              <a:rPr lang="en-US" sz="800" dirty="0">
-                <a:solidFill>
-                  <a:srgbClr val="CADCFC"/>
-                </a:solidFill>
-                <a:latin typeface="Calibri" pitchFamily="34" charset="0"/>
-                <a:ea typeface="Calibri" pitchFamily="34" charset="-122"/>
-                <a:cs typeface="Calibri" pitchFamily="34" charset="-120"/>
-              </a:rPr>
-              <a:t>Hero FinCorp Treasury | RBI Circular: April 9, 2026 | Internal Use Only</a:t>
-            </a:r>
-            <a:endParaRPr lang="en-US" sz="800" dirty="0"/>
-          </a:p>
-        </p:txBody>
-      </p:sp>
-      <p:sp>
-        <p:nvSpPr>
-          <p:cNvPr id="53" name="Text 51"/>
-          <p:cNvSpPr/>
-          <p:nvPr/>
-        </p:nvSpPr>
-        <p:spPr>
-          <a:xfrm>
-            <a:off x="274320" y="4160520"/>
+            <a:off x="457200" y="4690872"/>
             <a:ext cx="8229600" cy="91440"/>
           </a:xfrm>
           <a:prstGeom prst="rect">
@@ -2739,11 +2639,11 @@
             <a:r>
               <a:rPr lang="en-US" sz="700" i="1" dirty="0">
                 <a:solidFill>
-                  <a:srgbClr val="9CA3AF"/>
-                </a:solidFill>
-                <a:latin typeface="Calibri" pitchFamily="34" charset="0"/>
-                <a:ea typeface="Calibri" pitchFamily="34" charset="-122"/>
-                <a:cs typeface="Calibri" pitchFamily="34" charset="-120"/>
+                  <a:srgbClr val="94A3B8"/>
+                </a:solidFill>
+                <a:latin typeface="Arial" pitchFamily="34" charset="0"/>
+                <a:ea typeface="Arial" pitchFamily="34" charset="-122"/>
+                <a:cs typeface="Arial" pitchFamily="34" charset="-120"/>
               </a:rPr>
               <a:t>Projections are estimates based on market conditions.</a:t>
             </a:r>

</xml_diff>

<commit_message>
Fix PowerPoint v5 - resolved header overlap, increased footer height, verified margins
</commit_message>
<xml_diff>
--- a/RBI_Term_Money_Market_HeroFinCorp_Analysis.pptx
+++ b/RBI_Term_Money_Market_HeroFinCorp_Analysis.pptx
@@ -884,7 +884,7 @@
         <p:spPr>
           <a:xfrm>
             <a:off x="0" y="0"/>
-            <a:ext cx="9144000" cy="457200"/>
+            <a:ext cx="9144000" cy="411480"/>
           </a:xfrm>
           <a:prstGeom prst="rect">
             <a:avLst/>
@@ -903,8 +903,8 @@
         </p:nvSpPr>
         <p:spPr>
           <a:xfrm>
-            <a:off x="457200" y="118872"/>
-            <a:ext cx="8229600" cy="274320"/>
+            <a:off x="274320" y="91440"/>
+            <a:ext cx="7772400" cy="228600"/>
           </a:xfrm>
           <a:prstGeom prst="rect">
             <a:avLst/>
@@ -928,7 +928,7 @@
                 <a:ea typeface="Arial" pitchFamily="34" charset="-122"/>
                 <a:cs typeface="Arial" pitchFamily="34" charset="-120"/>
               </a:rPr>
-              <a:t>RBI Term Money Market Expansion — Hero FinCorp Impact Analysis</a:t>
+              <a:t>RBI Term Money Market Expansion — Hero FinCorp Impact</a:t>
             </a:r>
             <a:endParaRPr lang="en-US" sz="1400" dirty="0"/>
           </a:p>
@@ -942,8 +942,8 @@
         </p:nvSpPr>
         <p:spPr>
           <a:xfrm>
-            <a:off x="7772400" y="118872"/>
-            <a:ext cx="1371600" cy="274320"/>
+            <a:off x="7772400" y="91440"/>
+            <a:ext cx="1371600" cy="228600"/>
           </a:xfrm>
           <a:prstGeom prst="rect">
             <a:avLst/>
@@ -981,7 +981,7 @@
         </p:nvSpPr>
         <p:spPr>
           <a:xfrm>
-            <a:off x="457200" y="548640"/>
+            <a:off x="274320" y="502920"/>
             <a:ext cx="1965960" cy="457200"/>
           </a:xfrm>
           <a:prstGeom prst="roundRect">
@@ -1008,8 +1008,8 @@
         </p:nvSpPr>
         <p:spPr>
           <a:xfrm>
-            <a:off x="548640" y="594360"/>
-            <a:ext cx="1783080" cy="228600"/>
+            <a:off x="365760" y="557784"/>
+            <a:ext cx="1783080" cy="201168"/>
           </a:xfrm>
           <a:prstGeom prst="rect">
             <a:avLst/>
@@ -1047,7 +1047,7 @@
         </p:nvSpPr>
         <p:spPr>
           <a:xfrm>
-            <a:off x="548640" y="804672"/>
+            <a:off x="365760" y="758952"/>
             <a:ext cx="1783080" cy="164592"/>
           </a:xfrm>
           <a:prstGeom prst="rect">
@@ -1086,7 +1086,7 @@
         </p:nvSpPr>
         <p:spPr>
           <a:xfrm>
-            <a:off x="2542032" y="548640"/>
+            <a:off x="2359152" y="502920"/>
             <a:ext cx="1965960" cy="457200"/>
           </a:xfrm>
           <a:prstGeom prst="roundRect">
@@ -1113,8 +1113,8 @@
         </p:nvSpPr>
         <p:spPr>
           <a:xfrm>
-            <a:off x="2633472" y="594360"/>
-            <a:ext cx="1783080" cy="228600"/>
+            <a:off x="2450592" y="557784"/>
+            <a:ext cx="1783080" cy="201168"/>
           </a:xfrm>
           <a:prstGeom prst="rect">
             <a:avLst/>
@@ -1152,7 +1152,7 @@
         </p:nvSpPr>
         <p:spPr>
           <a:xfrm>
-            <a:off x="2633472" y="804672"/>
+            <a:off x="2450592" y="758952"/>
             <a:ext cx="1783080" cy="164592"/>
           </a:xfrm>
           <a:prstGeom prst="rect">
@@ -1191,7 +1191,7 @@
         </p:nvSpPr>
         <p:spPr>
           <a:xfrm>
-            <a:off x="4626864" y="548640"/>
+            <a:off x="4443984" y="502920"/>
             <a:ext cx="1965960" cy="457200"/>
           </a:xfrm>
           <a:prstGeom prst="roundRect">
@@ -1218,8 +1218,8 @@
         </p:nvSpPr>
         <p:spPr>
           <a:xfrm>
-            <a:off x="4718304" y="594360"/>
-            <a:ext cx="1783080" cy="228600"/>
+            <a:off x="4535424" y="557784"/>
+            <a:ext cx="1783080" cy="201168"/>
           </a:xfrm>
           <a:prstGeom prst="rect">
             <a:avLst/>
@@ -1257,7 +1257,7 @@
         </p:nvSpPr>
         <p:spPr>
           <a:xfrm>
-            <a:off x="4718304" y="804672"/>
+            <a:off x="4535424" y="758952"/>
             <a:ext cx="1783080" cy="164592"/>
           </a:xfrm>
           <a:prstGeom prst="rect">
@@ -1296,7 +1296,7 @@
         </p:nvSpPr>
         <p:spPr>
           <a:xfrm>
-            <a:off x="6711696" y="548640"/>
+            <a:off x="6528816" y="502920"/>
             <a:ext cx="1965960" cy="457200"/>
           </a:xfrm>
           <a:prstGeom prst="roundRect">
@@ -1323,8 +1323,8 @@
         </p:nvSpPr>
         <p:spPr>
           <a:xfrm>
-            <a:off x="6803136" y="594360"/>
-            <a:ext cx="1783080" cy="228600"/>
+            <a:off x="6620256" y="557784"/>
+            <a:ext cx="1783080" cy="201168"/>
           </a:xfrm>
           <a:prstGeom prst="rect">
             <a:avLst/>
@@ -1362,7 +1362,7 @@
         </p:nvSpPr>
         <p:spPr>
           <a:xfrm>
-            <a:off x="6803136" y="804672"/>
+            <a:off x="6620256" y="758952"/>
             <a:ext cx="1783080" cy="164592"/>
           </a:xfrm>
           <a:prstGeom prst="rect">
@@ -1401,12 +1401,12 @@
         </p:nvSpPr>
         <p:spPr>
           <a:xfrm>
-            <a:off x="457200" y="1097280"/>
-            <a:ext cx="4069080" cy="1188720"/>
+            <a:off x="274320" y="1051560"/>
+            <a:ext cx="4114800" cy="1234440"/>
           </a:xfrm>
           <a:prstGeom prst="roundRect">
             <a:avLst>
-              <a:gd name="adj" fmla="val 2308"/>
+              <a:gd name="adj" fmla="val 2222"/>
             </a:avLst>
           </a:prstGeom>
           <a:solidFill>
@@ -1428,8 +1428,8 @@
         </p:nvSpPr>
         <p:spPr>
           <a:xfrm>
-            <a:off x="457200" y="1097280"/>
-            <a:ext cx="4069080" cy="201168"/>
+            <a:off x="274320" y="1051560"/>
+            <a:ext cx="4114800" cy="219456"/>
           </a:xfrm>
           <a:prstGeom prst="rect">
             <a:avLst/>
@@ -1448,24 +1448,24 @@
         </p:nvSpPr>
         <p:spPr>
           <a:xfrm>
-            <a:off x="548640" y="1124712"/>
-            <a:ext cx="3886200" cy="164592"/>
-          </a:xfrm>
-          <a:prstGeom prst="rect">
-            <a:avLst/>
-          </a:prstGeom>
-          <a:noFill/>
-          <a:ln/>
-        </p:spPr>
-        <p:txBody>
-          <a:bodyPr wrap="square" rtlCol="0" anchor="ctr"/>
-          <a:lstStyle/>
-          <a:p>
-            <a:pPr indent="0" marL="0">
-              <a:buNone/>
-            </a:pPr>
-            <a:r>
-              <a:rPr lang="en-US" sz="900" b="1" dirty="0">
+            <a:off x="365760" y="1088136"/>
+            <a:ext cx="3931920" cy="164592"/>
+          </a:xfrm>
+          <a:prstGeom prst="rect">
+            <a:avLst/>
+          </a:prstGeom>
+          <a:noFill/>
+          <a:ln/>
+        </p:spPr>
+        <p:txBody>
+          <a:bodyPr wrap="square" rtlCol="0" anchor="ctr"/>
+          <a:lstStyle/>
+          <a:p>
+            <a:pPr indent="0" marL="0">
+              <a:buNone/>
+            </a:pPr>
+            <a:r>
+              <a:rPr lang="en-US" sz="1000" b="1" dirty="0">
                 <a:solidFill>
                   <a:srgbClr val="FFFFFF"/>
                 </a:solidFill>
@@ -1475,7 +1475,7 @@
               </a:rPr>
               <a:t>PRE-EXPANSION</a:t>
             </a:r>
-            <a:endParaRPr lang="en-US" sz="900" dirty="0"/>
+            <a:endParaRPr lang="en-US" sz="1000" dirty="0"/>
           </a:p>
         </p:txBody>
       </p:sp>
@@ -1487,8 +1487,8 @@
         </p:nvSpPr>
         <p:spPr>
           <a:xfrm>
-            <a:off x="548640" y="1353312"/>
-            <a:ext cx="3886200" cy="868680"/>
+            <a:off x="365760" y="1325880"/>
+            <a:ext cx="3931920" cy="868680"/>
           </a:xfrm>
           <a:prstGeom prst="rect">
             <a:avLst/>
@@ -1589,12 +1589,12 @@
         </p:nvSpPr>
         <p:spPr>
           <a:xfrm>
-            <a:off x="4709160" y="1097280"/>
-            <a:ext cx="4069080" cy="1188720"/>
+            <a:off x="4572000" y="1051560"/>
+            <a:ext cx="4114800" cy="1234440"/>
           </a:xfrm>
           <a:prstGeom prst="roundRect">
             <a:avLst>
-              <a:gd name="adj" fmla="val 2308"/>
+              <a:gd name="adj" fmla="val 2222"/>
             </a:avLst>
           </a:prstGeom>
           <a:solidFill>
@@ -1616,8 +1616,8 @@
         </p:nvSpPr>
         <p:spPr>
           <a:xfrm>
-            <a:off x="4709160" y="1097280"/>
-            <a:ext cx="4069080" cy="201168"/>
+            <a:off x="4572000" y="1051560"/>
+            <a:ext cx="4114800" cy="219456"/>
           </a:xfrm>
           <a:prstGeom prst="rect">
             <a:avLst/>
@@ -1636,24 +1636,24 @@
         </p:nvSpPr>
         <p:spPr>
           <a:xfrm>
-            <a:off x="4800600" y="1124712"/>
-            <a:ext cx="3886200" cy="164592"/>
-          </a:xfrm>
-          <a:prstGeom prst="rect">
-            <a:avLst/>
-          </a:prstGeom>
-          <a:noFill/>
-          <a:ln/>
-        </p:spPr>
-        <p:txBody>
-          <a:bodyPr wrap="square" rtlCol="0" anchor="ctr"/>
-          <a:lstStyle/>
-          <a:p>
-            <a:pPr indent="0" marL="0">
-              <a:buNone/>
-            </a:pPr>
-            <a:r>
-              <a:rPr lang="en-US" sz="900" b="1" dirty="0">
+            <a:off x="4663440" y="1088136"/>
+            <a:ext cx="3931920" cy="164592"/>
+          </a:xfrm>
+          <a:prstGeom prst="rect">
+            <a:avLst/>
+          </a:prstGeom>
+          <a:noFill/>
+          <a:ln/>
+        </p:spPr>
+        <p:txBody>
+          <a:bodyPr wrap="square" rtlCol="0" anchor="ctr"/>
+          <a:lstStyle/>
+          <a:p>
+            <a:pPr indent="0" marL="0">
+              <a:buNone/>
+            </a:pPr>
+            <a:r>
+              <a:rPr lang="en-US" sz="1000" b="1" dirty="0">
                 <a:solidFill>
                   <a:srgbClr val="FFFFFF"/>
                 </a:solidFill>
@@ -1663,7 +1663,7 @@
               </a:rPr>
               <a:t>POST-EXPANSION</a:t>
             </a:r>
-            <a:endParaRPr lang="en-US" sz="900" dirty="0"/>
+            <a:endParaRPr lang="en-US" sz="1000" dirty="0"/>
           </a:p>
         </p:txBody>
       </p:sp>
@@ -1675,8 +1675,8 @@
         </p:nvSpPr>
         <p:spPr>
           <a:xfrm>
-            <a:off x="4800600" y="1353312"/>
-            <a:ext cx="3886200" cy="868680"/>
+            <a:off x="4663440" y="1325880"/>
+            <a:ext cx="3931920" cy="868680"/>
           </a:xfrm>
           <a:prstGeom prst="rect">
             <a:avLst/>
@@ -1777,12 +1777,12 @@
         </p:nvSpPr>
         <p:spPr>
           <a:xfrm>
-            <a:off x="457200" y="2423160"/>
-            <a:ext cx="4663440" cy="1051560"/>
+            <a:off x="274320" y="2423160"/>
+            <a:ext cx="4572000" cy="1143000"/>
           </a:xfrm>
           <a:prstGeom prst="roundRect">
             <a:avLst>
-              <a:gd name="adj" fmla="val 2609"/>
+              <a:gd name="adj" fmla="val 2400"/>
             </a:avLst>
           </a:prstGeom>
           <a:solidFill>
@@ -1804,8 +1804,8 @@
         </p:nvSpPr>
         <p:spPr>
           <a:xfrm>
-            <a:off x="457200" y="2423160"/>
-            <a:ext cx="4663440" cy="182880"/>
+            <a:off x="274320" y="2423160"/>
+            <a:ext cx="4572000" cy="201168"/>
           </a:xfrm>
           <a:prstGeom prst="rect">
             <a:avLst/>
@@ -1824,8 +1824,47 @@
         </p:nvSpPr>
         <p:spPr>
           <a:xfrm>
-            <a:off x="548640" y="2450592"/>
-            <a:ext cx="4480560" cy="137160"/>
+            <a:off x="365760" y="2459736"/>
+            <a:ext cx="4389120" cy="137160"/>
+          </a:xfrm>
+          <a:prstGeom prst="rect">
+            <a:avLst/>
+          </a:prstGeom>
+          <a:noFill/>
+          <a:ln/>
+        </p:spPr>
+        <p:txBody>
+          <a:bodyPr wrap="square" rtlCol="0" anchor="ctr"/>
+          <a:lstStyle/>
+          <a:p>
+            <a:pPr indent="0" marL="0">
+              <a:buNone/>
+            </a:pPr>
+            <a:r>
+              <a:rPr lang="en-US" sz="1000" b="1" dirty="0">
+                <a:solidFill>
+                  <a:srgbClr val="FFFFFF"/>
+                </a:solidFill>
+                <a:latin typeface="Arial" pitchFamily="34" charset="0"/>
+                <a:ea typeface="Arial" pitchFamily="34" charset="-122"/>
+                <a:cs typeface="Arial" pitchFamily="34" charset="-120"/>
+              </a:rPr>
+              <a:t>Strategic Benefits</a:t>
+            </a:r>
+            <a:endParaRPr lang="en-US" sz="1000" dirty="0"/>
+          </a:p>
+        </p:txBody>
+      </p:sp>
+      <p:sp>
+        <p:nvSpPr>
+          <p:cNvPr id="28" name="Text 26"/>
+          <p:cNvSpPr/>
+          <p:nvPr/>
+        </p:nvSpPr>
+        <p:spPr>
+          <a:xfrm>
+            <a:off x="411480" y="2697480"/>
+            <a:ext cx="2011680" cy="137160"/>
           </a:xfrm>
           <a:prstGeom prst="rect">
             <a:avLst/>
@@ -1843,13 +1882,13 @@
             <a:r>
               <a:rPr lang="en-US" sz="900" b="1" dirty="0">
                 <a:solidFill>
-                  <a:srgbClr val="FFFFFF"/>
-                </a:solidFill>
-                <a:latin typeface="Arial" pitchFamily="34" charset="0"/>
-                <a:ea typeface="Arial" pitchFamily="34" charset="-122"/>
-                <a:cs typeface="Arial" pitchFamily="34" charset="-120"/>
-              </a:rPr>
-              <a:t>Strategic Benefits</a:t>
+                  <a:srgbClr val="2563EB"/>
+                </a:solidFill>
+                <a:latin typeface="Arial" pitchFamily="34" charset="0"/>
+                <a:ea typeface="Arial" pitchFamily="34" charset="-122"/>
+                <a:cs typeface="Arial" pitchFamily="34" charset="-120"/>
+              </a:rPr>
+              <a:t>ALM Optimization</a:t>
             </a:r>
             <a:endParaRPr lang="en-US" sz="900" dirty="0"/>
           </a:p>
@@ -1857,14 +1896,53 @@
       </p:sp>
       <p:sp>
         <p:nvSpPr>
-          <p:cNvPr id="28" name="Text 26"/>
-          <p:cNvSpPr/>
-          <p:nvPr/>
-        </p:nvSpPr>
-        <p:spPr>
-          <a:xfrm>
-            <a:off x="594360" y="2679192"/>
-            <a:ext cx="2011680" cy="128016"/>
+          <p:cNvPr id="29" name="Text 27"/>
+          <p:cNvSpPr/>
+          <p:nvPr/>
+        </p:nvSpPr>
+        <p:spPr>
+          <a:xfrm>
+            <a:off x="411480" y="2834640"/>
+            <a:ext cx="2011680" cy="228600"/>
+          </a:xfrm>
+          <a:prstGeom prst="rect">
+            <a:avLst/>
+          </a:prstGeom>
+          <a:noFill/>
+          <a:ln/>
+        </p:spPr>
+        <p:txBody>
+          <a:bodyPr wrap="square" rtlCol="0" anchor="ctr"/>
+          <a:lstStyle/>
+          <a:p>
+            <a:pPr indent="0" marL="0">
+              <a:buNone/>
+            </a:pPr>
+            <a:r>
+              <a:rPr lang="en-US" sz="800" dirty="0">
+                <a:solidFill>
+                  <a:srgbClr val="4B5563"/>
+                </a:solidFill>
+                <a:latin typeface="Arial" pitchFamily="34" charset="0"/>
+                <a:ea typeface="Arial" pitchFamily="34" charset="-122"/>
+                <a:cs typeface="Arial" pitchFamily="34" charset="-120"/>
+              </a:rPr>
+              <a:t>Granular tenor matching</a:t>
+            </a:r>
+            <a:endParaRPr lang="en-US" sz="800" dirty="0"/>
+          </a:p>
+        </p:txBody>
+      </p:sp>
+      <p:sp>
+        <p:nvSpPr>
+          <p:cNvPr id="30" name="Text 28"/>
+          <p:cNvSpPr/>
+          <p:nvPr/>
+        </p:nvSpPr>
+        <p:spPr>
+          <a:xfrm>
+            <a:off x="2560320" y="2697480"/>
+            <a:ext cx="2103120" cy="137160"/>
           </a:xfrm>
           <a:prstGeom prst="rect">
             <a:avLst/>
@@ -1888,7 +1966,7 @@
                 <a:ea typeface="Arial" pitchFamily="34" charset="-122"/>
                 <a:cs typeface="Arial" pitchFamily="34" charset="-120"/>
               </a:rPr>
-              <a:t>ALM Optimization</a:t>
+              <a:t>Liquidity Buffer</a:t>
             </a:r>
             <a:endParaRPr lang="en-US" sz="900" dirty="0"/>
           </a:p>
@@ -1896,14 +1974,14 @@
       </p:sp>
       <p:sp>
         <p:nvSpPr>
-          <p:cNvPr id="29" name="Text 27"/>
-          <p:cNvSpPr/>
-          <p:nvPr/>
-        </p:nvSpPr>
-        <p:spPr>
-          <a:xfrm>
-            <a:off x="594360" y="2807208"/>
-            <a:ext cx="2011680" cy="256032"/>
+          <p:cNvPr id="31" name="Text 29"/>
+          <p:cNvSpPr/>
+          <p:nvPr/>
+        </p:nvSpPr>
+        <p:spPr>
+          <a:xfrm>
+            <a:off x="2560320" y="2834640"/>
+            <a:ext cx="2103120" cy="228600"/>
           </a:xfrm>
           <a:prstGeom prst="rect">
             <a:avLst/>
@@ -1927,7 +2005,7 @@
                 <a:ea typeface="Arial" pitchFamily="34" charset="-122"/>
                 <a:cs typeface="Arial" pitchFamily="34" charset="-120"/>
               </a:rPr>
-              <a:t>Granular tenor matching for portfolios</a:t>
+              <a:t>LCR without bank dependence</a:t>
             </a:r>
             <a:endParaRPr lang="en-US" sz="800" dirty="0"/>
           </a:p>
@@ -1935,14 +2013,14 @@
       </p:sp>
       <p:sp>
         <p:nvSpPr>
-          <p:cNvPr id="30" name="Text 28"/>
-          <p:cNvSpPr/>
-          <p:nvPr/>
-        </p:nvSpPr>
-        <p:spPr>
-          <a:xfrm>
-            <a:off x="2743200" y="2679192"/>
-            <a:ext cx="2194560" cy="128016"/>
+          <p:cNvPr id="32" name="Text 30"/>
+          <p:cNvSpPr/>
+          <p:nvPr/>
+        </p:nvSpPr>
+        <p:spPr>
+          <a:xfrm>
+            <a:off x="411480" y="3108960"/>
+            <a:ext cx="2011680" cy="137160"/>
           </a:xfrm>
           <a:prstGeom prst="rect">
             <a:avLst/>
@@ -1966,7 +2044,7 @@
                 <a:ea typeface="Arial" pitchFamily="34" charset="-122"/>
                 <a:cs typeface="Arial" pitchFamily="34" charset="-120"/>
               </a:rPr>
-              <a:t>Liquidity Buffer</a:t>
+              <a:t>Rate Transmission</a:t>
             </a:r>
             <a:endParaRPr lang="en-US" sz="900" dirty="0"/>
           </a:p>
@@ -1974,14 +2052,14 @@
       </p:sp>
       <p:sp>
         <p:nvSpPr>
-          <p:cNvPr id="31" name="Text 29"/>
-          <p:cNvSpPr/>
-          <p:nvPr/>
-        </p:nvSpPr>
-        <p:spPr>
-          <a:xfrm>
-            <a:off x="2743200" y="2807208"/>
-            <a:ext cx="2194560" cy="256032"/>
+          <p:cNvPr id="33" name="Text 31"/>
+          <p:cNvSpPr/>
+          <p:nvPr/>
+        </p:nvSpPr>
+        <p:spPr>
+          <a:xfrm>
+            <a:off x="411480" y="3246120"/>
+            <a:ext cx="2011680" cy="228600"/>
           </a:xfrm>
           <a:prstGeom prst="rect">
             <a:avLst/>
@@ -2005,7 +2083,7 @@
                 <a:ea typeface="Arial" pitchFamily="34" charset="-122"/>
                 <a:cs typeface="Arial" pitchFamily="34" charset="-120"/>
               </a:rPr>
-              <a:t>LCR source without bank dependence</a:t>
+              <a:t>MIBOR-linked vs MCLR</a:t>
             </a:r>
             <a:endParaRPr lang="en-US" sz="800" dirty="0"/>
           </a:p>
@@ -2013,14 +2091,14 @@
       </p:sp>
       <p:sp>
         <p:nvSpPr>
-          <p:cNvPr id="32" name="Text 30"/>
-          <p:cNvSpPr/>
-          <p:nvPr/>
-        </p:nvSpPr>
-        <p:spPr>
-          <a:xfrm>
-            <a:off x="594360" y="3081528"/>
-            <a:ext cx="2011680" cy="128016"/>
+          <p:cNvPr id="34" name="Text 32"/>
+          <p:cNvSpPr/>
+          <p:nvPr/>
+        </p:nvSpPr>
+        <p:spPr>
+          <a:xfrm>
+            <a:off x="2560320" y="3108960"/>
+            <a:ext cx="2103120" cy="137160"/>
           </a:xfrm>
           <a:prstGeom prst="rect">
             <a:avLst/>
@@ -2044,7 +2122,7 @@
                 <a:ea typeface="Arial" pitchFamily="34" charset="-122"/>
                 <a:cs typeface="Arial" pitchFamily="34" charset="-120"/>
               </a:rPr>
-              <a:t>Rate Transmission</a:t>
+              <a:t>Roll-over Efficiency</a:t>
             </a:r>
             <a:endParaRPr lang="en-US" sz="900" dirty="0"/>
           </a:p>
@@ -2052,14 +2130,14 @@
       </p:sp>
       <p:sp>
         <p:nvSpPr>
-          <p:cNvPr id="33" name="Text 31"/>
-          <p:cNvSpPr/>
-          <p:nvPr/>
-        </p:nvSpPr>
-        <p:spPr>
-          <a:xfrm>
-            <a:off x="594360" y="3209544"/>
-            <a:ext cx="2011680" cy="201168"/>
+          <p:cNvPr id="35" name="Text 33"/>
+          <p:cNvSpPr/>
+          <p:nvPr/>
+        </p:nvSpPr>
+        <p:spPr>
+          <a:xfrm>
+            <a:off x="2560320" y="3246120"/>
+            <a:ext cx="2103120" cy="228600"/>
           </a:xfrm>
           <a:prstGeom prst="rect">
             <a:avLst/>
@@ -2083,7 +2161,7 @@
                 <a:ea typeface="Arial" pitchFamily="34" charset="-122"/>
                 <a:cs typeface="Arial" pitchFamily="34" charset="-120"/>
               </a:rPr>
-              <a:t>MIBOR-linked vs slower MCLR</a:t>
+              <a:t>Reduced risk vs CP rollover</a:t>
             </a:r>
             <a:endParaRPr lang="en-US" sz="800" dirty="0"/>
           </a:p>
@@ -2091,96 +2169,18 @@
       </p:sp>
       <p:sp>
         <p:nvSpPr>
-          <p:cNvPr id="34" name="Text 32"/>
-          <p:cNvSpPr/>
-          <p:nvPr/>
-        </p:nvSpPr>
-        <p:spPr>
-          <a:xfrm>
-            <a:off x="2743200" y="3081528"/>
-            <a:ext cx="2194560" cy="128016"/>
-          </a:xfrm>
-          <a:prstGeom prst="rect">
-            <a:avLst/>
-          </a:prstGeom>
-          <a:noFill/>
-          <a:ln/>
-        </p:spPr>
-        <p:txBody>
-          <a:bodyPr wrap="square" rtlCol="0" anchor="ctr"/>
-          <a:lstStyle/>
-          <a:p>
-            <a:pPr indent="0" marL="0">
-              <a:buNone/>
-            </a:pPr>
-            <a:r>
-              <a:rPr lang="en-US" sz="900" b="1" dirty="0">
-                <a:solidFill>
-                  <a:srgbClr val="2563EB"/>
-                </a:solidFill>
-                <a:latin typeface="Arial" pitchFamily="34" charset="0"/>
-                <a:ea typeface="Arial" pitchFamily="34" charset="-122"/>
-                <a:cs typeface="Arial" pitchFamily="34" charset="-120"/>
-              </a:rPr>
-              <a:t>Roll-over Efficiency</a:t>
-            </a:r>
-            <a:endParaRPr lang="en-US" sz="900" dirty="0"/>
-          </a:p>
-        </p:txBody>
-      </p:sp>
-      <p:sp>
-        <p:nvSpPr>
-          <p:cNvPr id="35" name="Text 33"/>
-          <p:cNvSpPr/>
-          <p:nvPr/>
-        </p:nvSpPr>
-        <p:spPr>
-          <a:xfrm>
-            <a:off x="2743200" y="3209544"/>
-            <a:ext cx="2194560" cy="201168"/>
-          </a:xfrm>
-          <a:prstGeom prst="rect">
-            <a:avLst/>
-          </a:prstGeom>
-          <a:noFill/>
-          <a:ln/>
-        </p:spPr>
-        <p:txBody>
-          <a:bodyPr wrap="square" rtlCol="0" anchor="ctr"/>
-          <a:lstStyle/>
-          <a:p>
-            <a:pPr indent="0" marL="0">
-              <a:buNone/>
-            </a:pPr>
-            <a:r>
-              <a:rPr lang="en-US" sz="800" dirty="0">
-                <a:solidFill>
-                  <a:srgbClr val="4B5563"/>
-                </a:solidFill>
-                <a:latin typeface="Arial" pitchFamily="34" charset="0"/>
-                <a:ea typeface="Arial" pitchFamily="34" charset="-122"/>
-                <a:cs typeface="Arial" pitchFamily="34" charset="-120"/>
-              </a:rPr>
-              <a:t>Reduced refinancing risk vs CP</a:t>
-            </a:r>
-            <a:endParaRPr lang="en-US" sz="800" dirty="0"/>
-          </a:p>
-        </p:txBody>
-      </p:sp>
-      <p:sp>
-        <p:nvSpPr>
           <p:cNvPr id="36" name="Shape 34"/>
           <p:cNvSpPr/>
           <p:nvPr/>
         </p:nvSpPr>
         <p:spPr>
           <a:xfrm>
-            <a:off x="5257800" y="2423160"/>
-            <a:ext cx="3657600" cy="1051560"/>
+            <a:off x="5029200" y="2423160"/>
+            <a:ext cx="3566160" cy="1143000"/>
           </a:xfrm>
           <a:prstGeom prst="roundRect">
             <a:avLst>
-              <a:gd name="adj" fmla="val 2609"/>
+              <a:gd name="adj" fmla="val 2400"/>
             </a:avLst>
           </a:prstGeom>
           <a:solidFill>
@@ -2202,8 +2202,8 @@
         </p:nvSpPr>
         <p:spPr>
           <a:xfrm>
-            <a:off x="5257800" y="2423160"/>
-            <a:ext cx="3657600" cy="182880"/>
+            <a:off x="5029200" y="2423160"/>
+            <a:ext cx="3566160" cy="201168"/>
           </a:xfrm>
           <a:prstGeom prst="rect">
             <a:avLst/>
@@ -2222,24 +2222,24 @@
         </p:nvSpPr>
         <p:spPr>
           <a:xfrm>
-            <a:off x="5349240" y="2450592"/>
-            <a:ext cx="3474720" cy="137160"/>
-          </a:xfrm>
-          <a:prstGeom prst="rect">
-            <a:avLst/>
-          </a:prstGeom>
-          <a:noFill/>
-          <a:ln/>
-        </p:spPr>
-        <p:txBody>
-          <a:bodyPr wrap="square" rtlCol="0" anchor="ctr"/>
-          <a:lstStyle/>
-          <a:p>
-            <a:pPr indent="0" marL="0">
-              <a:buNone/>
-            </a:pPr>
-            <a:r>
-              <a:rPr lang="en-US" sz="900" b="1" dirty="0">
+            <a:off x="5120640" y="2459736"/>
+            <a:ext cx="3383280" cy="137160"/>
+          </a:xfrm>
+          <a:prstGeom prst="rect">
+            <a:avLst/>
+          </a:prstGeom>
+          <a:noFill/>
+          <a:ln/>
+        </p:spPr>
+        <p:txBody>
+          <a:bodyPr wrap="square" rtlCol="0" anchor="ctr"/>
+          <a:lstStyle/>
+          <a:p>
+            <a:pPr indent="0" marL="0">
+              <a:buNone/>
+            </a:pPr>
+            <a:r>
+              <a:rPr lang="en-US" sz="1000" b="1" dirty="0">
                 <a:solidFill>
                   <a:srgbClr val="78350F"/>
                 </a:solidFill>
@@ -2249,7 +2249,7 @@
               </a:rPr>
               <a:t>Immediate Actions (30 Days)</a:t>
             </a:r>
-            <a:endParaRPr lang="en-US" sz="900" dirty="0"/>
+            <a:endParaRPr lang="en-US" sz="1000" dirty="0"/>
           </a:p>
         </p:txBody>
       </p:sp>
@@ -2261,12 +2261,12 @@
         </p:nvSpPr>
         <p:spPr>
           <a:xfrm>
-            <a:off x="5349240" y="2679192"/>
-            <a:ext cx="320040" cy="118872"/>
+            <a:off x="5120640" y="2715768"/>
+            <a:ext cx="347472" cy="137160"/>
           </a:xfrm>
           <a:prstGeom prst="roundRect">
             <a:avLst>
-              <a:gd name="adj" fmla="val 15385"/>
+              <a:gd name="adj" fmla="val 13333"/>
             </a:avLst>
           </a:prstGeom>
           <a:solidFill>
@@ -2283,8 +2283,8 @@
         </p:nvSpPr>
         <p:spPr>
           <a:xfrm>
-            <a:off x="5349240" y="2679192"/>
-            <a:ext cx="320040" cy="118872"/>
+            <a:off x="5120640" y="2715768"/>
+            <a:ext cx="347472" cy="137160"/>
           </a:xfrm>
           <a:prstGeom prst="rect">
             <a:avLst/>
@@ -2300,7 +2300,7 @@
               <a:buNone/>
             </a:pPr>
             <a:r>
-              <a:rPr lang="en-US" sz="600" b="1" dirty="0">
+              <a:rPr lang="en-US" sz="700" b="1" dirty="0">
                 <a:solidFill>
                   <a:srgbClr val="FFFFFF"/>
                 </a:solidFill>
@@ -2310,7 +2310,7 @@
               </a:rPr>
               <a:t>HIGH</a:t>
             </a:r>
-            <a:endParaRPr lang="en-US" sz="600" dirty="0"/>
+            <a:endParaRPr lang="en-US" sz="700" dirty="0"/>
           </a:p>
         </p:txBody>
       </p:sp>
@@ -2322,8 +2322,8 @@
         </p:nvSpPr>
         <p:spPr>
           <a:xfrm>
-            <a:off x="5760720" y="2679192"/>
-            <a:ext cx="3017520" cy="118872"/>
+            <a:off x="5559552" y="2715768"/>
+            <a:ext cx="2834640" cy="137160"/>
           </a:xfrm>
           <a:prstGeom prst="rect">
             <a:avLst/>
@@ -2361,12 +2361,12 @@
         </p:nvSpPr>
         <p:spPr>
           <a:xfrm>
-            <a:off x="5349240" y="2852928"/>
-            <a:ext cx="320040" cy="118872"/>
+            <a:off x="5120640" y="2907792"/>
+            <a:ext cx="347472" cy="137160"/>
           </a:xfrm>
           <a:prstGeom prst="roundRect">
             <a:avLst>
-              <a:gd name="adj" fmla="val 15385"/>
+              <a:gd name="adj" fmla="val 13333"/>
             </a:avLst>
           </a:prstGeom>
           <a:solidFill>
@@ -2383,8 +2383,8 @@
         </p:nvSpPr>
         <p:spPr>
           <a:xfrm>
-            <a:off x="5349240" y="2852928"/>
-            <a:ext cx="320040" cy="118872"/>
+            <a:off x="5120640" y="2907792"/>
+            <a:ext cx="347472" cy="137160"/>
           </a:xfrm>
           <a:prstGeom prst="rect">
             <a:avLst/>
@@ -2400,7 +2400,7 @@
               <a:buNone/>
             </a:pPr>
             <a:r>
-              <a:rPr lang="en-US" sz="600" b="1" dirty="0">
+              <a:rPr lang="en-US" sz="700" b="1" dirty="0">
                 <a:solidFill>
                   <a:srgbClr val="FFFFFF"/>
                 </a:solidFill>
@@ -2410,7 +2410,7 @@
               </a:rPr>
               <a:t>HIGH</a:t>
             </a:r>
-            <a:endParaRPr lang="en-US" sz="600" dirty="0"/>
+            <a:endParaRPr lang="en-US" sz="700" dirty="0"/>
           </a:p>
         </p:txBody>
       </p:sp>
@@ -2422,8 +2422,8 @@
         </p:nvSpPr>
         <p:spPr>
           <a:xfrm>
-            <a:off x="5760720" y="2852928"/>
-            <a:ext cx="3017520" cy="118872"/>
+            <a:off x="5559552" y="2907792"/>
+            <a:ext cx="2834640" cy="137160"/>
           </a:xfrm>
           <a:prstGeom prst="rect">
             <a:avLst/>
@@ -2461,12 +2461,12 @@
         </p:nvSpPr>
         <p:spPr>
           <a:xfrm>
-            <a:off x="5349240" y="3026664"/>
-            <a:ext cx="320040" cy="118872"/>
+            <a:off x="5120640" y="3099816"/>
+            <a:ext cx="347472" cy="137160"/>
           </a:xfrm>
           <a:prstGeom prst="roundRect">
             <a:avLst>
-              <a:gd name="adj" fmla="val 15385"/>
+              <a:gd name="adj" fmla="val 13333"/>
             </a:avLst>
           </a:prstGeom>
           <a:solidFill>
@@ -2483,8 +2483,8 @@
         </p:nvSpPr>
         <p:spPr>
           <a:xfrm>
-            <a:off x="5349240" y="3026664"/>
-            <a:ext cx="320040" cy="118872"/>
+            <a:off x="5120640" y="3099816"/>
+            <a:ext cx="347472" cy="137160"/>
           </a:xfrm>
           <a:prstGeom prst="rect">
             <a:avLst/>
@@ -2500,7 +2500,7 @@
               <a:buNone/>
             </a:pPr>
             <a:r>
-              <a:rPr lang="en-US" sz="600" b="1" dirty="0">
+              <a:rPr lang="en-US" sz="700" b="1" dirty="0">
                 <a:solidFill>
                   <a:srgbClr val="FFFFFF"/>
                 </a:solidFill>
@@ -2510,7 +2510,7 @@
               </a:rPr>
               <a:t>MED</a:t>
             </a:r>
-            <a:endParaRPr lang="en-US" sz="600" dirty="0"/>
+            <a:endParaRPr lang="en-US" sz="700" dirty="0"/>
           </a:p>
         </p:txBody>
       </p:sp>
@@ -2522,8 +2522,8 @@
         </p:nvSpPr>
         <p:spPr>
           <a:xfrm>
-            <a:off x="5760720" y="3026664"/>
-            <a:ext cx="3017520" cy="118872"/>
+            <a:off x="5559552" y="3099816"/>
+            <a:ext cx="2834640" cy="137160"/>
           </a:xfrm>
           <a:prstGeom prst="rect">
             <a:avLst/>
@@ -2561,8 +2561,8 @@
         </p:nvSpPr>
         <p:spPr>
           <a:xfrm>
-            <a:off x="0" y="4572000"/>
-            <a:ext cx="9144000" cy="228600"/>
+            <a:off x="0" y="4617720"/>
+            <a:ext cx="9144000" cy="274320"/>
           </a:xfrm>
           <a:prstGeom prst="rect">
             <a:avLst/>
@@ -2581,24 +2581,24 @@
         </p:nvSpPr>
         <p:spPr>
           <a:xfrm>
-            <a:off x="457200" y="4599432"/>
-            <a:ext cx="8229600" cy="91440"/>
-          </a:xfrm>
-          <a:prstGeom prst="rect">
-            <a:avLst/>
-          </a:prstGeom>
-          <a:noFill/>
-          <a:ln/>
-        </p:spPr>
-        <p:txBody>
-          <a:bodyPr wrap="square" rtlCol="0" anchor="ctr"/>
-          <a:lstStyle/>
-          <a:p>
-            <a:pPr indent="0" marL="0">
-              <a:buNone/>
-            </a:pPr>
-            <a:r>
-              <a:rPr lang="en-US" sz="800" dirty="0">
+            <a:off x="274320" y="4645152"/>
+            <a:ext cx="8229600" cy="109728"/>
+          </a:xfrm>
+          <a:prstGeom prst="rect">
+            <a:avLst/>
+          </a:prstGeom>
+          <a:noFill/>
+          <a:ln/>
+        </p:spPr>
+        <p:txBody>
+          <a:bodyPr wrap="square" rtlCol="0" anchor="ctr"/>
+          <a:lstStyle/>
+          <a:p>
+            <a:pPr indent="0" marL="0">
+              <a:buNone/>
+            </a:pPr>
+            <a:r>
+              <a:rPr lang="en-US" sz="900" dirty="0">
                 <a:solidFill>
                   <a:srgbClr val="E0E7FF"/>
                 </a:solidFill>
@@ -2608,46 +2608,46 @@
               </a:rPr>
               <a:t>Hero FinCorp Treasury | RBI Circular: April 9, 2026 | Internal Use Only</a:t>
             </a:r>
+            <a:endParaRPr lang="en-US" sz="900" dirty="0"/>
+          </a:p>
+        </p:txBody>
+      </p:sp>
+      <p:sp>
+        <p:nvSpPr>
+          <p:cNvPr id="50" name="Text 48"/>
+          <p:cNvSpPr/>
+          <p:nvPr/>
+        </p:nvSpPr>
+        <p:spPr>
+          <a:xfrm>
+            <a:off x="274320" y="4754880"/>
+            <a:ext cx="8229600" cy="109728"/>
+          </a:xfrm>
+          <a:prstGeom prst="rect">
+            <a:avLst/>
+          </a:prstGeom>
+          <a:noFill/>
+          <a:ln/>
+        </p:spPr>
+        <p:txBody>
+          <a:bodyPr wrap="square" rtlCol="0" anchor="ctr"/>
+          <a:lstStyle/>
+          <a:p>
+            <a:pPr indent="0" marL="0">
+              <a:buNone/>
+            </a:pPr>
+            <a:r>
+              <a:rPr lang="en-US" sz="800" i="1" dirty="0">
+                <a:solidFill>
+                  <a:srgbClr val="94A3B8"/>
+                </a:solidFill>
+                <a:latin typeface="Arial" pitchFamily="34" charset="0"/>
+                <a:ea typeface="Arial" pitchFamily="34" charset="-122"/>
+                <a:cs typeface="Arial" pitchFamily="34" charset="-120"/>
+              </a:rPr>
+              <a:t>Projections are estimates based on market conditions.</a:t>
+            </a:r>
             <a:endParaRPr lang="en-US" sz="800" dirty="0"/>
-          </a:p>
-        </p:txBody>
-      </p:sp>
-      <p:sp>
-        <p:nvSpPr>
-          <p:cNvPr id="50" name="Text 48"/>
-          <p:cNvSpPr/>
-          <p:nvPr/>
-        </p:nvSpPr>
-        <p:spPr>
-          <a:xfrm>
-            <a:off x="457200" y="4690872"/>
-            <a:ext cx="8229600" cy="91440"/>
-          </a:xfrm>
-          <a:prstGeom prst="rect">
-            <a:avLst/>
-          </a:prstGeom>
-          <a:noFill/>
-          <a:ln/>
-        </p:spPr>
-        <p:txBody>
-          <a:bodyPr wrap="square" rtlCol="0" anchor="ctr"/>
-          <a:lstStyle/>
-          <a:p>
-            <a:pPr indent="0" marL="0">
-              <a:buNone/>
-            </a:pPr>
-            <a:r>
-              <a:rPr lang="en-US" sz="700" i="1" dirty="0">
-                <a:solidFill>
-                  <a:srgbClr val="94A3B8"/>
-                </a:solidFill>
-                <a:latin typeface="Arial" pitchFamily="34" charset="0"/>
-                <a:ea typeface="Arial" pitchFamily="34" charset="-122"/>
-                <a:cs typeface="Arial" pitchFamily="34" charset="-120"/>
-              </a:rPr>
-              <a:t>Projections are estimates based on market conditions.</a:t>
-            </a:r>
-            <a:endParaRPr lang="en-US" sz="700" dirty="0"/>
           </a:p>
         </p:txBody>
       </p:sp>

</xml_diff>

<commit_message>
Fix PowerPoint v5 final - resolved title-date overlap in header
</commit_message>
<xml_diff>
--- a/RBI_Term_Money_Market_HeroFinCorp_Analysis.pptx
+++ b/RBI_Term_Money_Market_HeroFinCorp_Analysis.pptx
@@ -904,7 +904,7 @@
         <p:spPr>
           <a:xfrm>
             <a:off x="274320" y="91440"/>
-            <a:ext cx="7772400" cy="228600"/>
+            <a:ext cx="7315200" cy="228600"/>
           </a:xfrm>
           <a:prstGeom prst="rect">
             <a:avLst/>
@@ -943,7 +943,7 @@
         <p:spPr>
           <a:xfrm>
             <a:off x="7772400" y="91440"/>
-            <a:ext cx="1371600" cy="228600"/>
+            <a:ext cx="1097280" cy="228600"/>
           </a:xfrm>
           <a:prstGeom prst="rect">
             <a:avLst/>

</xml_diff>